<commit_message>
fix(recommendation): correct 019c audit findings
</commit_message>
<xml_diff>
--- a/docs/presentation/FEELM-REC-EV-019C-results.pptx
+++ b/docs/presentation/FEELM-REC-EV-019C-results.pptx
@@ -2,21 +2,21 @@
 <file path=ppt/presentation.xml><?xml version="1.0" encoding="utf-8"?>
 <p:presentation xmlns:p="http://schemas.openxmlformats.org/presentationml/2006/main">
   <p:sldMasterIdLst>
-    <p:sldMasterId xmlns:r="http://schemas.openxmlformats.org/officeDocument/2006/relationships" id="2147483648" r:id="R4d3ab95f213e4825"/>
+    <p:sldMasterId xmlns:r="http://schemas.openxmlformats.org/officeDocument/2006/relationships" id="2147483648" r:id="R1f9e215a08904e37"/>
   </p:sldMasterIdLst>
   <p:notesMasterIdLst>
-    <p:notesMasterId xmlns:r="http://schemas.openxmlformats.org/officeDocument/2006/relationships" r:id="R64c9b49a1039428d"/>
+    <p:notesMasterId xmlns:r="http://schemas.openxmlformats.org/officeDocument/2006/relationships" r:id="R5c050e0799a24c5f"/>
   </p:notesMasterIdLst>
   <p:sldIdLst>
-    <p:sldId xmlns:r="http://schemas.openxmlformats.org/officeDocument/2006/relationships" id="256" r:id="R908e5003805643d9"/>
-    <p:sldId xmlns:r="http://schemas.openxmlformats.org/officeDocument/2006/relationships" id="257" r:id="Rf37ae9798cb84789"/>
-    <p:sldId xmlns:r="http://schemas.openxmlformats.org/officeDocument/2006/relationships" id="258" r:id="R1af82e1c5aeb40b9"/>
-    <p:sldId xmlns:r="http://schemas.openxmlformats.org/officeDocument/2006/relationships" id="259" r:id="Rf05dc27b056b4e79"/>
-    <p:sldId xmlns:r="http://schemas.openxmlformats.org/officeDocument/2006/relationships" id="260" r:id="R4cafe5d0529d4c82"/>
-    <p:sldId xmlns:r="http://schemas.openxmlformats.org/officeDocument/2006/relationships" id="261" r:id="R0f236831e7cf454f"/>
-    <p:sldId xmlns:r="http://schemas.openxmlformats.org/officeDocument/2006/relationships" id="262" r:id="R2606a4365d0d44d2"/>
-    <p:sldId xmlns:r="http://schemas.openxmlformats.org/officeDocument/2006/relationships" id="263" r:id="R80ecd1cd24064d35"/>
-    <p:sldId xmlns:r="http://schemas.openxmlformats.org/officeDocument/2006/relationships" id="264" r:id="Rff1e47061119483f"/>
+    <p:sldId xmlns:r="http://schemas.openxmlformats.org/officeDocument/2006/relationships" id="256" r:id="Rb2e781c3585a4081"/>
+    <p:sldId xmlns:r="http://schemas.openxmlformats.org/officeDocument/2006/relationships" id="257" r:id="R77de881117394d8e"/>
+    <p:sldId xmlns:r="http://schemas.openxmlformats.org/officeDocument/2006/relationships" id="258" r:id="Rd56719c21e694380"/>
+    <p:sldId xmlns:r="http://schemas.openxmlformats.org/officeDocument/2006/relationships" id="259" r:id="Re808d9c672394569"/>
+    <p:sldId xmlns:r="http://schemas.openxmlformats.org/officeDocument/2006/relationships" id="260" r:id="Rbca9473d30654e3e"/>
+    <p:sldId xmlns:r="http://schemas.openxmlformats.org/officeDocument/2006/relationships" id="261" r:id="R844b01856e274de7"/>
+    <p:sldId xmlns:r="http://schemas.openxmlformats.org/officeDocument/2006/relationships" id="262" r:id="Reaf2b7f8fc3745ec"/>
+    <p:sldId xmlns:r="http://schemas.openxmlformats.org/officeDocument/2006/relationships" id="263" r:id="R9047cde3710e427c"/>
+    <p:sldId xmlns:r="http://schemas.openxmlformats.org/officeDocument/2006/relationships" id="264" r:id="R7602d7e5219d45e2"/>
   </p:sldIdLst>
   <p:sldSz cx="12192000" cy="6858000"/>
   <p:notesSz cx="6858000" cy="9144000"/>
@@ -450,7 +450,7 @@
           <a:lstStyle xmlns:a="http://schemas.openxmlformats.org/drawingml/2006/main"/>
           <a:p xmlns:a="http://schemas.openxmlformats.org/drawingml/2006/main">
             <a:r>
-              <a:t>근거: docs/recommendation/evidence/REC-EV-019C-validation-analysis.md. Locked Test와 제품 정책은 변경하지 않았다.</a:t>
+              <a:t>근거: docs/recommendation/evidence/REC-EV-019C-validation-analysis.md. 독립 감사 교정본이며 Locked Test와 제품 정책은 변경하지 않았다.</a:t>
             </a:r>
           </a:p>
         </p:txBody>
@@ -590,7 +590,7 @@
           <a:lstStyle xmlns:a="http://schemas.openxmlformats.org/drawingml/2006/main"/>
           <a:p xmlns:a="http://schemas.openxmlformats.org/drawingml/2006/main">
             <a:r>
-              <a:t>근거: REC-EV-019A 후보 41,625편, REC-EV-019B TMDB 구조·E5 feature. MovieLens 사용자는 FEELM 사용자가 아니며 timestamp는 실제 관람 시각이 아니다.</a:t>
+              <a:t>근거: REC-EV-019A 후보 41,625편, REC-EV-019B TMDB 구조·E5 feature. MovieLens 사용자는 FEELM 사용자가 아니며 K별 미래 구간이 달라 K5/K10 품질을 직접 비교하지 않는다.</a:t>
             </a:r>
           </a:p>
         </p:txBody>
@@ -660,7 +660,7 @@
           <a:lstStyle xmlns:a="http://schemas.openxmlformats.org/drawingml/2006/main"/>
           <a:p xmlns:a="http://schemas.openxmlformats.org/drawingml/2006/main">
             <a:r>
-              <a:t>출처: outputs/recommendation-evidence/rec-ev-019c/analysis-summary.json aggregate. K5 users=1,614, K10 users=1,479.</a:t>
+              <a:t>독립 재계산: tuning panel 제외 LightFM T003-B0 paired NDCG@10. K5 +0.0333138, 95% percentile bootstrap [0.02582, 0.04114], n=1,358; K10 +0.0453236, [0.03681, 0.05462], n=1,223. 2,000회, seed=20260905+K. K별 미래 구간이 달라 직접 비교하지 않는다.</a:t>
             </a:r>
           </a:p>
         </p:txBody>
@@ -730,7 +730,7 @@
           <a:lstStyle xmlns:a="http://schemas.openxmlformats.org/drawingml/2006/main"/>
           <a:p xmlns:a="http://schemas.openxmlformats.org/drawingml/2006/main">
             <a:r>
-              <a:t>출처: analysis-summary.json paired_vs_b0. 개선/동률/악화는 같은 사용자에서 LightFM과 B0 인기도의 NDCG@10 차이를 비교했다.</a:t>
+              <a:t>공통 1,253명에서 LightFM NDCG@10은 K5 0.075359, K10 0.075348로 사실상 동일했다. delta 확대는 B0가 0.038780에서 0.030512로 낮아진 영향이다. 좌측 차트는 각 K 내부 사용자별 기술 통계이며 K별 미래 구간이 달라 prefix 효과를 뜻하지 않는다.</a:t>
             </a:r>
           </a:p>
         </p:txBody>
@@ -800,7 +800,7 @@
           <a:lstStyle xmlns:a="http://schemas.openxmlformats.org/drawingml/2006/main"/>
           <a:p xmlns:a="http://schemas.openxmlformats.org/drawingml/2006/main">
             <a:r>
-              <a:t>출처: analysis-summary.json cohorts_for_validation_best_vs_b0의 prefix_signal. 이 결정은 다음 Validation/Test 후보이며 제품 정책 채택이 아니다.</a:t>
+              <a:t>LightFM fold-in은 최종 후보 매핑 뒤 positive/negative anchor가 모두 있어야 한다. raw 양쪽 신호 중 K5 97명, K10 46명은 valid anchor 부족으로 B0 fallback이 됐다. raw 한쪽 신호는 모두 설계상 fallback이다. 이 비교는 양방향 신호의 효과 검증이 아니다.</a:t>
             </a:r>
           </a:p>
         </p:txBody>
@@ -870,7 +870,7 @@
           <a:lstStyle xmlns:a="http://schemas.openxmlformats.org/drawingml/2006/main"/>
           <a:p xmlns:a="http://schemas.openxmlformats.org/drawingml/2006/main">
             <a:r>
-              <a:t>출처: analysis-summary.json item_slices. K10 관측 GOOD 수는 Q1 36, Q2 33, Q3 145, Q4 5,729, 한국어 원어 23, 비한국어 원어 5,920이다. 한국어 원어는 TMDB original_language=ko proxy다.</a:t>
+              <a:t>Q4 positive 비중은 K5 6,086/6,345=95.9%, K10 5,729/5,943=96.4%다. 한국어 원어 positive는 K5 21건, K10 23건; Top500 적중은 B0 10, LightFM 6(두 K 동일), Top10은 모두 0이다. release_year&gt;=2020 후보 9편은 positive 0, true cold 후보는 0편이다. 희소 slice에서 inferiority를 결론 내리지 않는다.</a:t>
             </a:r>
           </a:p>
         </p:txBody>
@@ -940,7 +940,7 @@
           <a:lstStyle xmlns:a="http://schemas.openxmlformats.org/drawingml/2006/main"/>
           <a:p xmlns:a="http://schemas.openxmlformats.org/drawingml/2006/main">
             <a:r>
-              <a:t>AI 활용은 구현·반복·분석 자동화에 한정했다. 문제 정의, 데이터 역할, 승격 조건, 결과 해석은 사람이 결정했다.</a:t>
+              <a:t>분석과 verifier는 paired·slice 원자료를 재계산했다. stability는 K별 256명 tuning panel에서만 계산했다. raw Parquet은 git-ignored outputs에만 있고 외부 artifact URI가 없어 commit 단독 재현은 불가능하다. locked_test_used=false, champion=null, product_policy_updated=false.</a:t>
             </a:r>
           </a:p>
         </p:txBody>
@@ -1010,7 +1010,7 @@
           <a:lstStyle xmlns:a="http://schemas.openxmlformats.org/drawingml/2006/main"/>
           <a:p xmlns:a="http://schemas.openxmlformats.org/drawingml/2006/main">
             <a:r>
-              <a:t>최종 판정: 문제 2는 출시 전 대리 환경의 초기 후보를 좁히는 수준에서 부분적으로 답했다. 문제 1은 해결 근거가 없다. 제품 정책 APPROVED_C2A_INTERNAL_POPULARITY_ONLY를 유지한다.</a:t>
+              <a:t>공개 대안은 보조 검증 후보일 뿐 즉시 대체재가 아니다: ML-32M Extension https://uwaterlooir.github.io/datasets/ml-32m-extension.html ; MovieLens Beliefs https://grouplens.org/datasets/movielens/ml_belief_2024/ ; KMRD https://github.com/lovit/kmrd ; Amazon Reviews 2023 https://amazon-reviews-2023.github.io/main.html . 목표 도메인·최신성·한국 영화 범위·제품 사용 가능한 라이선스·사용자 행동을 동시에 만족하는 즉시 사용 가능한 대안은 확인되지 않았다. locked_test_used=false, champion=null, product_policy_updated=false.</a:t>
             </a:r>
           </a:p>
         </p:txBody>
@@ -1078,7 +1078,7 @@
   </p:cSld>
   <p:clrMap bg1="lt1" tx1="dk1" bg2="lt2" tx2="dk2" accent1="accent1" accent2="accent2" accent3="accent3" accent4="accent4" accent5="accent5" accent6="accent6" hlink="hlink" folHlink="folHlink"/>
   <p:sldLayoutIdLst>
-    <p:sldLayoutId xmlns:r="http://schemas.openxmlformats.org/officeDocument/2006/relationships" id="2147483649" r:id="R6c905e291f0b431f"/>
+    <p:sldLayoutId xmlns:r="http://schemas.openxmlformats.org/officeDocument/2006/relationships" id="2147483649" r:id="R86c5e67689394589"/>
   </p:sldLayoutIdLst>
   <p:txStyles>
     <p:titleStyle>
@@ -1609,6 +1609,44 @@
 <c:chartSpace xmlns:c="http://schemas.openxmlformats.org/drawingml/2006/chart" xmlns:r="http://schemas.openxmlformats.org/officeDocument/2006/relationships">
   <c:lang val="en-US"/>
   <c:chart>
+    <c:title>
+      <c:tx>
+        <c:rich>
+          <a:bodyPr xmlns:a="http://schemas.openxmlformats.org/drawingml/2006/main"/>
+          <a:lstStyle xmlns:a="http://schemas.openxmlformats.org/drawingml/2006/main"/>
+          <a:p xmlns:a="http://schemas.openxmlformats.org/drawingml/2006/main">
+            <a:r>
+              <a:rPr sz="1200" b="1">
+                <a:solidFill>
+                  <a:srgbClr val="2E2C2A"/>
+                </a:solidFill>
+                <a:latin typeface="Noto Sans KR"/>
+                <a:ea typeface="Noto Sans KR"/>
+                <a:cs typeface="Noto Sans KR"/>
+              </a:rPr>
+              <a:t>Validation NDCG@10 · 각 K 내부 결과</a:t>
+            </a:r>
+          </a:p>
+        </c:rich>
+      </c:tx>
+      <c:overlay val="0"/>
+      <c:txPr>
+        <a:bodyPr xmlns:a="http://schemas.openxmlformats.org/drawingml/2006/main" anchorCtr="1"/>
+        <a:lstStyle xmlns:a="http://schemas.openxmlformats.org/drawingml/2006/main"/>
+        <a:p xmlns:a="http://schemas.openxmlformats.org/drawingml/2006/main">
+          <a:pPr>
+            <a:defRPr sz="1200" b="1">
+              <a:solidFill>
+                <a:srgbClr val="2E2C2A"/>
+              </a:solidFill>
+              <a:latin typeface="Noto Sans KR"/>
+              <a:ea typeface="Noto Sans KR"/>
+              <a:cs typeface="Noto Sans KR"/>
+            </a:defRPr>
+          </a:pPr>
+        </a:p>
+      </c:txPr>
+    </c:title>
     <c:plotArea>
       <c:barChart>
         <c:barDir val="col"/>
@@ -1618,68 +1656,38 @@
           <c:idx val="0"/>
           <c:order val="0"/>
           <c:tx>
-            <c:v>K=5</c:v>
+            <c:v>B0 인기도</c:v>
           </c:tx>
           <c:spPr>
             <a:solidFill xmlns:a="http://schemas.openxmlformats.org/drawingml/2006/main">
-              <a:srgbClr val="8AA2F2"/>
+              <a:srgbClr val="8A8F94"/>
             </a:solidFill>
           </c:spPr>
           <c:cat>
             <c:strRef>
-              <c:f>'Chart Data'!$A$2:$A$8</c:f>
+              <c:f>'Chart Data'!$A$2:$A$3</c:f>
               <c:strCache>
-                <c:ptCount val="7"/>
+                <c:ptCount val="2"/>
                 <c:pt idx="0">
-                  <c:v>인기도</c:v>
+                  <c:v>K=5</c:v>
                 </c:pt>
                 <c:pt idx="1">
-                  <c:v>ItemKNN</c:v>
-                </c:pt>
-                <c:pt idx="2">
-                  <c:v>관측 BPR</c:v>
-                </c:pt>
-                <c:pt idx="3">
-                  <c:v>TMDB 구조</c:v>
-                </c:pt>
-                <c:pt idx="4">
-                  <c:v>TMDB 텍스트</c:v>
-                </c:pt>
-                <c:pt idx="5">
-                  <c:v>LightFM</c:v>
-                </c:pt>
-                <c:pt idx="6">
-                  <c:v>RRF</c:v>
+                  <c:v>K=10</c:v>
                 </c:pt>
               </c:strCache>
             </c:strRef>
           </c:cat>
           <c:val>
             <c:numRef>
-              <c:f>'Chart Data'!$B$2:$B$8</c:f>
+              <c:f>'Chart Data'!$B$2:$B$3</c:f>
               <c:numCache>
-                <c:formatCode>0.000</c:formatCode>
-                <c:ptCount val="7"/>
+                <c:formatCode>0.00</c:formatCode>
+                <c:ptCount val="2"/>
                 <c:pt idx="0">
-                  <c:v>0.0402</c:v>
+                  <c:v>0.0401824605</c:v>
                 </c:pt>
                 <c:pt idx="1">
-                  <c:v>0.0055</c:v>
-                </c:pt>
-                <c:pt idx="2">
-                  <c:v>0.0587</c:v>
-                </c:pt>
-                <c:pt idx="3">
-                  <c:v>0.0307</c:v>
-                </c:pt>
-                <c:pt idx="4">
-                  <c:v>0.025</c:v>
-                </c:pt>
-                <c:pt idx="5">
-                  <c:v>0.0713</c:v>
-                </c:pt>
-                <c:pt idx="6">
-                  <c:v>0.0615</c:v>
+                  <c:v>0.0291377428</c:v>
                 </c:pt>
               </c:numCache>
             </c:numRef>
@@ -1689,68 +1697,202 @@
           <c:idx val="1"/>
           <c:order val="1"/>
           <c:tx>
-            <c:v>K=10</c:v>
+            <c:v>B4 BPR</c:v>
           </c:tx>
           <c:spPr>
             <a:solidFill xmlns:a="http://schemas.openxmlformats.org/drawingml/2006/main">
-              <a:srgbClr val="3157D5"/>
+              <a:srgbClr val="7A8A99"/>
             </a:solidFill>
           </c:spPr>
           <c:cat>
             <c:strRef>
-              <c:f>'Chart Data'!$C$2:$C$8</c:f>
+              <c:f>'Chart Data'!$C$2:$C$3</c:f>
               <c:strCache>
-                <c:ptCount val="7"/>
+                <c:ptCount val="2"/>
                 <c:pt idx="0">
-                  <c:v>인기도</c:v>
+                  <c:v>K=5</c:v>
                 </c:pt>
                 <c:pt idx="1">
-                  <c:v>ItemKNN</c:v>
-                </c:pt>
-                <c:pt idx="2">
-                  <c:v>관측 BPR</c:v>
-                </c:pt>
-                <c:pt idx="3">
-                  <c:v>TMDB 구조</c:v>
-                </c:pt>
-                <c:pt idx="4">
-                  <c:v>TMDB 텍스트</c:v>
-                </c:pt>
-                <c:pt idx="5">
-                  <c:v>LightFM</c:v>
-                </c:pt>
-                <c:pt idx="6">
-                  <c:v>RRF</c:v>
+                  <c:v>K=10</c:v>
                 </c:pt>
               </c:strCache>
             </c:strRef>
           </c:cat>
           <c:val>
             <c:numRef>
-              <c:f>'Chart Data'!$D$2:$D$8</c:f>
+              <c:f>'Chart Data'!$D$2:$D$3</c:f>
               <c:numCache>
-                <c:formatCode>0.000</c:formatCode>
-                <c:ptCount val="7"/>
+                <c:formatCode>0.00</c:formatCode>
+                <c:ptCount val="2"/>
                 <c:pt idx="0">
-                  <c:v>0.0291</c:v>
+                  <c:v>0.0586592244</c:v>
                 </c:pt>
                 <c:pt idx="1">
-                  <c:v>0.0022</c:v>
+                  <c:v>0.0583089551</c:v>
                 </c:pt>
-                <c:pt idx="2">
-                  <c:v>0.0583</c:v>
+              </c:numCache>
+            </c:numRef>
+          </c:val>
+        </c:ser>
+        <c:ser>
+          <c:idx val="2"/>
+          <c:order val="2"/>
+          <c:tx>
+            <c:v>B6 구조</c:v>
+          </c:tx>
+          <c:spPr>
+            <a:solidFill xmlns:a="http://schemas.openxmlformats.org/drawingml/2006/main">
+              <a:srgbClr val="D1A15A"/>
+            </a:solidFill>
+          </c:spPr>
+          <c:cat>
+            <c:strRef>
+              <c:f>'Chart Data'!$E$2:$E$3</c:f>
+              <c:strCache>
+                <c:ptCount val="2"/>
+                <c:pt idx="0">
+                  <c:v>K=5</c:v>
                 </c:pt>
-                <c:pt idx="3">
-                  <c:v>0.0218</c:v>
+                <c:pt idx="1">
+                  <c:v>K=10</c:v>
                 </c:pt>
-                <c:pt idx="4">
-                  <c:v>0.0131</c:v>
+              </c:strCache>
+            </c:strRef>
+          </c:cat>
+          <c:val>
+            <c:numRef>
+              <c:f>'Chart Data'!$F$2:$F$3</c:f>
+              <c:numCache>
+                <c:formatCode>0.00</c:formatCode>
+                <c:ptCount val="2"/>
+                <c:pt idx="0">
+                  <c:v>0.0307124144</c:v>
                 </c:pt>
-                <c:pt idx="5">
-                  <c:v>0.0725</c:v>
+                <c:pt idx="1">
+                  <c:v>0.0217528934</c:v>
                 </c:pt>
-                <c:pt idx="6">
-                  <c:v>0.0622</c:v>
+              </c:numCache>
+            </c:numRef>
+          </c:val>
+        </c:ser>
+        <c:ser>
+          <c:idx val="3"/>
+          <c:order val="3"/>
+          <c:tx>
+            <c:v>B7 텍스트</c:v>
+          </c:tx>
+          <c:spPr>
+            <a:solidFill xmlns:a="http://schemas.openxmlformats.org/drawingml/2006/main">
+              <a:srgbClr val="B77A52"/>
+            </a:solidFill>
+          </c:spPr>
+          <c:cat>
+            <c:strRef>
+              <c:f>'Chart Data'!$G$2:$G$3</c:f>
+              <c:strCache>
+                <c:ptCount val="2"/>
+                <c:pt idx="0">
+                  <c:v>K=5</c:v>
+                </c:pt>
+                <c:pt idx="1">
+                  <c:v>K=10</c:v>
+                </c:pt>
+              </c:strCache>
+            </c:strRef>
+          </c:cat>
+          <c:val>
+            <c:numRef>
+              <c:f>'Chart Data'!$H$2:$H$3</c:f>
+              <c:numCache>
+                <c:formatCode>0.00</c:formatCode>
+                <c:ptCount val="2"/>
+                <c:pt idx="0">
+                  <c:v>0.024974488</c:v>
+                </c:pt>
+                <c:pt idx="1">
+                  <c:v>0.0130963709</c:v>
+                </c:pt>
+              </c:numCache>
+            </c:numRef>
+          </c:val>
+        </c:ser>
+        <c:ser>
+          <c:idx val="4"/>
+          <c:order val="4"/>
+          <c:tx>
+            <c:v>B8 LightFM</c:v>
+          </c:tx>
+          <c:spPr>
+            <a:solidFill xmlns:a="http://schemas.openxmlformats.org/drawingml/2006/main">
+              <a:srgbClr val="1E6595"/>
+            </a:solidFill>
+          </c:spPr>
+          <c:cat>
+            <c:strRef>
+              <c:f>'Chart Data'!$I$2:$I$3</c:f>
+              <c:strCache>
+                <c:ptCount val="2"/>
+                <c:pt idx="0">
+                  <c:v>K=5</c:v>
+                </c:pt>
+                <c:pt idx="1">
+                  <c:v>K=10</c:v>
+                </c:pt>
+              </c:strCache>
+            </c:strRef>
+          </c:cat>
+          <c:val>
+            <c:numRef>
+              <c:f>'Chart Data'!$J$2:$J$3</c:f>
+              <c:numCache>
+                <c:formatCode>0.00</c:formatCode>
+                <c:ptCount val="2"/>
+                <c:pt idx="0">
+                  <c:v>0.0712774743</c:v>
+                </c:pt>
+                <c:pt idx="1">
+                  <c:v>0.0725451828</c:v>
+                </c:pt>
+              </c:numCache>
+            </c:numRef>
+          </c:val>
+        </c:ser>
+        <c:ser>
+          <c:idx val="5"/>
+          <c:order val="5"/>
+          <c:tx>
+            <c:v>B9 RRF</c:v>
+          </c:tx>
+          <c:spPr>
+            <a:solidFill xmlns:a="http://schemas.openxmlformats.org/drawingml/2006/main">
+              <a:srgbClr val="4C8A88"/>
+            </a:solidFill>
+          </c:spPr>
+          <c:cat>
+            <c:strRef>
+              <c:f>'Chart Data'!$K$2:$K$3</c:f>
+              <c:strCache>
+                <c:ptCount val="2"/>
+                <c:pt idx="0">
+                  <c:v>K=5</c:v>
+                </c:pt>
+                <c:pt idx="1">
+                  <c:v>K=10</c:v>
+                </c:pt>
+              </c:strCache>
+            </c:strRef>
+          </c:cat>
+          <c:val>
+            <c:numRef>
+              <c:f>'Chart Data'!$L$2:$L$3</c:f>
+              <c:numCache>
+                <c:formatCode>0.00</c:formatCode>
+                <c:ptCount val="2"/>
+                <c:pt idx="0">
+                  <c:v>0.0614992641</c:v>
+                </c:pt>
+                <c:pt idx="1">
+                  <c:v>0.0622194789</c:v>
                 </c:pt>
               </c:numCache>
             </c:numRef>
@@ -1778,7 +1920,7 @@
           <c:showBubbleSize val="0"/>
           <c:showLeaderLines val="0"/>
         </c:dLbls>
-        <c:gapWidth val="48"/>
+        <c:gapWidth val="70"/>
         <c:axId val="48650112"/>
         <c:axId val="48672768"/>
       </c:barChart>
@@ -1795,8 +1937,9 @@
         <c:spPr>
           <a:ln xmlns:a="http://schemas.openxmlformats.org/drawingml/2006/main" w="9525">
             <a:solidFill>
-              <a:srgbClr val="DDD9CF"/>
+              <a:srgbClr val="D8D1C5"/>
             </a:solidFill>
+            <a:prstDash val="solid"/>
           </a:ln>
         </c:spPr>
         <c:txPr>
@@ -1804,9 +1947,9 @@
           <a:lstStyle xmlns:a="http://schemas.openxmlformats.org/drawingml/2006/main"/>
           <a:p xmlns:a="http://schemas.openxmlformats.org/drawingml/2006/main">
             <a:pPr>
-              <a:defRPr sz="1050">
-                <a:solidFill>
-                  <a:srgbClr val="68727F"/>
+              <a:defRPr>
+                <a:solidFill>
+                  <a:srgbClr val="666666"/>
                 </a:solidFill>
                 <a:latin typeface="Noto Sans KR"/>
                 <a:ea typeface="Noto Sans KR"/>
@@ -1830,8 +1973,9 @@
           <c:spPr>
             <a:ln xmlns:a="http://schemas.openxmlformats.org/drawingml/2006/main" w="9525">
               <a:solidFill>
-                <a:srgbClr val="DDD9CF"/>
+                <a:srgbClr val="E7E1D8"/>
               </a:solidFill>
+              <a:prstDash val="solid"/>
             </a:ln>
           </c:spPr>
         </c:majorGridlines>
@@ -1851,9 +1995,9 @@
           <a:lstStyle xmlns:a="http://schemas.openxmlformats.org/drawingml/2006/main"/>
           <a:p xmlns:a="http://schemas.openxmlformats.org/drawingml/2006/main">
             <a:pPr>
-              <a:defRPr sz="1125">
-                <a:solidFill>
-                  <a:srgbClr val="68727F"/>
+              <a:defRPr>
+                <a:solidFill>
+                  <a:srgbClr val="666666"/>
                 </a:solidFill>
                 <a:latin typeface="Noto Sans KR"/>
                 <a:ea typeface="Noto Sans KR"/>
@@ -1866,6 +2010,14 @@
         <c:crossBetween val="between"/>
         <c:majorUnit val="0.02"/>
       </c:valAx>
+      <c:spPr>
+        <a:solidFill xmlns:a="http://schemas.openxmlformats.org/drawingml/2006/main">
+          <a:srgbClr val="F7F3EC"/>
+        </a:solidFill>
+        <a:ln xmlns:a="http://schemas.openxmlformats.org/drawingml/2006/main" w="0">
+          <a:noFill/>
+        </a:ln>
+      </c:spPr>
     </c:plotArea>
     <c:legend>
       <c:legendPos val="b"/>
@@ -1875,10 +2027,7 @@
         <a:lstStyle xmlns:a="http://schemas.openxmlformats.org/drawingml/2006/main"/>
         <a:p xmlns:a="http://schemas.openxmlformats.org/drawingml/2006/main">
           <a:pPr>
-            <a:defRPr sz="1275">
-              <a:solidFill>
-                <a:srgbClr val="68727F"/>
-              </a:solidFill>
+            <a:defRPr>
               <a:latin typeface="Noto Sans KR"/>
               <a:ea typeface="Noto Sans KR"/>
               <a:cs typeface="Noto Sans KR"/>
@@ -1889,6 +2038,14 @@
     </c:legend>
     <c:plotVisOnly val="1"/>
   </c:chart>
+  <c:spPr>
+    <a:solidFill xmlns:a="http://schemas.openxmlformats.org/drawingml/2006/main">
+      <a:srgbClr val="F7F3EC"/>
+    </a:solidFill>
+    <a:ln xmlns:a="http://schemas.openxmlformats.org/drawingml/2006/main" w="0">
+      <a:noFill/>
+    </a:ln>
+  </c:spPr>
   <c:externalData r:id="rIdChartSnapshot1">
     <c:autoUpdate val="0"/>
   </c:externalData>
@@ -1899,9 +2056,47 @@
 <c:chartSpace xmlns:c="http://schemas.openxmlformats.org/drawingml/2006/chart" xmlns:r="http://schemas.openxmlformats.org/officeDocument/2006/relationships">
   <c:lang val="en-US"/>
   <c:chart>
+    <c:title>
+      <c:tx>
+        <c:rich>
+          <a:bodyPr xmlns:a="http://schemas.openxmlformats.org/drawingml/2006/main"/>
+          <a:lstStyle xmlns:a="http://schemas.openxmlformats.org/drawingml/2006/main"/>
+          <a:p xmlns:a="http://schemas.openxmlformats.org/drawingml/2006/main">
+            <a:r>
+              <a:rPr sz="1200" b="1">
+                <a:solidFill>
+                  <a:srgbClr val="2E2C2A"/>
+                </a:solidFill>
+                <a:latin typeface="Noto Sans KR"/>
+                <a:ea typeface="Noto Sans KR"/>
+                <a:cs typeface="Noto Sans KR"/>
+              </a:rPr>
+              <a:t>각 K 내부 사용자별 변화율</a:t>
+            </a:r>
+          </a:p>
+        </c:rich>
+      </c:tx>
+      <c:overlay val="0"/>
+      <c:txPr>
+        <a:bodyPr xmlns:a="http://schemas.openxmlformats.org/drawingml/2006/main" anchorCtr="1"/>
+        <a:lstStyle xmlns:a="http://schemas.openxmlformats.org/drawingml/2006/main"/>
+        <a:p xmlns:a="http://schemas.openxmlformats.org/drawingml/2006/main">
+          <a:pPr>
+            <a:defRPr sz="1200" b="1">
+              <a:solidFill>
+                <a:srgbClr val="2E2C2A"/>
+              </a:solidFill>
+              <a:latin typeface="Noto Sans KR"/>
+              <a:ea typeface="Noto Sans KR"/>
+              <a:cs typeface="Noto Sans KR"/>
+            </a:defRPr>
+          </a:pPr>
+        </a:p>
+      </c:txPr>
+    </c:title>
     <c:plotArea>
       <c:barChart>
-        <c:barDir val="bar"/>
+        <c:barDir val="col"/>
         <c:grouping val="percentStacked"/>
         <c:varyColors val="0"/>
         <c:ser>
@@ -1912,7 +2107,7 @@
           </c:tx>
           <c:spPr>
             <a:solidFill xmlns:a="http://schemas.openxmlformats.org/drawingml/2006/main">
-              <a:srgbClr val="3157D5"/>
+              <a:srgbClr val="1E6595"/>
             </a:solidFill>
           </c:spPr>
           <c:cat>
@@ -1936,10 +2131,10 @@
                 <c:formatCode>0%</c:formatCode>
                 <c:ptCount val="2"/>
                 <c:pt idx="0">
-                  <c:v>0.1549</c:v>
+                  <c:v>0.1548946716</c:v>
                 </c:pt>
                 <c:pt idx="1">
-                  <c:v>0.2177</c:v>
+                  <c:v>0.2177146721</c:v>
                 </c:pt>
               </c:numCache>
             </c:numRef>
@@ -1953,7 +2148,7 @@
           </c:tx>
           <c:spPr>
             <a:solidFill xmlns:a="http://schemas.openxmlformats.org/drawingml/2006/main">
-              <a:srgbClr val="C7CCD4"/>
+              <a:srgbClr val="C8C0B4"/>
             </a:solidFill>
           </c:spPr>
           <c:cat>
@@ -1977,10 +2172,10 @@
                 <c:formatCode>0%</c:formatCode>
                 <c:ptCount val="2"/>
                 <c:pt idx="0">
-                  <c:v>0.7912</c:v>
+                  <c:v>0.7912019827</c:v>
                 </c:pt>
                 <c:pt idx="1">
-                  <c:v>0.7201</c:v>
+                  <c:v>0.7200811359</c:v>
                 </c:pt>
               </c:numCache>
             </c:numRef>
@@ -1994,7 +2189,7 @@
           </c:tx>
           <c:spPr>
             <a:solidFill xmlns:a="http://schemas.openxmlformats.org/drawingml/2006/main">
-              <a:srgbClr val="D34E5B"/>
+              <a:srgbClr val="B45443"/>
             </a:solidFill>
           </c:spPr>
           <c:cat>
@@ -2018,285 +2213,10 @@
                 <c:formatCode>0%</c:formatCode>
                 <c:ptCount val="2"/>
                 <c:pt idx="0">
-                  <c:v>0.0539</c:v>
+                  <c:v>0.0539033457</c:v>
                 </c:pt>
                 <c:pt idx="1">
-                  <c:v>0.0622</c:v>
-                </c:pt>
-              </c:numCache>
-            </c:numRef>
-          </c:val>
-        </c:ser>
-        <c:dLbls>
-          <c:txPr>
-            <a:bodyPr xmlns:a="http://schemas.openxmlformats.org/drawingml/2006/main" anchorCtr="1"/>
-            <a:lstStyle xmlns:a="http://schemas.openxmlformats.org/drawingml/2006/main"/>
-            <a:p xmlns:a="http://schemas.openxmlformats.org/drawingml/2006/main">
-              <a:pPr>
-                <a:defRPr>
-                  <a:latin typeface="Noto Sans KR"/>
-                  <a:ea typeface="Noto Sans KR"/>
-                  <a:cs typeface="Noto Sans KR"/>
-                </a:defRPr>
-              </a:pPr>
-            </a:p>
-          </c:txPr>
-          <c:dLblPos val="ctr"/>
-          <c:showLegendKey val="0"/>
-          <c:showVal val="0"/>
-          <c:showCatName val="0"/>
-          <c:showSerName val="0"/>
-          <c:showPercent val="0"/>
-          <c:showBubbleSize val="0"/>
-          <c:showLeaderLines val="0"/>
-        </c:dLbls>
-        <c:gapWidth val="65"/>
-        <c:overlap val="100"/>
-        <c:axId val="48650112"/>
-        <c:axId val="48672768"/>
-      </c:barChart>
-      <c:catAx>
-        <c:axId val="48650112"/>
-        <c:scaling>
-          <c:orientation val="minMax"/>
-        </c:scaling>
-        <c:delete val="0"/>
-        <c:axPos val="l"/>
-        <c:majorGridlines>
-          <c:spPr>
-            <a:ln xmlns:a="http://schemas.openxmlformats.org/drawingml/2006/main" w="9525">
-              <a:solidFill>
-                <a:srgbClr val="DDD9CF"/>
-              </a:solidFill>
-            </a:ln>
-          </c:spPr>
-        </c:majorGridlines>
-        <c:numFmt formatCode="0%"/>
-        <c:majorTickMark val="none"/>
-        <c:minorTickMark val="none"/>
-        <c:spPr>
-          <a:ln xmlns:a="http://schemas.openxmlformats.org/drawingml/2006/main" w="9525">
-            <a:solidFill>
-              <a:srgbClr val="D4D4D4"/>
-            </a:solidFill>
-            <a:prstDash val="solid"/>
-          </a:ln>
-        </c:spPr>
-        <c:txPr>
-          <a:bodyPr xmlns:a="http://schemas.openxmlformats.org/drawingml/2006/main" anchorCtr="1"/>
-          <a:lstStyle xmlns:a="http://schemas.openxmlformats.org/drawingml/2006/main"/>
-          <a:p xmlns:a="http://schemas.openxmlformats.org/drawingml/2006/main">
-            <a:pPr>
-              <a:defRPr sz="1125">
-                <a:solidFill>
-                  <a:srgbClr val="68727F"/>
-                </a:solidFill>
-                <a:latin typeface="Noto Sans KR"/>
-                <a:ea typeface="Noto Sans KR"/>
-                <a:cs typeface="Noto Sans KR"/>
-              </a:defRPr>
-            </a:pPr>
-          </a:p>
-        </c:txPr>
-        <c:crossAx val="48672768"/>
-      </c:catAx>
-      <c:valAx>
-        <c:axId val="48672768"/>
-        <c:scaling>
-          <c:orientation val="minMax"/>
-        </c:scaling>
-        <c:delete val="0"/>
-        <c:axPos val="b"/>
-        <c:numFmt formatCode="General"/>
-        <c:majorTickMark val="none"/>
-        <c:minorTickMark val="none"/>
-        <c:spPr>
-          <a:ln xmlns:a="http://schemas.openxmlformats.org/drawingml/2006/main" w="0">
-            <a:noFill/>
-          </a:ln>
-        </c:spPr>
-        <c:txPr>
-          <a:bodyPr xmlns:a="http://schemas.openxmlformats.org/drawingml/2006/main" anchorCtr="1"/>
-          <a:lstStyle xmlns:a="http://schemas.openxmlformats.org/drawingml/2006/main"/>
-          <a:p xmlns:a="http://schemas.openxmlformats.org/drawingml/2006/main">
-            <a:pPr>
-              <a:defRPr sz="1500" b="1">
-                <a:solidFill>
-                  <a:srgbClr val="18202A"/>
-                </a:solidFill>
-                <a:latin typeface="Noto Sans KR"/>
-                <a:ea typeface="Noto Sans KR"/>
-                <a:cs typeface="Noto Sans KR"/>
-              </a:defRPr>
-            </a:pPr>
-          </a:p>
-        </c:txPr>
-        <c:crossAx val="48650112"/>
-        <c:crossBetween val="between"/>
-      </c:valAx>
-    </c:plotArea>
-    <c:legend>
-      <c:legendPos val="b"/>
-      <c:overlay val="0"/>
-      <c:txPr>
-        <a:bodyPr xmlns:a="http://schemas.openxmlformats.org/drawingml/2006/main" anchorCtr="1"/>
-        <a:lstStyle xmlns:a="http://schemas.openxmlformats.org/drawingml/2006/main"/>
-        <a:p xmlns:a="http://schemas.openxmlformats.org/drawingml/2006/main">
-          <a:pPr>
-            <a:defRPr sz="1350">
-              <a:solidFill>
-                <a:srgbClr val="68727F"/>
-              </a:solidFill>
-              <a:latin typeface="Noto Sans KR"/>
-              <a:ea typeface="Noto Sans KR"/>
-              <a:cs typeface="Noto Sans KR"/>
-            </a:defRPr>
-          </a:pPr>
-        </a:p>
-      </c:txPr>
-    </c:legend>
-    <c:plotVisOnly val="1"/>
-  </c:chart>
-  <c:externalData r:id="rIdChartSnapshot1">
-    <c:autoUpdate val="0"/>
-  </c:externalData>
-</c:chartSpace>
-</file>
-
-<file path=ppt/slides/charts/chart3.xml><?xml version="1.0" encoding="utf-8"?>
-<c:chartSpace xmlns:c="http://schemas.openxmlformats.org/drawingml/2006/chart" xmlns:r="http://schemas.openxmlformats.org/officeDocument/2006/relationships">
-  <c:lang val="en-US"/>
-  <c:chart>
-    <c:plotArea>
-      <c:barChart>
-        <c:barDir val="col"/>
-        <c:grouping val="clustered"/>
-        <c:varyColors val="0"/>
-        <c:ser>
-          <c:idx val="0"/>
-          <c:order val="0"/>
-          <c:tx>
-            <c:v>B0 인기도</c:v>
-          </c:tx>
-          <c:spPr>
-            <a:solidFill xmlns:a="http://schemas.openxmlformats.org/drawingml/2006/main">
-              <a:srgbClr val="C7CCD4"/>
-            </a:solidFill>
-          </c:spPr>
-          <c:cat>
-            <c:strRef>
-              <c:f>'Chart Data'!$A$2:$A$7</c:f>
-              <c:strCache>
-                <c:ptCount val="6"/>
-                <c:pt idx="0">
-                  <c:v>인기도 Q1</c:v>
-                </c:pt>
-                <c:pt idx="1">
-                  <c:v>인기도 Q2</c:v>
-                </c:pt>
-                <c:pt idx="2">
-                  <c:v>인기도 Q3</c:v>
-                </c:pt>
-                <c:pt idx="3">
-                  <c:v>인기도 Q4</c:v>
-                </c:pt>
-                <c:pt idx="4">
-                  <c:v>한국어 원어</c:v>
-                </c:pt>
-                <c:pt idx="5">
-                  <c:v>비한국어 원어</c:v>
-                </c:pt>
-              </c:strCache>
-            </c:strRef>
-          </c:cat>
-          <c:val>
-            <c:numRef>
-              <c:f>'Chart Data'!$B$2:$B$7</c:f>
-              <c:numCache>
-                <c:formatCode>0.0%</c:formatCode>
-                <c:ptCount val="6"/>
-                <c:pt idx="0">
-                  <c:v>0</c:v>
-                </c:pt>
-                <c:pt idx="1">
-                  <c:v>0</c:v>
-                </c:pt>
-                <c:pt idx="2">
-                  <c:v>0</c:v>
-                </c:pt>
-                <c:pt idx="3">
-                  <c:v>0.0375</c:v>
-                </c:pt>
-                <c:pt idx="4">
-                  <c:v>0</c:v>
-                </c:pt>
-                <c:pt idx="5">
-                  <c:v>0.0363</c:v>
-                </c:pt>
-              </c:numCache>
-            </c:numRef>
-          </c:val>
-        </c:ser>
-        <c:ser>
-          <c:idx val="1"/>
-          <c:order val="1"/>
-          <c:tx>
-            <c:v>B8 LightFM</c:v>
-          </c:tx>
-          <c:spPr>
-            <a:solidFill xmlns:a="http://schemas.openxmlformats.org/drawingml/2006/main">
-              <a:srgbClr val="3157D5"/>
-            </a:solidFill>
-          </c:spPr>
-          <c:cat>
-            <c:strRef>
-              <c:f>'Chart Data'!$C$2:$C$7</c:f>
-              <c:strCache>
-                <c:ptCount val="6"/>
-                <c:pt idx="0">
-                  <c:v>인기도 Q1</c:v>
-                </c:pt>
-                <c:pt idx="1">
-                  <c:v>인기도 Q2</c:v>
-                </c:pt>
-                <c:pt idx="2">
-                  <c:v>인기도 Q3</c:v>
-                </c:pt>
-                <c:pt idx="3">
-                  <c:v>인기도 Q4</c:v>
-                </c:pt>
-                <c:pt idx="4">
-                  <c:v>한국어 원어</c:v>
-                </c:pt>
-                <c:pt idx="5">
-                  <c:v>비한국어 원어</c:v>
-                </c:pt>
-              </c:strCache>
-            </c:strRef>
-          </c:cat>
-          <c:val>
-            <c:numRef>
-              <c:f>'Chart Data'!$D$2:$D$7</c:f>
-              <c:numCache>
-                <c:formatCode>0.0%</c:formatCode>
-                <c:ptCount val="6"/>
-                <c:pt idx="0">
-                  <c:v>0</c:v>
-                </c:pt>
-                <c:pt idx="1">
-                  <c:v>0</c:v>
-                </c:pt>
-                <c:pt idx="2">
-                  <c:v>0</c:v>
-                </c:pt>
-                <c:pt idx="3">
-                  <c:v>0.0946</c:v>
-                </c:pt>
-                <c:pt idx="4">
-                  <c:v>0</c:v>
-                </c:pt>
-                <c:pt idx="5">
-                  <c:v>0.0916</c:v>
+                  <c:v>0.062204192</c:v>
                 </c:pt>
               </c:numCache>
             </c:numRef>
@@ -2324,7 +2244,8 @@
           <c:showBubbleSize val="0"/>
           <c:showLeaderLines val="0"/>
         </c:dLbls>
-        <c:gapWidth val="52"/>
+        <c:gapWidth val="72"/>
+        <c:overlap val="100"/>
         <c:axId val="48650112"/>
         <c:axId val="48672768"/>
       </c:barChart>
@@ -2341,8 +2262,9 @@
         <c:spPr>
           <a:ln xmlns:a="http://schemas.openxmlformats.org/drawingml/2006/main" w="9525">
             <a:solidFill>
-              <a:srgbClr val="DDD9CF"/>
+              <a:srgbClr val="D8D1C5"/>
             </a:solidFill>
+            <a:prstDash val="solid"/>
           </a:ln>
         </c:spPr>
         <c:txPr>
@@ -2350,9 +2272,328 @@
           <a:lstStyle xmlns:a="http://schemas.openxmlformats.org/drawingml/2006/main"/>
           <a:p xmlns:a="http://schemas.openxmlformats.org/drawingml/2006/main">
             <a:pPr>
-              <a:defRPr sz="1125">
-                <a:solidFill>
-                  <a:srgbClr val="68727F"/>
+              <a:defRPr>
+                <a:solidFill>
+                  <a:srgbClr val="666666"/>
+                </a:solidFill>
+                <a:latin typeface="Noto Sans KR"/>
+                <a:ea typeface="Noto Sans KR"/>
+                <a:cs typeface="Noto Sans KR"/>
+              </a:defRPr>
+            </a:pPr>
+          </a:p>
+        </c:txPr>
+        <c:crossAx val="48672768"/>
+      </c:catAx>
+      <c:valAx>
+        <c:axId val="48672768"/>
+        <c:scaling>
+          <c:orientation val="minMax"/>
+          <c:max val="1"/>
+          <c:min val="0"/>
+        </c:scaling>
+        <c:delete val="0"/>
+        <c:axPos val="l"/>
+        <c:majorGridlines>
+          <c:spPr>
+            <a:ln xmlns:a="http://schemas.openxmlformats.org/drawingml/2006/main" w="9525">
+              <a:solidFill>
+                <a:srgbClr val="E7E1D8"/>
+              </a:solidFill>
+              <a:prstDash val="solid"/>
+            </a:ln>
+          </c:spPr>
+        </c:majorGridlines>
+        <c:numFmt formatCode="0%"/>
+        <c:majorTickMark val="none"/>
+        <c:minorTickMark val="none"/>
+        <c:spPr>
+          <a:ln xmlns:a="http://schemas.openxmlformats.org/drawingml/2006/main" w="9525">
+            <a:solidFill>
+              <a:srgbClr val="D4D4D4"/>
+            </a:solidFill>
+            <a:prstDash val="solid"/>
+          </a:ln>
+        </c:spPr>
+        <c:txPr>
+          <a:bodyPr xmlns:a="http://schemas.openxmlformats.org/drawingml/2006/main" anchorCtr="1"/>
+          <a:lstStyle xmlns:a="http://schemas.openxmlformats.org/drawingml/2006/main"/>
+          <a:p xmlns:a="http://schemas.openxmlformats.org/drawingml/2006/main">
+            <a:pPr>
+              <a:defRPr>
+                <a:solidFill>
+                  <a:srgbClr val="666666"/>
+                </a:solidFill>
+                <a:latin typeface="Noto Sans KR"/>
+                <a:ea typeface="Noto Sans KR"/>
+                <a:cs typeface="Noto Sans KR"/>
+              </a:defRPr>
+            </a:pPr>
+          </a:p>
+        </c:txPr>
+        <c:crossAx val="48650112"/>
+        <c:crossBetween val="between"/>
+        <c:majorUnit val="0.25"/>
+      </c:valAx>
+      <c:spPr>
+        <a:solidFill xmlns:a="http://schemas.openxmlformats.org/drawingml/2006/main">
+          <a:srgbClr val="F7F3EC"/>
+        </a:solidFill>
+        <a:ln xmlns:a="http://schemas.openxmlformats.org/drawingml/2006/main" w="0">
+          <a:noFill/>
+        </a:ln>
+      </c:spPr>
+    </c:plotArea>
+    <c:legend>
+      <c:legendPos val="b"/>
+      <c:overlay val="0"/>
+      <c:txPr>
+        <a:bodyPr xmlns:a="http://schemas.openxmlformats.org/drawingml/2006/main" anchorCtr="1"/>
+        <a:lstStyle xmlns:a="http://schemas.openxmlformats.org/drawingml/2006/main"/>
+        <a:p xmlns:a="http://schemas.openxmlformats.org/drawingml/2006/main">
+          <a:pPr>
+            <a:defRPr>
+              <a:latin typeface="Noto Sans KR"/>
+              <a:ea typeface="Noto Sans KR"/>
+              <a:cs typeface="Noto Sans KR"/>
+            </a:defRPr>
+          </a:pPr>
+        </a:p>
+      </c:txPr>
+    </c:legend>
+    <c:plotVisOnly val="1"/>
+  </c:chart>
+  <c:spPr>
+    <a:solidFill xmlns:a="http://schemas.openxmlformats.org/drawingml/2006/main">
+      <a:srgbClr val="F7F3EC"/>
+    </a:solidFill>
+    <a:ln xmlns:a="http://schemas.openxmlformats.org/drawingml/2006/main" w="0">
+      <a:noFill/>
+    </a:ln>
+  </c:spPr>
+  <c:externalData r:id="rIdChartSnapshot1">
+    <c:autoUpdate val="0"/>
+  </c:externalData>
+</c:chartSpace>
+</file>
+
+<file path=ppt/slides/charts/chart3.xml><?xml version="1.0" encoding="utf-8"?>
+<c:chartSpace xmlns:c="http://schemas.openxmlformats.org/drawingml/2006/chart" xmlns:r="http://schemas.openxmlformats.org/officeDocument/2006/relationships">
+  <c:lang val="en-US"/>
+  <c:chart>
+    <c:title>
+      <c:tx>
+        <c:rich>
+          <a:bodyPr xmlns:a="http://schemas.openxmlformats.org/drawingml/2006/main"/>
+          <a:lstStyle xmlns:a="http://schemas.openxmlformats.org/drawingml/2006/main"/>
+          <a:p xmlns:a="http://schemas.openxmlformats.org/drawingml/2006/main">
+            <a:r>
+              <a:rPr sz="1200" b="1">
+                <a:solidFill>
+                  <a:srgbClr val="2E2C2A"/>
+                </a:solidFill>
+                <a:latin typeface="Noto Sans KR"/>
+                <a:ea typeface="Noto Sans KR"/>
+                <a:cs typeface="Noto Sans KR"/>
+              </a:rPr>
+              <a:t>K=10 관측 GOOD Top-10 적중률</a:t>
+            </a:r>
+          </a:p>
+        </c:rich>
+      </c:tx>
+      <c:overlay val="0"/>
+      <c:txPr>
+        <a:bodyPr xmlns:a="http://schemas.openxmlformats.org/drawingml/2006/main" anchorCtr="1"/>
+        <a:lstStyle xmlns:a="http://schemas.openxmlformats.org/drawingml/2006/main"/>
+        <a:p xmlns:a="http://schemas.openxmlformats.org/drawingml/2006/main">
+          <a:pPr>
+            <a:defRPr sz="1200" b="1">
+              <a:solidFill>
+                <a:srgbClr val="2E2C2A"/>
+              </a:solidFill>
+              <a:latin typeface="Noto Sans KR"/>
+              <a:ea typeface="Noto Sans KR"/>
+              <a:cs typeface="Noto Sans KR"/>
+            </a:defRPr>
+          </a:pPr>
+        </a:p>
+      </c:txPr>
+    </c:title>
+    <c:plotArea>
+      <c:barChart>
+        <c:barDir val="col"/>
+        <c:grouping val="clustered"/>
+        <c:varyColors val="0"/>
+        <c:ser>
+          <c:idx val="0"/>
+          <c:order val="0"/>
+          <c:tx>
+            <c:v>B0 인기도</c:v>
+          </c:tx>
+          <c:spPr>
+            <a:solidFill xmlns:a="http://schemas.openxmlformats.org/drawingml/2006/main">
+              <a:srgbClr val="8A8F94"/>
+            </a:solidFill>
+          </c:spPr>
+          <c:cat>
+            <c:strRef>
+              <c:f>'Chart Data'!$A$2:$A$6</c:f>
+              <c:strCache>
+                <c:ptCount val="5"/>
+                <c:pt idx="0">
+                  <c:v>Q1</c:v>
+                </c:pt>
+                <c:pt idx="1">
+                  <c:v>Q2</c:v>
+                </c:pt>
+                <c:pt idx="2">
+                  <c:v>Q3</c:v>
+                </c:pt>
+                <c:pt idx="3">
+                  <c:v>Q4</c:v>
+                </c:pt>
+                <c:pt idx="4">
+                  <c:v>한국어 원어</c:v>
+                </c:pt>
+              </c:strCache>
+            </c:strRef>
+          </c:cat>
+          <c:val>
+            <c:numRef>
+              <c:f>'Chart Data'!$B$2:$B$6</c:f>
+              <c:numCache>
+                <c:formatCode>0%</c:formatCode>
+                <c:ptCount val="5"/>
+                <c:pt idx="0">
+                  <c:v>0</c:v>
+                </c:pt>
+                <c:pt idx="1">
+                  <c:v>0</c:v>
+                </c:pt>
+                <c:pt idx="2">
+                  <c:v>0</c:v>
+                </c:pt>
+                <c:pt idx="3">
+                  <c:v>0.0375283645</c:v>
+                </c:pt>
+                <c:pt idx="4">
+                  <c:v>0</c:v>
+                </c:pt>
+              </c:numCache>
+            </c:numRef>
+          </c:val>
+        </c:ser>
+        <c:ser>
+          <c:idx val="1"/>
+          <c:order val="1"/>
+          <c:tx>
+            <c:v>B8 LightFM</c:v>
+          </c:tx>
+          <c:spPr>
+            <a:solidFill xmlns:a="http://schemas.openxmlformats.org/drawingml/2006/main">
+              <a:srgbClr val="1E6595"/>
+            </a:solidFill>
+          </c:spPr>
+          <c:cat>
+            <c:strRef>
+              <c:f>'Chart Data'!$C$2:$C$6</c:f>
+              <c:strCache>
+                <c:ptCount val="5"/>
+                <c:pt idx="0">
+                  <c:v>Q1</c:v>
+                </c:pt>
+                <c:pt idx="1">
+                  <c:v>Q2</c:v>
+                </c:pt>
+                <c:pt idx="2">
+                  <c:v>Q3</c:v>
+                </c:pt>
+                <c:pt idx="3">
+                  <c:v>Q4</c:v>
+                </c:pt>
+                <c:pt idx="4">
+                  <c:v>한국어 원어</c:v>
+                </c:pt>
+              </c:strCache>
+            </c:strRef>
+          </c:cat>
+          <c:val>
+            <c:numRef>
+              <c:f>'Chart Data'!$D$2:$D$6</c:f>
+              <c:numCache>
+                <c:formatCode>0%</c:formatCode>
+                <c:ptCount val="5"/>
+                <c:pt idx="0">
+                  <c:v>0</c:v>
+                </c:pt>
+                <c:pt idx="1">
+                  <c:v>0</c:v>
+                </c:pt>
+                <c:pt idx="2">
+                  <c:v>0</c:v>
+                </c:pt>
+                <c:pt idx="3">
+                  <c:v>0.0946063885</c:v>
+                </c:pt>
+                <c:pt idx="4">
+                  <c:v>0</c:v>
+                </c:pt>
+              </c:numCache>
+            </c:numRef>
+          </c:val>
+        </c:ser>
+        <c:dLbls>
+          <c:txPr>
+            <a:bodyPr xmlns:a="http://schemas.openxmlformats.org/drawingml/2006/main" anchorCtr="1"/>
+            <a:lstStyle xmlns:a="http://schemas.openxmlformats.org/drawingml/2006/main"/>
+            <a:p xmlns:a="http://schemas.openxmlformats.org/drawingml/2006/main">
+              <a:pPr>
+                <a:defRPr>
+                  <a:latin typeface="Noto Sans KR"/>
+                  <a:ea typeface="Noto Sans KR"/>
+                  <a:cs typeface="Noto Sans KR"/>
+                </a:defRPr>
+              </a:pPr>
+            </a:p>
+          </c:txPr>
+          <c:showLegendKey val="0"/>
+          <c:showVal val="0"/>
+          <c:showCatName val="0"/>
+          <c:showSerName val="0"/>
+          <c:showPercent val="0"/>
+          <c:showBubbleSize val="0"/>
+          <c:showLeaderLines val="0"/>
+        </c:dLbls>
+        <c:gapWidth val="66"/>
+        <c:axId val="48650112"/>
+        <c:axId val="48672768"/>
+      </c:barChart>
+      <c:catAx>
+        <c:axId val="48650112"/>
+        <c:scaling>
+          <c:orientation val="minMax"/>
+        </c:scaling>
+        <c:delete val="0"/>
+        <c:axPos val="b"/>
+        <c:numFmt formatCode="General"/>
+        <c:majorTickMark val="none"/>
+        <c:minorTickMark val="none"/>
+        <c:spPr>
+          <a:ln xmlns:a="http://schemas.openxmlformats.org/drawingml/2006/main" w="9525">
+            <a:solidFill>
+              <a:srgbClr val="D8D1C5"/>
+            </a:solidFill>
+            <a:prstDash val="solid"/>
+          </a:ln>
+        </c:spPr>
+        <c:txPr>
+          <a:bodyPr xmlns:a="http://schemas.openxmlformats.org/drawingml/2006/main" anchorCtr="1"/>
+          <a:lstStyle xmlns:a="http://schemas.openxmlformats.org/drawingml/2006/main"/>
+          <a:p xmlns:a="http://schemas.openxmlformats.org/drawingml/2006/main">
+            <a:pPr>
+              <a:defRPr>
+                <a:solidFill>
+                  <a:srgbClr val="666666"/>
                 </a:solidFill>
                 <a:latin typeface="Noto Sans KR"/>
                 <a:ea typeface="Noto Sans KR"/>
@@ -2376,8 +2617,9 @@
           <c:spPr>
             <a:ln xmlns:a="http://schemas.openxmlformats.org/drawingml/2006/main" w="9525">
               <a:solidFill>
-                <a:srgbClr val="DDD9CF"/>
+                <a:srgbClr val="E7E1D8"/>
               </a:solidFill>
+              <a:prstDash val="solid"/>
             </a:ln>
           </c:spPr>
         </c:majorGridlines>
@@ -2397,9 +2639,9 @@
           <a:lstStyle xmlns:a="http://schemas.openxmlformats.org/drawingml/2006/main"/>
           <a:p xmlns:a="http://schemas.openxmlformats.org/drawingml/2006/main">
             <a:pPr>
-              <a:defRPr sz="1125">
-                <a:solidFill>
-                  <a:srgbClr val="68727F"/>
+              <a:defRPr>
+                <a:solidFill>
+                  <a:srgbClr val="666666"/>
                 </a:solidFill>
                 <a:latin typeface="Noto Sans KR"/>
                 <a:ea typeface="Noto Sans KR"/>
@@ -2410,8 +2652,16 @@
         </c:txPr>
         <c:crossAx val="48650112"/>
         <c:crossBetween val="between"/>
-        <c:majorUnit val="0.02"/>
+        <c:majorUnit val="0.025"/>
       </c:valAx>
+      <c:spPr>
+        <a:solidFill xmlns:a="http://schemas.openxmlformats.org/drawingml/2006/main">
+          <a:srgbClr val="F7F3EC"/>
+        </a:solidFill>
+        <a:ln xmlns:a="http://schemas.openxmlformats.org/drawingml/2006/main" w="0">
+          <a:noFill/>
+        </a:ln>
+      </c:spPr>
     </c:plotArea>
     <c:legend>
       <c:legendPos val="b"/>
@@ -2421,10 +2671,7 @@
         <a:lstStyle xmlns:a="http://schemas.openxmlformats.org/drawingml/2006/main"/>
         <a:p xmlns:a="http://schemas.openxmlformats.org/drawingml/2006/main">
           <a:pPr>
-            <a:defRPr sz="1275">
-              <a:solidFill>
-                <a:srgbClr val="68727F"/>
-              </a:solidFill>
+            <a:defRPr>
               <a:latin typeface="Noto Sans KR"/>
               <a:ea typeface="Noto Sans KR"/>
               <a:cs typeface="Noto Sans KR"/>
@@ -2435,6 +2682,14 @@
     </c:legend>
     <c:plotVisOnly val="1"/>
   </c:chart>
+  <c:spPr>
+    <a:solidFill xmlns:a="http://schemas.openxmlformats.org/drawingml/2006/main">
+      <a:srgbClr val="F7F3EC"/>
+    </a:solidFill>
+    <a:ln xmlns:a="http://schemas.openxmlformats.org/drawingml/2006/main" w="0">
+      <a:noFill/>
+    </a:ln>
+  </c:spPr>
   <c:externalData r:id="rIdChartSnapshot1">
     <c:autoUpdate val="0"/>
   </c:externalData>
@@ -2494,6 +2749,7 @@
           <a:lstStyle xmlns:a="http://schemas.openxmlformats.org/drawingml/2006/main"/>
           <a:p xmlns:a="http://schemas.openxmlformats.org/drawingml/2006/main">
             <a:pPr>
+              <a:buNone/>
               <a:defRPr sz="5100" b="1">
                 <a:solidFill>
                   <a:srgbClr val="18202A"/>
@@ -2517,6 +2773,7 @@
           </a:p>
           <a:p xmlns:a="http://schemas.openxmlformats.org/drawingml/2006/main">
             <a:pPr>
+              <a:buNone/>
               <a:defRPr sz="5100" b="1">
                 <a:solidFill>
                   <a:srgbClr val="18202A"/>
@@ -2574,6 +2831,7 @@
           <a:lstStyle xmlns:a="http://schemas.openxmlformats.org/drawingml/2006/main"/>
           <a:p xmlns:a="http://schemas.openxmlformats.org/drawingml/2006/main">
             <a:pPr>
+              <a:buNone/>
               <a:defRPr sz="2025" b="1">
                 <a:solidFill>
                   <a:srgbClr val="3157D5"/>
@@ -2631,6 +2889,7 @@
           <a:lstStyle xmlns:a="http://schemas.openxmlformats.org/drawingml/2006/main"/>
           <a:p xmlns:a="http://schemas.openxmlformats.org/drawingml/2006/main">
             <a:pPr>
+              <a:buNone/>
               <a:defRPr sz="1800" b="0">
                 <a:solidFill>
                   <a:srgbClr val="68727F"/>
@@ -2649,7 +2908,7 @@
                 <a:ea typeface="Noto Sans KR"/>
                 <a:cs typeface="Noto Sans KR"/>
               </a:rPr>
-              <a:t>한국 영화·신작의 데이터 공백과 실사용 피드백 부재를 분리해 검증</a:t>
+              <a:t>독립 감사 교정: paired·anchor·item slice·재현 한계</a:t>
             </a:r>
           </a:p>
         </p:txBody>
@@ -2688,6 +2947,7 @@
           <a:lstStyle xmlns:a="http://schemas.openxmlformats.org/drawingml/2006/main"/>
           <a:p xmlns:a="http://schemas.openxmlformats.org/drawingml/2006/main">
             <a:pPr>
+              <a:buNone/>
               <a:defRPr sz="1350" b="0">
                 <a:solidFill>
                   <a:srgbClr val="68727F"/>
@@ -2706,7 +2966,7 @@
                 <a:ea typeface="Noto Sans KR"/>
                 <a:cs typeface="Noto Sans KR"/>
               </a:rPr>
-              <a:t>Validation only  ·  2026.09.05</a:t>
+              <a:t>Validation only · independent audit correction · 2026.09.05</a:t>
             </a:r>
           </a:p>
         </p:txBody>
@@ -2774,6 +3034,7 @@
           <a:lstStyle xmlns:a="http://schemas.openxmlformats.org/drawingml/2006/main"/>
           <a:p xmlns:a="http://schemas.openxmlformats.org/drawingml/2006/main">
             <a:pPr>
+              <a:buNone/>
               <a:defRPr sz="3225" b="1">
                 <a:solidFill>
                   <a:srgbClr val="18202A"/>
@@ -2831,6 +3092,7 @@
           <a:lstStyle xmlns:a="http://schemas.openxmlformats.org/drawingml/2006/main"/>
           <a:p xmlns:a="http://schemas.openxmlformats.org/drawingml/2006/main">
             <a:pPr>
+              <a:buNone/>
               <a:defRPr sz="1275" b="1">
                 <a:solidFill>
                   <a:srgbClr val="68727F"/>
@@ -2888,6 +3150,7 @@
           <a:lstStyle xmlns:a="http://schemas.openxmlformats.org/drawingml/2006/main"/>
           <a:p xmlns:a="http://schemas.openxmlformats.org/drawingml/2006/main">
             <a:pPr>
+              <a:buNone/>
               <a:defRPr sz="4800" b="1">
                 <a:solidFill>
                   <a:srgbClr val="3157D5"/>
@@ -2945,6 +3208,7 @@
           <a:lstStyle xmlns:a="http://schemas.openxmlformats.org/drawingml/2006/main"/>
           <a:p xmlns:a="http://schemas.openxmlformats.org/drawingml/2006/main">
             <a:pPr>
+              <a:buNone/>
               <a:defRPr sz="2475" b="1">
                 <a:solidFill>
                   <a:srgbClr val="18202A"/>
@@ -3002,6 +3266,7 @@
           <a:lstStyle xmlns:a="http://schemas.openxmlformats.org/drawingml/2006/main"/>
           <a:p xmlns:a="http://schemas.openxmlformats.org/drawingml/2006/main">
             <a:pPr>
+              <a:buNone/>
               <a:defRPr sz="1875" b="0">
                 <a:solidFill>
                   <a:srgbClr val="68727F"/>
@@ -3025,6 +3290,7 @@
           </a:p>
           <a:p xmlns:a="http://schemas.openxmlformats.org/drawingml/2006/main">
             <a:pPr>
+              <a:buNone/>
               <a:defRPr sz="1875" b="0">
                 <a:solidFill>
                   <a:srgbClr val="68727F"/>
@@ -3082,6 +3348,7 @@
           <a:lstStyle xmlns:a="http://schemas.openxmlformats.org/drawingml/2006/main"/>
           <a:p xmlns:a="http://schemas.openxmlformats.org/drawingml/2006/main">
             <a:pPr>
+              <a:buNone/>
               <a:defRPr sz="4800" b="1">
                 <a:solidFill>
                   <a:srgbClr val="3157D5"/>
@@ -3139,6 +3406,7 @@
           <a:lstStyle xmlns:a="http://schemas.openxmlformats.org/drawingml/2006/main"/>
           <a:p xmlns:a="http://schemas.openxmlformats.org/drawingml/2006/main">
             <a:pPr>
+              <a:buNone/>
               <a:defRPr sz="2475" b="1">
                 <a:solidFill>
                   <a:srgbClr val="18202A"/>
@@ -3196,6 +3464,7 @@
           <a:lstStyle xmlns:a="http://schemas.openxmlformats.org/drawingml/2006/main"/>
           <a:p xmlns:a="http://schemas.openxmlformats.org/drawingml/2006/main">
             <a:pPr>
+              <a:buNone/>
               <a:defRPr sz="1875" b="0">
                 <a:solidFill>
                   <a:srgbClr val="68727F"/>
@@ -3219,6 +3488,7 @@
           </a:p>
           <a:p xmlns:a="http://schemas.openxmlformats.org/drawingml/2006/main">
             <a:pPr>
+              <a:buNone/>
               <a:defRPr sz="1875" b="0">
                 <a:solidFill>
                   <a:srgbClr val="68727F"/>
@@ -3276,6 +3546,7 @@
           <a:lstStyle xmlns:a="http://schemas.openxmlformats.org/drawingml/2006/main"/>
           <a:p xmlns:a="http://schemas.openxmlformats.org/drawingml/2006/main">
             <a:pPr>
+              <a:buNone/>
               <a:defRPr sz="1725" b="1">
                 <a:solidFill>
                   <a:srgbClr val="D34E5B"/>
@@ -3362,6 +3633,7 @@
           <a:lstStyle xmlns:a="http://schemas.openxmlformats.org/drawingml/2006/main"/>
           <a:p xmlns:a="http://schemas.openxmlformats.org/drawingml/2006/main">
             <a:pPr>
+              <a:buNone/>
               <a:defRPr sz="3225" b="1">
                 <a:solidFill>
                   <a:srgbClr val="18202A"/>
@@ -3419,6 +3691,7 @@
           <a:lstStyle xmlns:a="http://schemas.openxmlformats.org/drawingml/2006/main"/>
           <a:p xmlns:a="http://schemas.openxmlformats.org/drawingml/2006/main">
             <a:pPr>
+              <a:buNone/>
               <a:defRPr sz="1275" b="1">
                 <a:solidFill>
                   <a:srgbClr val="68727F"/>
@@ -3476,6 +3749,7 @@
           <a:lstStyle xmlns:a="http://schemas.openxmlformats.org/drawingml/2006/main"/>
           <a:p xmlns:a="http://schemas.openxmlformats.org/drawingml/2006/main">
             <a:pPr>
+              <a:buNone/>
               <a:defRPr sz="3000" b="1">
                 <a:solidFill>
                   <a:srgbClr val="3157D5"/>
@@ -3533,6 +3807,7 @@
           <a:lstStyle xmlns:a="http://schemas.openxmlformats.org/drawingml/2006/main"/>
           <a:p xmlns:a="http://schemas.openxmlformats.org/drawingml/2006/main">
             <a:pPr>
+              <a:buNone/>
               <a:defRPr sz="1875" b="1">
                 <a:solidFill>
                   <a:srgbClr val="18202A"/>
@@ -3590,6 +3865,7 @@
           <a:lstStyle xmlns:a="http://schemas.openxmlformats.org/drawingml/2006/main"/>
           <a:p xmlns:a="http://schemas.openxmlformats.org/drawingml/2006/main">
             <a:pPr>
+              <a:buNone/>
               <a:defRPr sz="2025" b="0">
                 <a:solidFill>
                   <a:srgbClr val="68727F"/>
@@ -3613,6 +3889,7 @@
           </a:p>
           <a:p xmlns:a="http://schemas.openxmlformats.org/drawingml/2006/main">
             <a:pPr>
+              <a:buNone/>
               <a:defRPr sz="2025" b="0">
                 <a:solidFill>
                   <a:srgbClr val="68727F"/>
@@ -3636,6 +3913,7 @@
           </a:p>
           <a:p xmlns:a="http://schemas.openxmlformats.org/drawingml/2006/main">
             <a:pPr>
+              <a:buNone/>
               <a:defRPr sz="2025" b="0">
                 <a:solidFill>
                   <a:srgbClr val="68727F"/>
@@ -3693,6 +3971,7 @@
           <a:lstStyle xmlns:a="http://schemas.openxmlformats.org/drawingml/2006/main"/>
           <a:p xmlns:a="http://schemas.openxmlformats.org/drawingml/2006/main">
             <a:pPr>
+              <a:buNone/>
               <a:defRPr sz="3000" b="1">
                 <a:solidFill>
                   <a:srgbClr val="3157D5"/>
@@ -3750,6 +4029,7 @@
           <a:lstStyle xmlns:a="http://schemas.openxmlformats.org/drawingml/2006/main"/>
           <a:p xmlns:a="http://schemas.openxmlformats.org/drawingml/2006/main">
             <a:pPr>
+              <a:buNone/>
               <a:defRPr sz="1875" b="1">
                 <a:solidFill>
                   <a:srgbClr val="18202A"/>
@@ -3807,6 +4087,7 @@
           <a:lstStyle xmlns:a="http://schemas.openxmlformats.org/drawingml/2006/main"/>
           <a:p xmlns:a="http://schemas.openxmlformats.org/drawingml/2006/main">
             <a:pPr>
+              <a:buNone/>
               <a:defRPr sz="2025" b="0">
                 <a:solidFill>
                   <a:srgbClr val="68727F"/>
@@ -3830,6 +4111,7 @@
           </a:p>
           <a:p xmlns:a="http://schemas.openxmlformats.org/drawingml/2006/main">
             <a:pPr>
+              <a:buNone/>
               <a:defRPr sz="2025" b="0">
                 <a:solidFill>
                   <a:srgbClr val="68727F"/>
@@ -3853,6 +4135,7 @@
           </a:p>
           <a:p xmlns:a="http://schemas.openxmlformats.org/drawingml/2006/main">
             <a:pPr>
+              <a:buNone/>
               <a:defRPr sz="2025" b="0">
                 <a:solidFill>
                   <a:srgbClr val="68727F"/>
@@ -3910,6 +4193,7 @@
           <a:lstStyle xmlns:a="http://schemas.openxmlformats.org/drawingml/2006/main"/>
           <a:p xmlns:a="http://schemas.openxmlformats.org/drawingml/2006/main">
             <a:pPr>
+              <a:buNone/>
               <a:defRPr sz="1800" b="1">
                 <a:solidFill>
                   <a:srgbClr val="3157D5"/>
@@ -3967,6 +4251,7 @@
           <a:lstStyle xmlns:a="http://schemas.openxmlformats.org/drawingml/2006/main"/>
           <a:p xmlns:a="http://schemas.openxmlformats.org/drawingml/2006/main">
             <a:pPr>
+              <a:buNone/>
               <a:defRPr sz="1875" b="1">
                 <a:solidFill>
                   <a:srgbClr val="18202A"/>
@@ -4024,6 +4309,7 @@
           <a:lstStyle xmlns:a="http://schemas.openxmlformats.org/drawingml/2006/main"/>
           <a:p xmlns:a="http://schemas.openxmlformats.org/drawingml/2006/main">
             <a:pPr>
+              <a:buNone/>
               <a:defRPr sz="1875" b="1">
                 <a:solidFill>
                   <a:srgbClr val="18202A"/>
@@ -4081,6 +4367,7 @@
           <a:lstStyle xmlns:a="http://schemas.openxmlformats.org/drawingml/2006/main"/>
           <a:p xmlns:a="http://schemas.openxmlformats.org/drawingml/2006/main">
             <a:pPr>
+              <a:buNone/>
               <a:defRPr sz="1875" b="1">
                 <a:solidFill>
                   <a:srgbClr val="18202A"/>
@@ -4138,6 +4425,7 @@
           <a:lstStyle xmlns:a="http://schemas.openxmlformats.org/drawingml/2006/main"/>
           <a:p xmlns:a="http://schemas.openxmlformats.org/drawingml/2006/main">
             <a:pPr>
+              <a:buNone/>
               <a:defRPr sz="1875" b="1">
                 <a:solidFill>
                   <a:srgbClr val="18202A"/>
@@ -4195,6 +4483,7 @@
           <a:lstStyle xmlns:a="http://schemas.openxmlformats.org/drawingml/2006/main"/>
           <a:p xmlns:a="http://schemas.openxmlformats.org/drawingml/2006/main">
             <a:pPr>
+              <a:buNone/>
               <a:defRPr sz="1350" b="0">
                 <a:solidFill>
                   <a:srgbClr val="68727F"/>
@@ -4213,7 +4502,7 @@
                 <a:ea typeface="Noto Sans KR"/>
                 <a:cs typeface="Noto Sans KR"/>
               </a:rPr>
-              <a:t>후보 41,625편 · Validation only · Locked Test 미개봉</a:t>
+              <a:t>후보 41,625편 · K 직접 비교 금지 · Locked Test 미개봉</a:t>
             </a:r>
           </a:p>
         </p:txBody>
@@ -4281,6 +4570,7 @@
           <a:lstStyle xmlns:a="http://schemas.openxmlformats.org/drawingml/2006/main"/>
           <a:p xmlns:a="http://schemas.openxmlformats.org/drawingml/2006/main">
             <a:pPr>
+              <a:buNone/>
               <a:defRPr sz="3225" b="1">
                 <a:solidFill>
                   <a:srgbClr val="18202A"/>
@@ -4299,7 +4589,7 @@
                 <a:ea typeface="Noto Sans KR"/>
                 <a:cs typeface="Noto Sans KR"/>
               </a:rPr>
-              <a:t>LightFM이 K5·10 평균 NDCG에서 1위였다</a:t>
+              <a:t>LightFM T003은 각 K에서 B0보다 높았다</a:t>
             </a:r>
           </a:p>
         </p:txBody>
@@ -4338,6 +4628,7 @@
           <a:lstStyle xmlns:a="http://schemas.openxmlformats.org/drawingml/2006/main"/>
           <a:p xmlns:a="http://schemas.openxmlformats.org/drawingml/2006/main">
             <a:pPr>
+              <a:buNone/>
               <a:defRPr sz="1275" b="1">
                 <a:solidFill>
                   <a:srgbClr val="68727F"/>
@@ -4357,13 +4648,385 @@
                 <a:cs typeface="Noto Sans KR"/>
               </a:rPr>
               <a:t>04</a:t>
+            </a:r>
+          </a:p>
+        </p:txBody>
+      </p:sp>
+      <p:sp>
+        <p:nvSpPr>
+          <p:cNvPr id="4" name="">
+            <a:extLst xmlns:a="http://schemas.openxmlformats.org/drawingml/2006/main">
+              <a:ext uri="{FF2B5EF4-FFF2-40B4-BE49-F238E27FC236}">
+                <a16:creationId xmlns:a16="http://schemas.microsoft.com/office/drawing/2014/main" id="{8FD4084F-EAE3-4B55-8B91-647BD19DCF23}"/>
+              </a:ext>
+            </a:extLst>
+          </p:cNvPr>
+          <p:cNvSpPr>
+            <a:spLocks xmlns:a="http://schemas.openxmlformats.org/drawingml/2006/main" noGrp="1"/>
+          </p:cNvSpPr>
+          <p:nvPr/>
+        </p:nvSpPr>
+        <p:spPr>
+          <a:xfrm xmlns:a="http://schemas.openxmlformats.org/drawingml/2006/main">
+            <a:off x="9429750" y="1790700"/>
+            <a:ext cx="2190750" cy="590550"/>
+          </a:xfrm>
+          <a:prstGeom xmlns:a="http://schemas.openxmlformats.org/drawingml/2006/main" prst="rect">
+            <a:avLst/>
+          </a:prstGeom>
+          <a:noFill xmlns:a="http://schemas.openxmlformats.org/drawingml/2006/main"/>
+          <a:ln xmlns:a="http://schemas.openxmlformats.org/drawingml/2006/main" w="0">
+            <a:noFill/>
+          </a:ln>
+        </p:spPr>
+        <p:txBody>
+          <a:bodyPr xmlns:a="http://schemas.openxmlformats.org/drawingml/2006/main">
+            <a:noAutofit/>
+          </a:bodyPr>
+          <a:lstStyle xmlns:a="http://schemas.openxmlformats.org/drawingml/2006/main"/>
+          <a:p xmlns:a="http://schemas.openxmlformats.org/drawingml/2006/main">
+            <a:pPr>
+              <a:buNone/>
+              <a:defRPr sz="3375" b="1">
+                <a:solidFill>
+                  <a:srgbClr val="3157D5"/>
+                </a:solidFill>
+                <a:latin typeface="Noto Sans KR"/>
+                <a:ea typeface="Noto Sans KR"/>
+                <a:cs typeface="Noto Sans KR"/>
+              </a:defRPr>
+            </a:pPr>
+            <a:r>
+              <a:rPr sz="3375" b="1">
+                <a:solidFill>
+                  <a:srgbClr val="3157D5"/>
+                </a:solidFill>
+                <a:latin typeface="Noto Sans KR"/>
+                <a:ea typeface="Noto Sans KR"/>
+                <a:cs typeface="Noto Sans KR"/>
+              </a:rPr>
+              <a:t>+0.03331</a:t>
+            </a:r>
+          </a:p>
+        </p:txBody>
+      </p:sp>
+      <p:sp>
+        <p:nvSpPr>
+          <p:cNvPr id="5" name="">
+            <a:extLst xmlns:a="http://schemas.openxmlformats.org/drawingml/2006/main">
+              <a:ext uri="{FF2B5EF4-FFF2-40B4-BE49-F238E27FC236}">
+                <a16:creationId xmlns:a16="http://schemas.microsoft.com/office/drawing/2014/main" id="{A8687CAE-FFF9-45ED-85A9-B00625C61E6C}"/>
+              </a:ext>
+            </a:extLst>
+          </p:cNvPr>
+          <p:cNvSpPr>
+            <a:spLocks xmlns:a="http://schemas.openxmlformats.org/drawingml/2006/main" noGrp="1"/>
+          </p:cNvSpPr>
+          <p:nvPr/>
+        </p:nvSpPr>
+        <p:spPr>
+          <a:xfrm xmlns:a="http://schemas.openxmlformats.org/drawingml/2006/main">
+            <a:off x="9467850" y="2400300"/>
+            <a:ext cx="2190750" cy="304800"/>
+          </a:xfrm>
+          <a:prstGeom xmlns:a="http://schemas.openxmlformats.org/drawingml/2006/main" prst="rect">
+            <a:avLst/>
+          </a:prstGeom>
+          <a:noFill xmlns:a="http://schemas.openxmlformats.org/drawingml/2006/main"/>
+          <a:ln xmlns:a="http://schemas.openxmlformats.org/drawingml/2006/main" w="0">
+            <a:noFill/>
+          </a:ln>
+        </p:spPr>
+        <p:txBody>
+          <a:bodyPr xmlns:a="http://schemas.openxmlformats.org/drawingml/2006/main">
+            <a:noAutofit/>
+          </a:bodyPr>
+          <a:lstStyle xmlns:a="http://schemas.openxmlformats.org/drawingml/2006/main"/>
+          <a:p xmlns:a="http://schemas.openxmlformats.org/drawingml/2006/main">
+            <a:pPr>
+              <a:buNone/>
+              <a:defRPr sz="1500" b="0">
+                <a:solidFill>
+                  <a:srgbClr val="68727F"/>
+                </a:solidFill>
+                <a:latin typeface="Noto Sans KR"/>
+                <a:ea typeface="Noto Sans KR"/>
+                <a:cs typeface="Noto Sans KR"/>
+              </a:defRPr>
+            </a:pPr>
+            <a:r>
+              <a:rPr sz="1500" b="0">
+                <a:solidFill>
+                  <a:srgbClr val="68727F"/>
+                </a:solidFill>
+                <a:latin typeface="Noto Sans KR"/>
+                <a:ea typeface="Noto Sans KR"/>
+                <a:cs typeface="Noto Sans KR"/>
+              </a:rPr>
+              <a:t>K5 · n=1,358</a:t>
+            </a:r>
+          </a:p>
+        </p:txBody>
+      </p:sp>
+      <p:sp>
+        <p:nvSpPr>
+          <p:cNvPr id="6" name="">
+            <a:extLst xmlns:a="http://schemas.openxmlformats.org/drawingml/2006/main">
+              <a:ext uri="{FF2B5EF4-FFF2-40B4-BE49-F238E27FC236}">
+                <a16:creationId xmlns:a16="http://schemas.microsoft.com/office/drawing/2014/main" id="{249D3293-4F77-4214-AD3F-3CBAC966FE5B}"/>
+              </a:ext>
+            </a:extLst>
+          </p:cNvPr>
+          <p:cNvSpPr>
+            <a:spLocks xmlns:a="http://schemas.openxmlformats.org/drawingml/2006/main" noGrp="1"/>
+          </p:cNvSpPr>
+          <p:nvPr/>
+        </p:nvSpPr>
+        <p:spPr>
+          <a:xfrm xmlns:a="http://schemas.openxmlformats.org/drawingml/2006/main">
+            <a:off x="9429750" y="3238500"/>
+            <a:ext cx="2190750" cy="590550"/>
+          </a:xfrm>
+          <a:prstGeom xmlns:a="http://schemas.openxmlformats.org/drawingml/2006/main" prst="rect">
+            <a:avLst/>
+          </a:prstGeom>
+          <a:noFill xmlns:a="http://schemas.openxmlformats.org/drawingml/2006/main"/>
+          <a:ln xmlns:a="http://schemas.openxmlformats.org/drawingml/2006/main" w="0">
+            <a:noFill/>
+          </a:ln>
+        </p:spPr>
+        <p:txBody>
+          <a:bodyPr xmlns:a="http://schemas.openxmlformats.org/drawingml/2006/main">
+            <a:noAutofit/>
+          </a:bodyPr>
+          <a:lstStyle xmlns:a="http://schemas.openxmlformats.org/drawingml/2006/main"/>
+          <a:p xmlns:a="http://schemas.openxmlformats.org/drawingml/2006/main">
+            <a:pPr>
+              <a:buNone/>
+              <a:defRPr sz="3375" b="1">
+                <a:solidFill>
+                  <a:srgbClr val="3157D5"/>
+                </a:solidFill>
+                <a:latin typeface="Noto Sans KR"/>
+                <a:ea typeface="Noto Sans KR"/>
+                <a:cs typeface="Noto Sans KR"/>
+              </a:defRPr>
+            </a:pPr>
+            <a:r>
+              <a:rPr sz="3375" b="1">
+                <a:solidFill>
+                  <a:srgbClr val="3157D5"/>
+                </a:solidFill>
+                <a:latin typeface="Noto Sans KR"/>
+                <a:ea typeface="Noto Sans KR"/>
+                <a:cs typeface="Noto Sans KR"/>
+              </a:rPr>
+              <a:t>+0.04532</a:t>
+            </a:r>
+          </a:p>
+        </p:txBody>
+      </p:sp>
+      <p:sp>
+        <p:nvSpPr>
+          <p:cNvPr id="7" name="">
+            <a:extLst xmlns:a="http://schemas.openxmlformats.org/drawingml/2006/main">
+              <a:ext uri="{FF2B5EF4-FFF2-40B4-BE49-F238E27FC236}">
+                <a16:creationId xmlns:a16="http://schemas.microsoft.com/office/drawing/2014/main" id="{371D8103-3CB4-4F56-A418-FC5A79214736}"/>
+              </a:ext>
+            </a:extLst>
+          </p:cNvPr>
+          <p:cNvSpPr>
+            <a:spLocks xmlns:a="http://schemas.openxmlformats.org/drawingml/2006/main" noGrp="1"/>
+          </p:cNvSpPr>
+          <p:nvPr/>
+        </p:nvSpPr>
+        <p:spPr>
+          <a:xfrm xmlns:a="http://schemas.openxmlformats.org/drawingml/2006/main">
+            <a:off x="9467850" y="3848100"/>
+            <a:ext cx="2190750" cy="304800"/>
+          </a:xfrm>
+          <a:prstGeom xmlns:a="http://schemas.openxmlformats.org/drawingml/2006/main" prst="rect">
+            <a:avLst/>
+          </a:prstGeom>
+          <a:noFill xmlns:a="http://schemas.openxmlformats.org/drawingml/2006/main"/>
+          <a:ln xmlns:a="http://schemas.openxmlformats.org/drawingml/2006/main" w="0">
+            <a:noFill/>
+          </a:ln>
+        </p:spPr>
+        <p:txBody>
+          <a:bodyPr xmlns:a="http://schemas.openxmlformats.org/drawingml/2006/main">
+            <a:noAutofit/>
+          </a:bodyPr>
+          <a:lstStyle xmlns:a="http://schemas.openxmlformats.org/drawingml/2006/main"/>
+          <a:p xmlns:a="http://schemas.openxmlformats.org/drawingml/2006/main">
+            <a:pPr>
+              <a:buNone/>
+              <a:defRPr sz="1500" b="0">
+                <a:solidFill>
+                  <a:srgbClr val="68727F"/>
+                </a:solidFill>
+                <a:latin typeface="Noto Sans KR"/>
+                <a:ea typeface="Noto Sans KR"/>
+                <a:cs typeface="Noto Sans KR"/>
+              </a:defRPr>
+            </a:pPr>
+            <a:r>
+              <a:rPr sz="1500" b="0">
+                <a:solidFill>
+                  <a:srgbClr val="68727F"/>
+                </a:solidFill>
+                <a:latin typeface="Noto Sans KR"/>
+                <a:ea typeface="Noto Sans KR"/>
+                <a:cs typeface="Noto Sans KR"/>
+              </a:rPr>
+              <a:t>K10 · n=1,223</a:t>
+            </a:r>
+          </a:p>
+        </p:txBody>
+      </p:sp>
+      <p:sp>
+        <p:nvSpPr>
+          <p:cNvPr id="8" name="">
+            <a:extLst xmlns:a="http://schemas.openxmlformats.org/drawingml/2006/main">
+              <a:ext uri="{FF2B5EF4-FFF2-40B4-BE49-F238E27FC236}">
+                <a16:creationId xmlns:a16="http://schemas.microsoft.com/office/drawing/2014/main" id="{CE3E4B44-CCCD-4EC9-BF7F-67CCB15D4B5F}"/>
+              </a:ext>
+            </a:extLst>
+          </p:cNvPr>
+          <p:cNvSpPr>
+            <a:spLocks xmlns:a="http://schemas.openxmlformats.org/drawingml/2006/main" noGrp="1"/>
+          </p:cNvSpPr>
+          <p:nvPr/>
+        </p:nvSpPr>
+        <p:spPr>
+          <a:xfrm xmlns:a="http://schemas.openxmlformats.org/drawingml/2006/main">
+            <a:off x="9429750" y="4762500"/>
+            <a:ext cx="2190750" cy="819150"/>
+          </a:xfrm>
+          <a:prstGeom xmlns:a="http://schemas.openxmlformats.org/drawingml/2006/main" prst="rect">
+            <a:avLst/>
+          </a:prstGeom>
+          <a:noFill xmlns:a="http://schemas.openxmlformats.org/drawingml/2006/main"/>
+          <a:ln xmlns:a="http://schemas.openxmlformats.org/drawingml/2006/main" w="0">
+            <a:noFill/>
+          </a:ln>
+        </p:spPr>
+        <p:txBody>
+          <a:bodyPr xmlns:a="http://schemas.openxmlformats.org/drawingml/2006/main">
+            <a:noAutofit/>
+          </a:bodyPr>
+          <a:lstStyle xmlns:a="http://schemas.openxmlformats.org/drawingml/2006/main"/>
+          <a:p xmlns:a="http://schemas.openxmlformats.org/drawingml/2006/main">
+            <a:pPr>
+              <a:buNone/>
+              <a:defRPr sz="1725" b="1">
+                <a:solidFill>
+                  <a:srgbClr val="D34E5B"/>
+                </a:solidFill>
+                <a:latin typeface="Noto Sans KR"/>
+                <a:ea typeface="Noto Sans KR"/>
+                <a:cs typeface="Noto Sans KR"/>
+              </a:defRPr>
+            </a:pPr>
+            <a:r>
+              <a:rPr sz="1725" b="1">
+                <a:solidFill>
+                  <a:srgbClr val="D34E5B"/>
+                </a:solidFill>
+                <a:latin typeface="Noto Sans KR"/>
+                <a:ea typeface="Noto Sans KR"/>
+                <a:cs typeface="Noto Sans KR"/>
+              </a:rPr>
+              <a:t>tuning panel 제외</a:t>
+            </a:r>
+          </a:p>
+          <a:p xmlns:a="http://schemas.openxmlformats.org/drawingml/2006/main">
+            <a:pPr>
+              <a:buNone/>
+              <a:defRPr sz="1725" b="1">
+                <a:solidFill>
+                  <a:srgbClr val="D34E5B"/>
+                </a:solidFill>
+                <a:latin typeface="Noto Sans KR"/>
+                <a:ea typeface="Noto Sans KR"/>
+                <a:cs typeface="Noto Sans KR"/>
+              </a:defRPr>
+            </a:pPr>
+            <a:r>
+              <a:rPr sz="1725" b="1">
+                <a:solidFill>
+                  <a:srgbClr val="D34E5B"/>
+                </a:solidFill>
+                <a:latin typeface="Noto Sans KR"/>
+                <a:ea typeface="Noto Sans KR"/>
+                <a:cs typeface="Noto Sans KR"/>
+              </a:rPr>
+              <a:t>95% CI도 0보다 큼</a:t>
+            </a:r>
+          </a:p>
+        </p:txBody>
+      </p:sp>
+      <p:sp>
+        <p:nvSpPr>
+          <p:cNvPr id="9" name="">
+            <a:extLst xmlns:a="http://schemas.openxmlformats.org/drawingml/2006/main">
+              <a:ext uri="{FF2B5EF4-FFF2-40B4-BE49-F238E27FC236}">
+                <a16:creationId xmlns:a16="http://schemas.microsoft.com/office/drawing/2014/main" id="{BC85B7AB-C12A-4945-A2E5-65A694173BD6}"/>
+              </a:ext>
+            </a:extLst>
+          </p:cNvPr>
+          <p:cNvSpPr>
+            <a:spLocks xmlns:a="http://schemas.openxmlformats.org/drawingml/2006/main" noGrp="1"/>
+          </p:cNvSpPr>
+          <p:nvPr/>
+        </p:nvSpPr>
+        <p:spPr>
+          <a:xfrm xmlns:a="http://schemas.openxmlformats.org/drawingml/2006/main">
+            <a:off x="552450" y="6153150"/>
+            <a:ext cx="4000500" cy="247650"/>
+          </a:xfrm>
+          <a:prstGeom xmlns:a="http://schemas.openxmlformats.org/drawingml/2006/main" prst="rect">
+            <a:avLst/>
+          </a:prstGeom>
+          <a:noFill xmlns:a="http://schemas.openxmlformats.org/drawingml/2006/main"/>
+          <a:ln xmlns:a="http://schemas.openxmlformats.org/drawingml/2006/main" w="0">
+            <a:noFill/>
+          </a:ln>
+        </p:spPr>
+        <p:txBody>
+          <a:bodyPr xmlns:a="http://schemas.openxmlformats.org/drawingml/2006/main">
+            <a:noAutofit/>
+          </a:bodyPr>
+          <a:lstStyle xmlns:a="http://schemas.openxmlformats.org/drawingml/2006/main"/>
+          <a:p xmlns:a="http://schemas.openxmlformats.org/drawingml/2006/main">
+            <a:pPr>
+              <a:buNone/>
+              <a:defRPr sz="1275" b="0">
+                <a:solidFill>
+                  <a:srgbClr val="68727F"/>
+                </a:solidFill>
+                <a:latin typeface="Noto Sans KR"/>
+                <a:ea typeface="Noto Sans KR"/>
+                <a:cs typeface="Noto Sans KR"/>
+              </a:defRPr>
+            </a:pPr>
+            <a:r>
+              <a:rPr sz="1275" b="0">
+                <a:solidFill>
+                  <a:srgbClr val="68727F"/>
+                </a:solidFill>
+                <a:latin typeface="Noto Sans KR"/>
+                <a:ea typeface="Noto Sans KR"/>
+                <a:cs typeface="Noto Sans KR"/>
+              </a:rPr>
+              <a:t>각 K 내부 paired 비교 · K5/K10 품질 직접 비교 아님</a:t>
             </a:r>
           </a:p>
         </p:txBody>
       </p:sp>
       <p:graphicFrame>
         <p:nvGraphicFramePr>
-          <p:cNvPr id="12" name="Chart"/>
+          <p:cNvPr id="20" name="Chart"/>
           <p:cNvGraphicFramePr/>
           <p:nvPr/>
         </p:nvGraphicFramePr>
@@ -4373,375 +5036,10 @@
         </p:xfrm>
         <a:graphic xmlns:a="http://schemas.openxmlformats.org/drawingml/2006/main">
           <a:graphicData uri="http://schemas.openxmlformats.org/drawingml/2006/chart">
-            <c:chart xmlns:r="http://schemas.openxmlformats.org/officeDocument/2006/relationships" xmlns:c="http://schemas.openxmlformats.org/drawingml/2006/chart" r:id="R1ca7f9a37dc048c4"/>
+            <c:chart xmlns:r="http://schemas.openxmlformats.org/officeDocument/2006/relationships" xmlns:c="http://schemas.openxmlformats.org/drawingml/2006/chart" r:id="R8ea7ec7a3aa44717"/>
           </a:graphicData>
         </a:graphic>
       </p:graphicFrame>
-      <p:sp>
-        <p:nvSpPr>
-          <p:cNvPr id="4" name="">
-            <a:extLst xmlns:a="http://schemas.openxmlformats.org/drawingml/2006/main">
-              <a:ext uri="{FF2B5EF4-FFF2-40B4-BE49-F238E27FC236}">
-                <a16:creationId xmlns:a16="http://schemas.microsoft.com/office/drawing/2014/main" id="{8FD4084F-EAE3-4B55-8B91-647BD19DCF23}"/>
-              </a:ext>
-            </a:extLst>
-          </p:cNvPr>
-          <p:cNvSpPr>
-            <a:spLocks xmlns:a="http://schemas.openxmlformats.org/drawingml/2006/main" noGrp="1"/>
-          </p:cNvSpPr>
-          <p:nvPr/>
-        </p:nvSpPr>
-        <p:spPr>
-          <a:xfrm xmlns:a="http://schemas.openxmlformats.org/drawingml/2006/main">
-            <a:off x="9429750" y="1790700"/>
-            <a:ext cx="2190750" cy="590550"/>
-          </a:xfrm>
-          <a:prstGeom xmlns:a="http://schemas.openxmlformats.org/drawingml/2006/main" prst="rect">
-            <a:avLst/>
-          </a:prstGeom>
-          <a:noFill xmlns:a="http://schemas.openxmlformats.org/drawingml/2006/main"/>
-          <a:ln xmlns:a="http://schemas.openxmlformats.org/drawingml/2006/main" w="0">
-            <a:noFill/>
-          </a:ln>
-        </p:spPr>
-        <p:txBody>
-          <a:bodyPr xmlns:a="http://schemas.openxmlformats.org/drawingml/2006/main">
-            <a:noAutofit/>
-          </a:bodyPr>
-          <a:lstStyle xmlns:a="http://schemas.openxmlformats.org/drawingml/2006/main"/>
-          <a:p xmlns:a="http://schemas.openxmlformats.org/drawingml/2006/main">
-            <a:pPr>
-              <a:defRPr sz="3375" b="1">
-                <a:solidFill>
-                  <a:srgbClr val="3157D5"/>
-                </a:solidFill>
-                <a:latin typeface="Noto Sans KR"/>
-                <a:ea typeface="Noto Sans KR"/>
-                <a:cs typeface="Noto Sans KR"/>
-              </a:defRPr>
-            </a:pPr>
-            <a:r>
-              <a:rPr sz="3375" b="1">
-                <a:solidFill>
-                  <a:srgbClr val="3157D5"/>
-                </a:solidFill>
-                <a:latin typeface="Noto Sans KR"/>
-                <a:ea typeface="Noto Sans KR"/>
-                <a:cs typeface="Noto Sans KR"/>
-              </a:rPr>
-              <a:t>+0.0311</a:t>
-            </a:r>
-          </a:p>
-        </p:txBody>
-      </p:sp>
-      <p:sp>
-        <p:nvSpPr>
-          <p:cNvPr id="5" name="">
-            <a:extLst xmlns:a="http://schemas.openxmlformats.org/drawingml/2006/main">
-              <a:ext uri="{FF2B5EF4-FFF2-40B4-BE49-F238E27FC236}">
-                <a16:creationId xmlns:a16="http://schemas.microsoft.com/office/drawing/2014/main" id="{A8687CAE-FFF9-45ED-85A9-B00625C61E6C}"/>
-              </a:ext>
-            </a:extLst>
-          </p:cNvPr>
-          <p:cNvSpPr>
-            <a:spLocks xmlns:a="http://schemas.openxmlformats.org/drawingml/2006/main" noGrp="1"/>
-          </p:cNvSpPr>
-          <p:nvPr/>
-        </p:nvSpPr>
-        <p:spPr>
-          <a:xfrm xmlns:a="http://schemas.openxmlformats.org/drawingml/2006/main">
-            <a:off x="9467850" y="2400300"/>
-            <a:ext cx="2190750" cy="304800"/>
-          </a:xfrm>
-          <a:prstGeom xmlns:a="http://schemas.openxmlformats.org/drawingml/2006/main" prst="rect">
-            <a:avLst/>
-          </a:prstGeom>
-          <a:noFill xmlns:a="http://schemas.openxmlformats.org/drawingml/2006/main"/>
-          <a:ln xmlns:a="http://schemas.openxmlformats.org/drawingml/2006/main" w="0">
-            <a:noFill/>
-          </a:ln>
-        </p:spPr>
-        <p:txBody>
-          <a:bodyPr xmlns:a="http://schemas.openxmlformats.org/drawingml/2006/main">
-            <a:noAutofit/>
-          </a:bodyPr>
-          <a:lstStyle xmlns:a="http://schemas.openxmlformats.org/drawingml/2006/main"/>
-          <a:p xmlns:a="http://schemas.openxmlformats.org/drawingml/2006/main">
-            <a:pPr>
-              <a:defRPr sz="1500" b="0">
-                <a:solidFill>
-                  <a:srgbClr val="68727F"/>
-                </a:solidFill>
-                <a:latin typeface="Noto Sans KR"/>
-                <a:ea typeface="Noto Sans KR"/>
-                <a:cs typeface="Noto Sans KR"/>
-              </a:defRPr>
-            </a:pPr>
-            <a:r>
-              <a:rPr sz="1500" b="0">
-                <a:solidFill>
-                  <a:srgbClr val="68727F"/>
-                </a:solidFill>
-                <a:latin typeface="Noto Sans KR"/>
-                <a:ea typeface="Noto Sans KR"/>
-                <a:cs typeface="Noto Sans KR"/>
-              </a:rPr>
-              <a:t>K5 인기도 대비</a:t>
-            </a:r>
-          </a:p>
-        </p:txBody>
-      </p:sp>
-      <p:sp>
-        <p:nvSpPr>
-          <p:cNvPr id="6" name="">
-            <a:extLst xmlns:a="http://schemas.openxmlformats.org/drawingml/2006/main">
-              <a:ext uri="{FF2B5EF4-FFF2-40B4-BE49-F238E27FC236}">
-                <a16:creationId xmlns:a16="http://schemas.microsoft.com/office/drawing/2014/main" id="{249D3293-4F77-4214-AD3F-3CBAC966FE5B}"/>
-              </a:ext>
-            </a:extLst>
-          </p:cNvPr>
-          <p:cNvSpPr>
-            <a:spLocks xmlns:a="http://schemas.openxmlformats.org/drawingml/2006/main" noGrp="1"/>
-          </p:cNvSpPr>
-          <p:nvPr/>
-        </p:nvSpPr>
-        <p:spPr>
-          <a:xfrm xmlns:a="http://schemas.openxmlformats.org/drawingml/2006/main">
-            <a:off x="9429750" y="3238500"/>
-            <a:ext cx="2190750" cy="590550"/>
-          </a:xfrm>
-          <a:prstGeom xmlns:a="http://schemas.openxmlformats.org/drawingml/2006/main" prst="rect">
-            <a:avLst/>
-          </a:prstGeom>
-          <a:noFill xmlns:a="http://schemas.openxmlformats.org/drawingml/2006/main"/>
-          <a:ln xmlns:a="http://schemas.openxmlformats.org/drawingml/2006/main" w="0">
-            <a:noFill/>
-          </a:ln>
-        </p:spPr>
-        <p:txBody>
-          <a:bodyPr xmlns:a="http://schemas.openxmlformats.org/drawingml/2006/main">
-            <a:noAutofit/>
-          </a:bodyPr>
-          <a:lstStyle xmlns:a="http://schemas.openxmlformats.org/drawingml/2006/main"/>
-          <a:p xmlns:a="http://schemas.openxmlformats.org/drawingml/2006/main">
-            <a:pPr>
-              <a:defRPr sz="3375" b="1">
-                <a:solidFill>
-                  <a:srgbClr val="3157D5"/>
-                </a:solidFill>
-                <a:latin typeface="Noto Sans KR"/>
-                <a:ea typeface="Noto Sans KR"/>
-                <a:cs typeface="Noto Sans KR"/>
-              </a:defRPr>
-            </a:pPr>
-            <a:r>
-              <a:rPr sz="3375" b="1">
-                <a:solidFill>
-                  <a:srgbClr val="3157D5"/>
-                </a:solidFill>
-                <a:latin typeface="Noto Sans KR"/>
-                <a:ea typeface="Noto Sans KR"/>
-                <a:cs typeface="Noto Sans KR"/>
-              </a:rPr>
-              <a:t>+0.0434</a:t>
-            </a:r>
-          </a:p>
-        </p:txBody>
-      </p:sp>
-      <p:sp>
-        <p:nvSpPr>
-          <p:cNvPr id="7" name="">
-            <a:extLst xmlns:a="http://schemas.openxmlformats.org/drawingml/2006/main">
-              <a:ext uri="{FF2B5EF4-FFF2-40B4-BE49-F238E27FC236}">
-                <a16:creationId xmlns:a16="http://schemas.microsoft.com/office/drawing/2014/main" id="{371D8103-3CB4-4F56-A418-FC5A79214736}"/>
-              </a:ext>
-            </a:extLst>
-          </p:cNvPr>
-          <p:cNvSpPr>
-            <a:spLocks xmlns:a="http://schemas.openxmlformats.org/drawingml/2006/main" noGrp="1"/>
-          </p:cNvSpPr>
-          <p:nvPr/>
-        </p:nvSpPr>
-        <p:spPr>
-          <a:xfrm xmlns:a="http://schemas.openxmlformats.org/drawingml/2006/main">
-            <a:off x="9467850" y="3848100"/>
-            <a:ext cx="2190750" cy="304800"/>
-          </a:xfrm>
-          <a:prstGeom xmlns:a="http://schemas.openxmlformats.org/drawingml/2006/main" prst="rect">
-            <a:avLst/>
-          </a:prstGeom>
-          <a:noFill xmlns:a="http://schemas.openxmlformats.org/drawingml/2006/main"/>
-          <a:ln xmlns:a="http://schemas.openxmlformats.org/drawingml/2006/main" w="0">
-            <a:noFill/>
-          </a:ln>
-        </p:spPr>
-        <p:txBody>
-          <a:bodyPr xmlns:a="http://schemas.openxmlformats.org/drawingml/2006/main">
-            <a:noAutofit/>
-          </a:bodyPr>
-          <a:lstStyle xmlns:a="http://schemas.openxmlformats.org/drawingml/2006/main"/>
-          <a:p xmlns:a="http://schemas.openxmlformats.org/drawingml/2006/main">
-            <a:pPr>
-              <a:defRPr sz="1500" b="0">
-                <a:solidFill>
-                  <a:srgbClr val="68727F"/>
-                </a:solidFill>
-                <a:latin typeface="Noto Sans KR"/>
-                <a:ea typeface="Noto Sans KR"/>
-                <a:cs typeface="Noto Sans KR"/>
-              </a:defRPr>
-            </a:pPr>
-            <a:r>
-              <a:rPr sz="1500" b="0">
-                <a:solidFill>
-                  <a:srgbClr val="68727F"/>
-                </a:solidFill>
-                <a:latin typeface="Noto Sans KR"/>
-                <a:ea typeface="Noto Sans KR"/>
-                <a:cs typeface="Noto Sans KR"/>
-              </a:rPr>
-              <a:t>K10 인기도 대비</a:t>
-            </a:r>
-          </a:p>
-        </p:txBody>
-      </p:sp>
-      <p:sp>
-        <p:nvSpPr>
-          <p:cNvPr id="8" name="">
-            <a:extLst xmlns:a="http://schemas.openxmlformats.org/drawingml/2006/main">
-              <a:ext uri="{FF2B5EF4-FFF2-40B4-BE49-F238E27FC236}">
-                <a16:creationId xmlns:a16="http://schemas.microsoft.com/office/drawing/2014/main" id="{CE3E4B44-CCCD-4EC9-BF7F-67CCB15D4B5F}"/>
-              </a:ext>
-            </a:extLst>
-          </p:cNvPr>
-          <p:cNvSpPr>
-            <a:spLocks xmlns:a="http://schemas.openxmlformats.org/drawingml/2006/main" noGrp="1"/>
-          </p:cNvSpPr>
-          <p:nvPr/>
-        </p:nvSpPr>
-        <p:spPr>
-          <a:xfrm xmlns:a="http://schemas.openxmlformats.org/drawingml/2006/main">
-            <a:off x="9429750" y="4762500"/>
-            <a:ext cx="2190750" cy="819150"/>
-          </a:xfrm>
-          <a:prstGeom xmlns:a="http://schemas.openxmlformats.org/drawingml/2006/main" prst="rect">
-            <a:avLst/>
-          </a:prstGeom>
-          <a:noFill xmlns:a="http://schemas.openxmlformats.org/drawingml/2006/main"/>
-          <a:ln xmlns:a="http://schemas.openxmlformats.org/drawingml/2006/main" w="0">
-            <a:noFill/>
-          </a:ln>
-        </p:spPr>
-        <p:txBody>
-          <a:bodyPr xmlns:a="http://schemas.openxmlformats.org/drawingml/2006/main">
-            <a:noAutofit/>
-          </a:bodyPr>
-          <a:lstStyle xmlns:a="http://schemas.openxmlformats.org/drawingml/2006/main"/>
-          <a:p xmlns:a="http://schemas.openxmlformats.org/drawingml/2006/main">
-            <a:pPr>
-              <a:defRPr sz="1725" b="1">
-                <a:solidFill>
-                  <a:srgbClr val="D34E5B"/>
-                </a:solidFill>
-                <a:latin typeface="Noto Sans KR"/>
-                <a:ea typeface="Noto Sans KR"/>
-                <a:cs typeface="Noto Sans KR"/>
-              </a:defRPr>
-            </a:pPr>
-            <a:r>
-              <a:rPr sz="1725" b="1">
-                <a:solidFill>
-                  <a:srgbClr val="D34E5B"/>
-                </a:solidFill>
-                <a:latin typeface="Noto Sans KR"/>
-                <a:ea typeface="Noto Sans KR"/>
-                <a:cs typeface="Noto Sans KR"/>
-              </a:rPr>
-              <a:t>콘텐츠 단독 모델은</a:t>
-            </a:r>
-          </a:p>
-          <a:p xmlns:a="http://schemas.openxmlformats.org/drawingml/2006/main">
-            <a:pPr>
-              <a:defRPr sz="1725" b="1">
-                <a:solidFill>
-                  <a:srgbClr val="D34E5B"/>
-                </a:solidFill>
-                <a:latin typeface="Noto Sans KR"/>
-                <a:ea typeface="Noto Sans KR"/>
-                <a:cs typeface="Noto Sans KR"/>
-              </a:defRPr>
-            </a:pPr>
-            <a:r>
-              <a:rPr sz="1725" b="1">
-                <a:solidFill>
-                  <a:srgbClr val="D34E5B"/>
-                </a:solidFill>
-                <a:latin typeface="Noto Sans KR"/>
-                <a:ea typeface="Noto Sans KR"/>
-                <a:cs typeface="Noto Sans KR"/>
-              </a:rPr>
-              <a:t>인기도보다 낮았다</a:t>
-            </a:r>
-          </a:p>
-        </p:txBody>
-      </p:sp>
-      <p:sp>
-        <p:nvSpPr>
-          <p:cNvPr id="9" name="">
-            <a:extLst xmlns:a="http://schemas.openxmlformats.org/drawingml/2006/main">
-              <a:ext uri="{FF2B5EF4-FFF2-40B4-BE49-F238E27FC236}">
-                <a16:creationId xmlns:a16="http://schemas.microsoft.com/office/drawing/2014/main" id="{BC85B7AB-C12A-4945-A2E5-65A694173BD6}"/>
-              </a:ext>
-            </a:extLst>
-          </p:cNvPr>
-          <p:cNvSpPr>
-            <a:spLocks xmlns:a="http://schemas.openxmlformats.org/drawingml/2006/main" noGrp="1"/>
-          </p:cNvSpPr>
-          <p:nvPr/>
-        </p:nvSpPr>
-        <p:spPr>
-          <a:xfrm xmlns:a="http://schemas.openxmlformats.org/drawingml/2006/main">
-            <a:off x="552450" y="6153150"/>
-            <a:ext cx="4000500" cy="247650"/>
-          </a:xfrm>
-          <a:prstGeom xmlns:a="http://schemas.openxmlformats.org/drawingml/2006/main" prst="rect">
-            <a:avLst/>
-          </a:prstGeom>
-          <a:noFill xmlns:a="http://schemas.openxmlformats.org/drawingml/2006/main"/>
-          <a:ln xmlns:a="http://schemas.openxmlformats.org/drawingml/2006/main" w="0">
-            <a:noFill/>
-          </a:ln>
-        </p:spPr>
-        <p:txBody>
-          <a:bodyPr xmlns:a="http://schemas.openxmlformats.org/drawingml/2006/main">
-            <a:noAutofit/>
-          </a:bodyPr>
-          <a:lstStyle xmlns:a="http://schemas.openxmlformats.org/drawingml/2006/main"/>
-          <a:p xmlns:a="http://schemas.openxmlformats.org/drawingml/2006/main">
-            <a:pPr>
-              <a:defRPr sz="1275" b="0">
-                <a:solidFill>
-                  <a:srgbClr val="68727F"/>
-                </a:solidFill>
-                <a:latin typeface="Noto Sans KR"/>
-                <a:ea typeface="Noto Sans KR"/>
-                <a:cs typeface="Noto Sans KR"/>
-              </a:defRPr>
-            </a:pPr>
-            <a:r>
-              <a:rPr sz="1275" b="0">
-                <a:solidFill>
-                  <a:srgbClr val="68727F"/>
-                </a:solidFill>
-                <a:latin typeface="Noto Sans KR"/>
-                <a:ea typeface="Noto Sans KR"/>
-                <a:cs typeface="Noto Sans KR"/>
-              </a:rPr>
-              <a:t>NDCG@10 · 사용자 macro</a:t>
-            </a:r>
-          </a:p>
-        </p:txBody>
-      </p:sp>
     </p:spTree>
     <p:extLst>
       <p:ext uri="{BB962C8B-B14F-4D97-AF65-F5344CB8AC3E}">
@@ -4805,6 +5103,7 @@
           <a:lstStyle xmlns:a="http://schemas.openxmlformats.org/drawingml/2006/main"/>
           <a:p xmlns:a="http://schemas.openxmlformats.org/drawingml/2006/main">
             <a:pPr>
+              <a:buNone/>
               <a:defRPr sz="3225" b="1">
                 <a:solidFill>
                   <a:srgbClr val="18202A"/>
@@ -4823,7 +5122,7 @@
                 <a:ea typeface="Noto Sans KR"/>
                 <a:cs typeface="Noto Sans KR"/>
               </a:rPr>
-              <a:t>개선 사용자는 늘었지만 다수는 동률이었다</a:t>
+              <a:t>K10의 더 큰 delta는 B0 하락의 영향이었다</a:t>
             </a:r>
           </a:p>
         </p:txBody>
@@ -4862,6 +5161,7 @@
           <a:lstStyle xmlns:a="http://schemas.openxmlformats.org/drawingml/2006/main"/>
           <a:p xmlns:a="http://schemas.openxmlformats.org/drawingml/2006/main">
             <a:pPr>
+              <a:buNone/>
               <a:defRPr sz="1275" b="1">
                 <a:solidFill>
                   <a:srgbClr val="68727F"/>
@@ -4881,13 +5181,477 @@
                 <a:cs typeface="Noto Sans KR"/>
               </a:rPr>
               <a:t>05</a:t>
+            </a:r>
+          </a:p>
+        </p:txBody>
+      </p:sp>
+      <p:sp>
+        <p:nvSpPr>
+          <p:cNvPr id="4" name="">
+            <a:extLst xmlns:a="http://schemas.openxmlformats.org/drawingml/2006/main">
+              <a:ext uri="{FF2B5EF4-FFF2-40B4-BE49-F238E27FC236}">
+                <a16:creationId xmlns:a16="http://schemas.microsoft.com/office/drawing/2014/main" id="{86B169F6-14C4-4B49-B6CF-6854CC2CE69A}"/>
+              </a:ext>
+            </a:extLst>
+          </p:cNvPr>
+          <p:cNvSpPr>
+            <a:spLocks xmlns:a="http://schemas.openxmlformats.org/drawingml/2006/main" noGrp="1"/>
+          </p:cNvSpPr>
+          <p:nvPr/>
+        </p:nvSpPr>
+        <p:spPr>
+          <a:xfrm xmlns:a="http://schemas.openxmlformats.org/drawingml/2006/main">
+            <a:off x="9334500" y="1562100"/>
+            <a:ext cx="2095500" cy="476250"/>
+          </a:xfrm>
+          <a:prstGeom xmlns:a="http://schemas.openxmlformats.org/drawingml/2006/main" prst="rect">
+            <a:avLst/>
+          </a:prstGeom>
+          <a:noFill xmlns:a="http://schemas.openxmlformats.org/drawingml/2006/main"/>
+          <a:ln xmlns:a="http://schemas.openxmlformats.org/drawingml/2006/main" w="0">
+            <a:noFill/>
+          </a:ln>
+        </p:spPr>
+        <p:txBody>
+          <a:bodyPr xmlns:a="http://schemas.openxmlformats.org/drawingml/2006/main">
+            <a:noAutofit/>
+          </a:bodyPr>
+          <a:lstStyle xmlns:a="http://schemas.openxmlformats.org/drawingml/2006/main"/>
+          <a:p xmlns:a="http://schemas.openxmlformats.org/drawingml/2006/main">
+            <a:pPr>
+              <a:buNone/>
+              <a:defRPr sz="3000" b="1">
+                <a:solidFill>
+                  <a:srgbClr val="3157D5"/>
+                </a:solidFill>
+                <a:latin typeface="Noto Sans KR"/>
+                <a:ea typeface="Noto Sans KR"/>
+                <a:cs typeface="Noto Sans KR"/>
+              </a:defRPr>
+            </a:pPr>
+            <a:r>
+              <a:rPr sz="3000" b="1">
+                <a:solidFill>
+                  <a:srgbClr val="3157D5"/>
+                </a:solidFill>
+                <a:latin typeface="Noto Sans KR"/>
+                <a:ea typeface="Noto Sans KR"/>
+                <a:cs typeface="Noto Sans KR"/>
+              </a:rPr>
+              <a:t>1,253명</a:t>
+            </a:r>
+          </a:p>
+        </p:txBody>
+      </p:sp>
+      <p:sp>
+        <p:nvSpPr>
+          <p:cNvPr id="5" name="">
+            <a:extLst xmlns:a="http://schemas.openxmlformats.org/drawingml/2006/main">
+              <a:ext uri="{FF2B5EF4-FFF2-40B4-BE49-F238E27FC236}">
+                <a16:creationId xmlns:a16="http://schemas.microsoft.com/office/drawing/2014/main" id="{A7B1202C-61EC-416F-AB0C-B9BB43A477F6}"/>
+              </a:ext>
+            </a:extLst>
+          </p:cNvPr>
+          <p:cNvSpPr>
+            <a:spLocks xmlns:a="http://schemas.openxmlformats.org/drawingml/2006/main" noGrp="1"/>
+          </p:cNvSpPr>
+          <p:nvPr/>
+        </p:nvSpPr>
+        <p:spPr>
+          <a:xfrm xmlns:a="http://schemas.openxmlformats.org/drawingml/2006/main">
+            <a:off x="9372600" y="2066925"/>
+            <a:ext cx="1905000" cy="285750"/>
+          </a:xfrm>
+          <a:prstGeom xmlns:a="http://schemas.openxmlformats.org/drawingml/2006/main" prst="rect">
+            <a:avLst/>
+          </a:prstGeom>
+          <a:noFill xmlns:a="http://schemas.openxmlformats.org/drawingml/2006/main"/>
+          <a:ln xmlns:a="http://schemas.openxmlformats.org/drawingml/2006/main" w="0">
+            <a:noFill/>
+          </a:ln>
+        </p:spPr>
+        <p:txBody>
+          <a:bodyPr xmlns:a="http://schemas.openxmlformats.org/drawingml/2006/main">
+            <a:noAutofit/>
+          </a:bodyPr>
+          <a:lstStyle xmlns:a="http://schemas.openxmlformats.org/drawingml/2006/main"/>
+          <a:p xmlns:a="http://schemas.openxmlformats.org/drawingml/2006/main">
+            <a:pPr>
+              <a:buNone/>
+              <a:defRPr sz="1425" b="0">
+                <a:solidFill>
+                  <a:srgbClr val="68727F"/>
+                </a:solidFill>
+                <a:latin typeface="Noto Sans KR"/>
+                <a:ea typeface="Noto Sans KR"/>
+                <a:cs typeface="Noto Sans KR"/>
+              </a:defRPr>
+            </a:pPr>
+            <a:r>
+              <a:rPr sz="1425" b="0">
+                <a:solidFill>
+                  <a:srgbClr val="68727F"/>
+                </a:solidFill>
+                <a:latin typeface="Noto Sans KR"/>
+                <a:ea typeface="Noto Sans KR"/>
+                <a:cs typeface="Noto Sans KR"/>
+              </a:rPr>
+              <a:t>K5·10 공통 사용자</a:t>
+            </a:r>
+          </a:p>
+        </p:txBody>
+      </p:sp>
+      <p:sp>
+        <p:nvSpPr>
+          <p:cNvPr id="6" name="">
+            <a:extLst xmlns:a="http://schemas.openxmlformats.org/drawingml/2006/main">
+              <a:ext uri="{FF2B5EF4-FFF2-40B4-BE49-F238E27FC236}">
+                <a16:creationId xmlns:a16="http://schemas.microsoft.com/office/drawing/2014/main" id="{DDC40817-285B-4908-9DBB-739546BB7E76}"/>
+              </a:ext>
+            </a:extLst>
+          </p:cNvPr>
+          <p:cNvSpPr>
+            <a:spLocks xmlns:a="http://schemas.openxmlformats.org/drawingml/2006/main" noGrp="1"/>
+          </p:cNvSpPr>
+          <p:nvPr/>
+        </p:nvSpPr>
+        <p:spPr>
+          <a:xfrm xmlns:a="http://schemas.openxmlformats.org/drawingml/2006/main">
+            <a:off x="9334500" y="2800350"/>
+            <a:ext cx="2095500" cy="476250"/>
+          </a:xfrm>
+          <a:prstGeom xmlns:a="http://schemas.openxmlformats.org/drawingml/2006/main" prst="rect">
+            <a:avLst/>
+          </a:prstGeom>
+          <a:noFill xmlns:a="http://schemas.openxmlformats.org/drawingml/2006/main"/>
+          <a:ln xmlns:a="http://schemas.openxmlformats.org/drawingml/2006/main" w="0">
+            <a:noFill/>
+          </a:ln>
+        </p:spPr>
+        <p:txBody>
+          <a:bodyPr xmlns:a="http://schemas.openxmlformats.org/drawingml/2006/main">
+            <a:noAutofit/>
+          </a:bodyPr>
+          <a:lstStyle xmlns:a="http://schemas.openxmlformats.org/drawingml/2006/main"/>
+          <a:p xmlns:a="http://schemas.openxmlformats.org/drawingml/2006/main">
+            <a:pPr>
+              <a:buNone/>
+              <a:defRPr sz="3000" b="1">
+                <a:solidFill>
+                  <a:srgbClr val="3157D5"/>
+                </a:solidFill>
+                <a:latin typeface="Noto Sans KR"/>
+                <a:ea typeface="Noto Sans KR"/>
+                <a:cs typeface="Noto Sans KR"/>
+              </a:defRPr>
+            </a:pPr>
+            <a:r>
+              <a:rPr sz="3000" b="1">
+                <a:solidFill>
+                  <a:srgbClr val="3157D5"/>
+                </a:solidFill>
+                <a:latin typeface="Noto Sans KR"/>
+                <a:ea typeface="Noto Sans KR"/>
+                <a:cs typeface="Noto Sans KR"/>
+              </a:rPr>
+              <a:t>0.075359</a:t>
+            </a:r>
+          </a:p>
+        </p:txBody>
+      </p:sp>
+      <p:sp>
+        <p:nvSpPr>
+          <p:cNvPr id="7" name="">
+            <a:extLst xmlns:a="http://schemas.openxmlformats.org/drawingml/2006/main">
+              <a:ext uri="{FF2B5EF4-FFF2-40B4-BE49-F238E27FC236}">
+                <a16:creationId xmlns:a16="http://schemas.microsoft.com/office/drawing/2014/main" id="{B6D20D6A-DB4D-4822-AEEB-BC84E92F3235}"/>
+              </a:ext>
+            </a:extLst>
+          </p:cNvPr>
+          <p:cNvSpPr>
+            <a:spLocks xmlns:a="http://schemas.openxmlformats.org/drawingml/2006/main" noGrp="1"/>
+          </p:cNvSpPr>
+          <p:nvPr/>
+        </p:nvSpPr>
+        <p:spPr>
+          <a:xfrm xmlns:a="http://schemas.openxmlformats.org/drawingml/2006/main">
+            <a:off x="9372600" y="3305175"/>
+            <a:ext cx="1905000" cy="285750"/>
+          </a:xfrm>
+          <a:prstGeom xmlns:a="http://schemas.openxmlformats.org/drawingml/2006/main" prst="rect">
+            <a:avLst/>
+          </a:prstGeom>
+          <a:noFill xmlns:a="http://schemas.openxmlformats.org/drawingml/2006/main"/>
+          <a:ln xmlns:a="http://schemas.openxmlformats.org/drawingml/2006/main" w="0">
+            <a:noFill/>
+          </a:ln>
+        </p:spPr>
+        <p:txBody>
+          <a:bodyPr xmlns:a="http://schemas.openxmlformats.org/drawingml/2006/main">
+            <a:noAutofit/>
+          </a:bodyPr>
+          <a:lstStyle xmlns:a="http://schemas.openxmlformats.org/drawingml/2006/main"/>
+          <a:p xmlns:a="http://schemas.openxmlformats.org/drawingml/2006/main">
+            <a:pPr>
+              <a:buNone/>
+              <a:defRPr sz="1425" b="0">
+                <a:solidFill>
+                  <a:srgbClr val="68727F"/>
+                </a:solidFill>
+                <a:latin typeface="Noto Sans KR"/>
+                <a:ea typeface="Noto Sans KR"/>
+                <a:cs typeface="Noto Sans KR"/>
+              </a:defRPr>
+            </a:pPr>
+            <a:r>
+              <a:rPr sz="1425" b="0">
+                <a:solidFill>
+                  <a:srgbClr val="68727F"/>
+                </a:solidFill>
+                <a:latin typeface="Noto Sans KR"/>
+                <a:ea typeface="Noto Sans KR"/>
+                <a:cs typeface="Noto Sans KR"/>
+              </a:rPr>
+              <a:t>LightFM K5</a:t>
+            </a:r>
+          </a:p>
+        </p:txBody>
+      </p:sp>
+      <p:sp>
+        <p:nvSpPr>
+          <p:cNvPr id="8" name="">
+            <a:extLst xmlns:a="http://schemas.openxmlformats.org/drawingml/2006/main">
+              <a:ext uri="{FF2B5EF4-FFF2-40B4-BE49-F238E27FC236}">
+                <a16:creationId xmlns:a16="http://schemas.microsoft.com/office/drawing/2014/main" id="{F4C35A2A-2923-4D8B-AD01-44DA57C396BC}"/>
+              </a:ext>
+            </a:extLst>
+          </p:cNvPr>
+          <p:cNvSpPr>
+            <a:spLocks xmlns:a="http://schemas.openxmlformats.org/drawingml/2006/main" noGrp="1"/>
+          </p:cNvSpPr>
+          <p:nvPr/>
+        </p:nvSpPr>
+        <p:spPr>
+          <a:xfrm xmlns:a="http://schemas.openxmlformats.org/drawingml/2006/main">
+            <a:off x="9334500" y="4038600"/>
+            <a:ext cx="2095500" cy="476250"/>
+          </a:xfrm>
+          <a:prstGeom xmlns:a="http://schemas.openxmlformats.org/drawingml/2006/main" prst="rect">
+            <a:avLst/>
+          </a:prstGeom>
+          <a:noFill xmlns:a="http://schemas.openxmlformats.org/drawingml/2006/main"/>
+          <a:ln xmlns:a="http://schemas.openxmlformats.org/drawingml/2006/main" w="0">
+            <a:noFill/>
+          </a:ln>
+        </p:spPr>
+        <p:txBody>
+          <a:bodyPr xmlns:a="http://schemas.openxmlformats.org/drawingml/2006/main">
+            <a:noAutofit/>
+          </a:bodyPr>
+          <a:lstStyle xmlns:a="http://schemas.openxmlformats.org/drawingml/2006/main"/>
+          <a:p xmlns:a="http://schemas.openxmlformats.org/drawingml/2006/main">
+            <a:pPr>
+              <a:buNone/>
+              <a:defRPr sz="3000" b="1">
+                <a:solidFill>
+                  <a:srgbClr val="D34E5B"/>
+                </a:solidFill>
+                <a:latin typeface="Noto Sans KR"/>
+                <a:ea typeface="Noto Sans KR"/>
+                <a:cs typeface="Noto Sans KR"/>
+              </a:defRPr>
+            </a:pPr>
+            <a:r>
+              <a:rPr sz="3000" b="1">
+                <a:solidFill>
+                  <a:srgbClr val="D34E5B"/>
+                </a:solidFill>
+                <a:latin typeface="Noto Sans KR"/>
+                <a:ea typeface="Noto Sans KR"/>
+                <a:cs typeface="Noto Sans KR"/>
+              </a:rPr>
+              <a:t>0.075348</a:t>
+            </a:r>
+          </a:p>
+        </p:txBody>
+      </p:sp>
+      <p:sp>
+        <p:nvSpPr>
+          <p:cNvPr id="9" name="">
+            <a:extLst xmlns:a="http://schemas.openxmlformats.org/drawingml/2006/main">
+              <a:ext uri="{FF2B5EF4-FFF2-40B4-BE49-F238E27FC236}">
+                <a16:creationId xmlns:a16="http://schemas.microsoft.com/office/drawing/2014/main" id="{3802BC1F-124D-46F3-BF3A-0FF70D1824C0}"/>
+              </a:ext>
+            </a:extLst>
+          </p:cNvPr>
+          <p:cNvSpPr>
+            <a:spLocks xmlns:a="http://schemas.openxmlformats.org/drawingml/2006/main" noGrp="1"/>
+          </p:cNvSpPr>
+          <p:nvPr/>
+        </p:nvSpPr>
+        <p:spPr>
+          <a:xfrm xmlns:a="http://schemas.openxmlformats.org/drawingml/2006/main">
+            <a:off x="9372600" y="4543425"/>
+            <a:ext cx="1905000" cy="285750"/>
+          </a:xfrm>
+          <a:prstGeom xmlns:a="http://schemas.openxmlformats.org/drawingml/2006/main" prst="rect">
+            <a:avLst/>
+          </a:prstGeom>
+          <a:noFill xmlns:a="http://schemas.openxmlformats.org/drawingml/2006/main"/>
+          <a:ln xmlns:a="http://schemas.openxmlformats.org/drawingml/2006/main" w="0">
+            <a:noFill/>
+          </a:ln>
+        </p:spPr>
+        <p:txBody>
+          <a:bodyPr xmlns:a="http://schemas.openxmlformats.org/drawingml/2006/main">
+            <a:noAutofit/>
+          </a:bodyPr>
+          <a:lstStyle xmlns:a="http://schemas.openxmlformats.org/drawingml/2006/main"/>
+          <a:p xmlns:a="http://schemas.openxmlformats.org/drawingml/2006/main">
+            <a:pPr>
+              <a:buNone/>
+              <a:defRPr sz="1425" b="0">
+                <a:solidFill>
+                  <a:srgbClr val="68727F"/>
+                </a:solidFill>
+                <a:latin typeface="Noto Sans KR"/>
+                <a:ea typeface="Noto Sans KR"/>
+                <a:cs typeface="Noto Sans KR"/>
+              </a:defRPr>
+            </a:pPr>
+            <a:r>
+              <a:rPr sz="1425" b="0">
+                <a:solidFill>
+                  <a:srgbClr val="68727F"/>
+                </a:solidFill>
+                <a:latin typeface="Noto Sans KR"/>
+                <a:ea typeface="Noto Sans KR"/>
+                <a:cs typeface="Noto Sans KR"/>
+              </a:rPr>
+              <a:t>LightFM K10</a:t>
+            </a:r>
+          </a:p>
+        </p:txBody>
+      </p:sp>
+      <p:sp>
+        <p:nvSpPr>
+          <p:cNvPr id="10" name="">
+            <a:extLst xmlns:a="http://schemas.openxmlformats.org/drawingml/2006/main">
+              <a:ext uri="{FF2B5EF4-FFF2-40B4-BE49-F238E27FC236}">
+                <a16:creationId xmlns:a16="http://schemas.microsoft.com/office/drawing/2014/main" id="{FA39A5E7-6B37-480D-9543-FE2D142660C2}"/>
+              </a:ext>
+            </a:extLst>
+          </p:cNvPr>
+          <p:cNvSpPr>
+            <a:spLocks xmlns:a="http://schemas.openxmlformats.org/drawingml/2006/main" noGrp="1"/>
+          </p:cNvSpPr>
+          <p:nvPr/>
+        </p:nvSpPr>
+        <p:spPr>
+          <a:xfrm xmlns:a="http://schemas.openxmlformats.org/drawingml/2006/main">
+            <a:off x="685800" y="5429250"/>
+            <a:ext cx="2857500" cy="285750"/>
+          </a:xfrm>
+          <a:prstGeom xmlns:a="http://schemas.openxmlformats.org/drawingml/2006/main" prst="rect">
+            <a:avLst/>
+          </a:prstGeom>
+          <a:noFill xmlns:a="http://schemas.openxmlformats.org/drawingml/2006/main"/>
+          <a:ln xmlns:a="http://schemas.openxmlformats.org/drawingml/2006/main" w="0">
+            <a:noFill/>
+          </a:ln>
+        </p:spPr>
+        <p:txBody>
+          <a:bodyPr xmlns:a="http://schemas.openxmlformats.org/drawingml/2006/main">
+            <a:noAutofit/>
+          </a:bodyPr>
+          <a:lstStyle xmlns:a="http://schemas.openxmlformats.org/drawingml/2006/main"/>
+          <a:p xmlns:a="http://schemas.openxmlformats.org/drawingml/2006/main">
+            <a:pPr>
+              <a:buNone/>
+              <a:defRPr sz="1425" b="1">
+                <a:solidFill>
+                  <a:srgbClr val="3157D5"/>
+                </a:solidFill>
+                <a:latin typeface="Noto Sans KR"/>
+                <a:ea typeface="Noto Sans KR"/>
+                <a:cs typeface="Noto Sans KR"/>
+              </a:defRPr>
+            </a:pPr>
+            <a:r>
+              <a:rPr sz="1425" b="1">
+                <a:solidFill>
+                  <a:srgbClr val="3157D5"/>
+                </a:solidFill>
+                <a:latin typeface="Noto Sans KR"/>
+                <a:ea typeface="Noto Sans KR"/>
+                <a:cs typeface="Noto Sans KR"/>
+              </a:rPr>
+              <a:t>공통 사용자 절대값</a:t>
+            </a:r>
+          </a:p>
+        </p:txBody>
+      </p:sp>
+      <p:sp>
+        <p:nvSpPr>
+          <p:cNvPr id="11" name="">
+            <a:extLst xmlns:a="http://schemas.openxmlformats.org/drawingml/2006/main">
+              <a:ext uri="{FF2B5EF4-FFF2-40B4-BE49-F238E27FC236}">
+                <a16:creationId xmlns:a16="http://schemas.microsoft.com/office/drawing/2014/main" id="{D8003AF8-182E-48B2-A004-914DB7DC9F06}"/>
+              </a:ext>
+            </a:extLst>
+          </p:cNvPr>
+          <p:cNvSpPr>
+            <a:spLocks xmlns:a="http://schemas.openxmlformats.org/drawingml/2006/main" noGrp="1"/>
+          </p:cNvSpPr>
+          <p:nvPr/>
+        </p:nvSpPr>
+        <p:spPr>
+          <a:xfrm xmlns:a="http://schemas.openxmlformats.org/drawingml/2006/main">
+            <a:off x="685800" y="5829300"/>
+            <a:ext cx="8096250" cy="323850"/>
+          </a:xfrm>
+          <a:prstGeom xmlns:a="http://schemas.openxmlformats.org/drawingml/2006/main" prst="rect">
+            <a:avLst/>
+          </a:prstGeom>
+          <a:noFill xmlns:a="http://schemas.openxmlformats.org/drawingml/2006/main"/>
+          <a:ln xmlns:a="http://schemas.openxmlformats.org/drawingml/2006/main" w="0">
+            <a:noFill/>
+          </a:ln>
+        </p:spPr>
+        <p:txBody>
+          <a:bodyPr xmlns:a="http://schemas.openxmlformats.org/drawingml/2006/main">
+            <a:noAutofit/>
+          </a:bodyPr>
+          <a:lstStyle xmlns:a="http://schemas.openxmlformats.org/drawingml/2006/main"/>
+          <a:p xmlns:a="http://schemas.openxmlformats.org/drawingml/2006/main">
+            <a:pPr>
+              <a:buNone/>
+              <a:defRPr sz="1800" b="1">
+                <a:solidFill>
+                  <a:srgbClr val="18202A"/>
+                </a:solidFill>
+                <a:latin typeface="Noto Sans KR"/>
+                <a:ea typeface="Noto Sans KR"/>
+                <a:cs typeface="Noto Sans KR"/>
+              </a:defRPr>
+            </a:pPr>
+            <a:r>
+              <a:rPr sz="1800" b="1">
+                <a:solidFill>
+                  <a:srgbClr val="18202A"/>
+                </a:solidFill>
+                <a:latin typeface="Noto Sans KR"/>
+                <a:ea typeface="Noto Sans KR"/>
+                <a:cs typeface="Noto Sans KR"/>
+              </a:rPr>
+              <a:t>B0 0.038780 → 0.030512 · LightFM은 사실상 동일</a:t>
             </a:r>
           </a:p>
         </p:txBody>
       </p:sp>
       <p:graphicFrame>
         <p:nvGraphicFramePr>
-          <p:cNvPr id="14" name="Chart"/>
+          <p:cNvPr id="24" name="Chart"/>
           <p:cNvGraphicFramePr/>
           <p:nvPr/>
         </p:nvGraphicFramePr>
@@ -4897,466 +5661,10 @@
         </p:xfrm>
         <a:graphic xmlns:a="http://schemas.openxmlformats.org/drawingml/2006/main">
           <a:graphicData uri="http://schemas.openxmlformats.org/drawingml/2006/chart">
-            <c:chart xmlns:r="http://schemas.openxmlformats.org/officeDocument/2006/relationships" xmlns:c="http://schemas.openxmlformats.org/drawingml/2006/chart" r:id="R014650c90629412d"/>
+            <c:chart xmlns:r="http://schemas.openxmlformats.org/officeDocument/2006/relationships" xmlns:c="http://schemas.openxmlformats.org/drawingml/2006/chart" r:id="R1c6109138ad84f2c"/>
           </a:graphicData>
         </a:graphic>
       </p:graphicFrame>
-      <p:sp>
-        <p:nvSpPr>
-          <p:cNvPr id="4" name="">
-            <a:extLst xmlns:a="http://schemas.openxmlformats.org/drawingml/2006/main">
-              <a:ext uri="{FF2B5EF4-FFF2-40B4-BE49-F238E27FC236}">
-                <a16:creationId xmlns:a16="http://schemas.microsoft.com/office/drawing/2014/main" id="{86B169F6-14C4-4B49-B6CF-6854CC2CE69A}"/>
-              </a:ext>
-            </a:extLst>
-          </p:cNvPr>
-          <p:cNvSpPr>
-            <a:spLocks xmlns:a="http://schemas.openxmlformats.org/drawingml/2006/main" noGrp="1"/>
-          </p:cNvSpPr>
-          <p:nvPr/>
-        </p:nvSpPr>
-        <p:spPr>
-          <a:xfrm xmlns:a="http://schemas.openxmlformats.org/drawingml/2006/main">
-            <a:off x="9334500" y="1562100"/>
-            <a:ext cx="2095500" cy="476250"/>
-          </a:xfrm>
-          <a:prstGeom xmlns:a="http://schemas.openxmlformats.org/drawingml/2006/main" prst="rect">
-            <a:avLst/>
-          </a:prstGeom>
-          <a:noFill xmlns:a="http://schemas.openxmlformats.org/drawingml/2006/main"/>
-          <a:ln xmlns:a="http://schemas.openxmlformats.org/drawingml/2006/main" w="0">
-            <a:noFill/>
-          </a:ln>
-        </p:spPr>
-        <p:txBody>
-          <a:bodyPr xmlns:a="http://schemas.openxmlformats.org/drawingml/2006/main">
-            <a:noAutofit/>
-          </a:bodyPr>
-          <a:lstStyle xmlns:a="http://schemas.openxmlformats.org/drawingml/2006/main"/>
-          <a:p xmlns:a="http://schemas.openxmlformats.org/drawingml/2006/main">
-            <a:pPr>
-              <a:defRPr sz="3000" b="1">
-                <a:solidFill>
-                  <a:srgbClr val="3157D5"/>
-                </a:solidFill>
-                <a:latin typeface="Noto Sans KR"/>
-                <a:ea typeface="Noto Sans KR"/>
-                <a:cs typeface="Noto Sans KR"/>
-              </a:defRPr>
-            </a:pPr>
-            <a:r>
-              <a:rPr sz="3000" b="1">
-                <a:solidFill>
-                  <a:srgbClr val="3157D5"/>
-                </a:solidFill>
-                <a:latin typeface="Noto Sans KR"/>
-                <a:ea typeface="Noto Sans KR"/>
-                <a:cs typeface="Noto Sans KR"/>
-              </a:rPr>
-              <a:t>21.8%</a:t>
-            </a:r>
-          </a:p>
-        </p:txBody>
-      </p:sp>
-      <p:sp>
-        <p:nvSpPr>
-          <p:cNvPr id="5" name="">
-            <a:extLst xmlns:a="http://schemas.openxmlformats.org/drawingml/2006/main">
-              <a:ext uri="{FF2B5EF4-FFF2-40B4-BE49-F238E27FC236}">
-                <a16:creationId xmlns:a16="http://schemas.microsoft.com/office/drawing/2014/main" id="{A7B1202C-61EC-416F-AB0C-B9BB43A477F6}"/>
-              </a:ext>
-            </a:extLst>
-          </p:cNvPr>
-          <p:cNvSpPr>
-            <a:spLocks xmlns:a="http://schemas.openxmlformats.org/drawingml/2006/main" noGrp="1"/>
-          </p:cNvSpPr>
-          <p:nvPr/>
-        </p:nvSpPr>
-        <p:spPr>
-          <a:xfrm xmlns:a="http://schemas.openxmlformats.org/drawingml/2006/main">
-            <a:off x="9372600" y="2066925"/>
-            <a:ext cx="1905000" cy="285750"/>
-          </a:xfrm>
-          <a:prstGeom xmlns:a="http://schemas.openxmlformats.org/drawingml/2006/main" prst="rect">
-            <a:avLst/>
-          </a:prstGeom>
-          <a:noFill xmlns:a="http://schemas.openxmlformats.org/drawingml/2006/main"/>
-          <a:ln xmlns:a="http://schemas.openxmlformats.org/drawingml/2006/main" w="0">
-            <a:noFill/>
-          </a:ln>
-        </p:spPr>
-        <p:txBody>
-          <a:bodyPr xmlns:a="http://schemas.openxmlformats.org/drawingml/2006/main">
-            <a:noAutofit/>
-          </a:bodyPr>
-          <a:lstStyle xmlns:a="http://schemas.openxmlformats.org/drawingml/2006/main"/>
-          <a:p xmlns:a="http://schemas.openxmlformats.org/drawingml/2006/main">
-            <a:pPr>
-              <a:defRPr sz="1425" b="0">
-                <a:solidFill>
-                  <a:srgbClr val="68727F"/>
-                </a:solidFill>
-                <a:latin typeface="Noto Sans KR"/>
-                <a:ea typeface="Noto Sans KR"/>
-                <a:cs typeface="Noto Sans KR"/>
-              </a:defRPr>
-            </a:pPr>
-            <a:r>
-              <a:rPr sz="1425" b="0">
-                <a:solidFill>
-                  <a:srgbClr val="68727F"/>
-                </a:solidFill>
-                <a:latin typeface="Noto Sans KR"/>
-                <a:ea typeface="Noto Sans KR"/>
-                <a:cs typeface="Noto Sans KR"/>
-              </a:rPr>
-              <a:t>K10 개선</a:t>
-            </a:r>
-          </a:p>
-        </p:txBody>
-      </p:sp>
-      <p:sp>
-        <p:nvSpPr>
-          <p:cNvPr id="6" name="">
-            <a:extLst xmlns:a="http://schemas.openxmlformats.org/drawingml/2006/main">
-              <a:ext uri="{FF2B5EF4-FFF2-40B4-BE49-F238E27FC236}">
-                <a16:creationId xmlns:a16="http://schemas.microsoft.com/office/drawing/2014/main" id="{DDC40817-285B-4908-9DBB-739546BB7E76}"/>
-              </a:ext>
-            </a:extLst>
-          </p:cNvPr>
-          <p:cNvSpPr>
-            <a:spLocks xmlns:a="http://schemas.openxmlformats.org/drawingml/2006/main" noGrp="1"/>
-          </p:cNvSpPr>
-          <p:nvPr/>
-        </p:nvSpPr>
-        <p:spPr>
-          <a:xfrm xmlns:a="http://schemas.openxmlformats.org/drawingml/2006/main">
-            <a:off x="9334500" y="2800350"/>
-            <a:ext cx="2095500" cy="476250"/>
-          </a:xfrm>
-          <a:prstGeom xmlns:a="http://schemas.openxmlformats.org/drawingml/2006/main" prst="rect">
-            <a:avLst/>
-          </a:prstGeom>
-          <a:noFill xmlns:a="http://schemas.openxmlformats.org/drawingml/2006/main"/>
-          <a:ln xmlns:a="http://schemas.openxmlformats.org/drawingml/2006/main" w="0">
-            <a:noFill/>
-          </a:ln>
-        </p:spPr>
-        <p:txBody>
-          <a:bodyPr xmlns:a="http://schemas.openxmlformats.org/drawingml/2006/main">
-            <a:noAutofit/>
-          </a:bodyPr>
-          <a:lstStyle xmlns:a="http://schemas.openxmlformats.org/drawingml/2006/main"/>
-          <a:p xmlns:a="http://schemas.openxmlformats.org/drawingml/2006/main">
-            <a:pPr>
-              <a:defRPr sz="3000" b="1">
-                <a:solidFill>
-                  <a:srgbClr val="3157D5"/>
-                </a:solidFill>
-                <a:latin typeface="Noto Sans KR"/>
-                <a:ea typeface="Noto Sans KR"/>
-                <a:cs typeface="Noto Sans KR"/>
-              </a:defRPr>
-            </a:pPr>
-            <a:r>
-              <a:rPr sz="3000" b="1">
-                <a:solidFill>
-                  <a:srgbClr val="3157D5"/>
-                </a:solidFill>
-                <a:latin typeface="Noto Sans KR"/>
-                <a:ea typeface="Noto Sans KR"/>
-                <a:cs typeface="Noto Sans KR"/>
-              </a:rPr>
-              <a:t>15.5%</a:t>
-            </a:r>
-          </a:p>
-        </p:txBody>
-      </p:sp>
-      <p:sp>
-        <p:nvSpPr>
-          <p:cNvPr id="7" name="">
-            <a:extLst xmlns:a="http://schemas.openxmlformats.org/drawingml/2006/main">
-              <a:ext uri="{FF2B5EF4-FFF2-40B4-BE49-F238E27FC236}">
-                <a16:creationId xmlns:a16="http://schemas.microsoft.com/office/drawing/2014/main" id="{B6D20D6A-DB4D-4822-AEEB-BC84E92F3235}"/>
-              </a:ext>
-            </a:extLst>
-          </p:cNvPr>
-          <p:cNvSpPr>
-            <a:spLocks xmlns:a="http://schemas.openxmlformats.org/drawingml/2006/main" noGrp="1"/>
-          </p:cNvSpPr>
-          <p:nvPr/>
-        </p:nvSpPr>
-        <p:spPr>
-          <a:xfrm xmlns:a="http://schemas.openxmlformats.org/drawingml/2006/main">
-            <a:off x="9372600" y="3305175"/>
-            <a:ext cx="1905000" cy="285750"/>
-          </a:xfrm>
-          <a:prstGeom xmlns:a="http://schemas.openxmlformats.org/drawingml/2006/main" prst="rect">
-            <a:avLst/>
-          </a:prstGeom>
-          <a:noFill xmlns:a="http://schemas.openxmlformats.org/drawingml/2006/main"/>
-          <a:ln xmlns:a="http://schemas.openxmlformats.org/drawingml/2006/main" w="0">
-            <a:noFill/>
-          </a:ln>
-        </p:spPr>
-        <p:txBody>
-          <a:bodyPr xmlns:a="http://schemas.openxmlformats.org/drawingml/2006/main">
-            <a:noAutofit/>
-          </a:bodyPr>
-          <a:lstStyle xmlns:a="http://schemas.openxmlformats.org/drawingml/2006/main"/>
-          <a:p xmlns:a="http://schemas.openxmlformats.org/drawingml/2006/main">
-            <a:pPr>
-              <a:defRPr sz="1425" b="0">
-                <a:solidFill>
-                  <a:srgbClr val="68727F"/>
-                </a:solidFill>
-                <a:latin typeface="Noto Sans KR"/>
-                <a:ea typeface="Noto Sans KR"/>
-                <a:cs typeface="Noto Sans KR"/>
-              </a:defRPr>
-            </a:pPr>
-            <a:r>
-              <a:rPr sz="1425" b="0">
-                <a:solidFill>
-                  <a:srgbClr val="68727F"/>
-                </a:solidFill>
-                <a:latin typeface="Noto Sans KR"/>
-                <a:ea typeface="Noto Sans KR"/>
-                <a:cs typeface="Noto Sans KR"/>
-              </a:rPr>
-              <a:t>K5 개선</a:t>
-            </a:r>
-          </a:p>
-        </p:txBody>
-      </p:sp>
-      <p:sp>
-        <p:nvSpPr>
-          <p:cNvPr id="8" name="">
-            <a:extLst xmlns:a="http://schemas.openxmlformats.org/drawingml/2006/main">
-              <a:ext uri="{FF2B5EF4-FFF2-40B4-BE49-F238E27FC236}">
-                <a16:creationId xmlns:a16="http://schemas.microsoft.com/office/drawing/2014/main" id="{F4C35A2A-2923-4D8B-AD01-44DA57C396BC}"/>
-              </a:ext>
-            </a:extLst>
-          </p:cNvPr>
-          <p:cNvSpPr>
-            <a:spLocks xmlns:a="http://schemas.openxmlformats.org/drawingml/2006/main" noGrp="1"/>
-          </p:cNvSpPr>
-          <p:nvPr/>
-        </p:nvSpPr>
-        <p:spPr>
-          <a:xfrm xmlns:a="http://schemas.openxmlformats.org/drawingml/2006/main">
-            <a:off x="9334500" y="4038600"/>
-            <a:ext cx="2095500" cy="476250"/>
-          </a:xfrm>
-          <a:prstGeom xmlns:a="http://schemas.openxmlformats.org/drawingml/2006/main" prst="rect">
-            <a:avLst/>
-          </a:prstGeom>
-          <a:noFill xmlns:a="http://schemas.openxmlformats.org/drawingml/2006/main"/>
-          <a:ln xmlns:a="http://schemas.openxmlformats.org/drawingml/2006/main" w="0">
-            <a:noFill/>
-          </a:ln>
-        </p:spPr>
-        <p:txBody>
-          <a:bodyPr xmlns:a="http://schemas.openxmlformats.org/drawingml/2006/main">
-            <a:noAutofit/>
-          </a:bodyPr>
-          <a:lstStyle xmlns:a="http://schemas.openxmlformats.org/drawingml/2006/main"/>
-          <a:p xmlns:a="http://schemas.openxmlformats.org/drawingml/2006/main">
-            <a:pPr>
-              <a:defRPr sz="3000" b="1">
-                <a:solidFill>
-                  <a:srgbClr val="D34E5B"/>
-                </a:solidFill>
-                <a:latin typeface="Noto Sans KR"/>
-                <a:ea typeface="Noto Sans KR"/>
-                <a:cs typeface="Noto Sans KR"/>
-              </a:defRPr>
-            </a:pPr>
-            <a:r>
-              <a:rPr sz="3000" b="1">
-                <a:solidFill>
-                  <a:srgbClr val="D34E5B"/>
-                </a:solidFill>
-                <a:latin typeface="Noto Sans KR"/>
-                <a:ea typeface="Noto Sans KR"/>
-                <a:cs typeface="Noto Sans KR"/>
-              </a:rPr>
-              <a:t>6.2%</a:t>
-            </a:r>
-          </a:p>
-        </p:txBody>
-      </p:sp>
-      <p:sp>
-        <p:nvSpPr>
-          <p:cNvPr id="9" name="">
-            <a:extLst xmlns:a="http://schemas.openxmlformats.org/drawingml/2006/main">
-              <a:ext uri="{FF2B5EF4-FFF2-40B4-BE49-F238E27FC236}">
-                <a16:creationId xmlns:a16="http://schemas.microsoft.com/office/drawing/2014/main" id="{3802BC1F-124D-46F3-BF3A-0FF70D1824C0}"/>
-              </a:ext>
-            </a:extLst>
-          </p:cNvPr>
-          <p:cNvSpPr>
-            <a:spLocks xmlns:a="http://schemas.openxmlformats.org/drawingml/2006/main" noGrp="1"/>
-          </p:cNvSpPr>
-          <p:nvPr/>
-        </p:nvSpPr>
-        <p:spPr>
-          <a:xfrm xmlns:a="http://schemas.openxmlformats.org/drawingml/2006/main">
-            <a:off x="9372600" y="4543425"/>
-            <a:ext cx="1905000" cy="285750"/>
-          </a:xfrm>
-          <a:prstGeom xmlns:a="http://schemas.openxmlformats.org/drawingml/2006/main" prst="rect">
-            <a:avLst/>
-          </a:prstGeom>
-          <a:noFill xmlns:a="http://schemas.openxmlformats.org/drawingml/2006/main"/>
-          <a:ln xmlns:a="http://schemas.openxmlformats.org/drawingml/2006/main" w="0">
-            <a:noFill/>
-          </a:ln>
-        </p:spPr>
-        <p:txBody>
-          <a:bodyPr xmlns:a="http://schemas.openxmlformats.org/drawingml/2006/main">
-            <a:noAutofit/>
-          </a:bodyPr>
-          <a:lstStyle xmlns:a="http://schemas.openxmlformats.org/drawingml/2006/main"/>
-          <a:p xmlns:a="http://schemas.openxmlformats.org/drawingml/2006/main">
-            <a:pPr>
-              <a:defRPr sz="1425" b="0">
-                <a:solidFill>
-                  <a:srgbClr val="68727F"/>
-                </a:solidFill>
-                <a:latin typeface="Noto Sans KR"/>
-                <a:ea typeface="Noto Sans KR"/>
-                <a:cs typeface="Noto Sans KR"/>
-              </a:defRPr>
-            </a:pPr>
-            <a:r>
-              <a:rPr sz="1425" b="0">
-                <a:solidFill>
-                  <a:srgbClr val="68727F"/>
-                </a:solidFill>
-                <a:latin typeface="Noto Sans KR"/>
-                <a:ea typeface="Noto Sans KR"/>
-                <a:cs typeface="Noto Sans KR"/>
-              </a:rPr>
-              <a:t>K10 악화</a:t>
-            </a:r>
-          </a:p>
-        </p:txBody>
-      </p:sp>
-      <p:sp>
-        <p:nvSpPr>
-          <p:cNvPr id="10" name="">
-            <a:extLst xmlns:a="http://schemas.openxmlformats.org/drawingml/2006/main">
-              <a:ext uri="{FF2B5EF4-FFF2-40B4-BE49-F238E27FC236}">
-                <a16:creationId xmlns:a16="http://schemas.microsoft.com/office/drawing/2014/main" id="{FA39A5E7-6B37-480D-9543-FE2D142660C2}"/>
-              </a:ext>
-            </a:extLst>
-          </p:cNvPr>
-          <p:cNvSpPr>
-            <a:spLocks xmlns:a="http://schemas.openxmlformats.org/drawingml/2006/main" noGrp="1"/>
-          </p:cNvSpPr>
-          <p:nvPr/>
-        </p:nvSpPr>
-        <p:spPr>
-          <a:xfrm xmlns:a="http://schemas.openxmlformats.org/drawingml/2006/main">
-            <a:off x="685800" y="5429250"/>
-            <a:ext cx="2857500" cy="285750"/>
-          </a:xfrm>
-          <a:prstGeom xmlns:a="http://schemas.openxmlformats.org/drawingml/2006/main" prst="rect">
-            <a:avLst/>
-          </a:prstGeom>
-          <a:noFill xmlns:a="http://schemas.openxmlformats.org/drawingml/2006/main"/>
-          <a:ln xmlns:a="http://schemas.openxmlformats.org/drawingml/2006/main" w="0">
-            <a:noFill/>
-          </a:ln>
-        </p:spPr>
-        <p:txBody>
-          <a:bodyPr xmlns:a="http://schemas.openxmlformats.org/drawingml/2006/main">
-            <a:noAutofit/>
-          </a:bodyPr>
-          <a:lstStyle xmlns:a="http://schemas.openxmlformats.org/drawingml/2006/main"/>
-          <a:p xmlns:a="http://schemas.openxmlformats.org/drawingml/2006/main">
-            <a:pPr>
-              <a:defRPr sz="1425" b="1">
-                <a:solidFill>
-                  <a:srgbClr val="3157D5"/>
-                </a:solidFill>
-                <a:latin typeface="Noto Sans KR"/>
-                <a:ea typeface="Noto Sans KR"/>
-                <a:cs typeface="Noto Sans KR"/>
-              </a:defRPr>
-            </a:pPr>
-            <a:r>
-              <a:rPr sz="1425" b="1">
-                <a:solidFill>
-                  <a:srgbClr val="3157D5"/>
-                </a:solidFill>
-                <a:latin typeface="Noto Sans KR"/>
-                <a:ea typeface="Noto Sans KR"/>
-                <a:cs typeface="Noto Sans KR"/>
-              </a:rPr>
-              <a:t>paired NDCG 95% CI</a:t>
-            </a:r>
-          </a:p>
-        </p:txBody>
-      </p:sp>
-      <p:sp>
-        <p:nvSpPr>
-          <p:cNvPr id="11" name="">
-            <a:extLst xmlns:a="http://schemas.openxmlformats.org/drawingml/2006/main">
-              <a:ext uri="{FF2B5EF4-FFF2-40B4-BE49-F238E27FC236}">
-                <a16:creationId xmlns:a16="http://schemas.microsoft.com/office/drawing/2014/main" id="{D8003AF8-182E-48B2-A004-914DB7DC9F06}"/>
-              </a:ext>
-            </a:extLst>
-          </p:cNvPr>
-          <p:cNvSpPr>
-            <a:spLocks xmlns:a="http://schemas.openxmlformats.org/drawingml/2006/main" noGrp="1"/>
-          </p:cNvSpPr>
-          <p:nvPr/>
-        </p:nvSpPr>
-        <p:spPr>
-          <a:xfrm xmlns:a="http://schemas.openxmlformats.org/drawingml/2006/main">
-            <a:off x="685800" y="5829300"/>
-            <a:ext cx="8096250" cy="323850"/>
-          </a:xfrm>
-          <a:prstGeom xmlns:a="http://schemas.openxmlformats.org/drawingml/2006/main" prst="rect">
-            <a:avLst/>
-          </a:prstGeom>
-          <a:noFill xmlns:a="http://schemas.openxmlformats.org/drawingml/2006/main"/>
-          <a:ln xmlns:a="http://schemas.openxmlformats.org/drawingml/2006/main" w="0">
-            <a:noFill/>
-          </a:ln>
-        </p:spPr>
-        <p:txBody>
-          <a:bodyPr xmlns:a="http://schemas.openxmlformats.org/drawingml/2006/main">
-            <a:noAutofit/>
-          </a:bodyPr>
-          <a:lstStyle xmlns:a="http://schemas.openxmlformats.org/drawingml/2006/main"/>
-          <a:p xmlns:a="http://schemas.openxmlformats.org/drawingml/2006/main">
-            <a:pPr>
-              <a:defRPr sz="1800" b="1">
-                <a:solidFill>
-                  <a:srgbClr val="18202A"/>
-                </a:solidFill>
-                <a:latin typeface="Noto Sans KR"/>
-                <a:ea typeface="Noto Sans KR"/>
-                <a:cs typeface="Noto Sans KR"/>
-              </a:defRPr>
-            </a:pPr>
-            <a:r>
-              <a:rPr sz="1800" b="1">
-                <a:solidFill>
-                  <a:srgbClr val="18202A"/>
-                </a:solidFill>
-                <a:latin typeface="Noto Sans KR"/>
-                <a:ea typeface="Noto Sans KR"/>
-                <a:cs typeface="Noto Sans KR"/>
-              </a:rPr>
-              <a:t>K5  [0.0243, 0.0383]     K10  [0.0355, 0.0515]</a:t>
-            </a:r>
-          </a:p>
-        </p:txBody>
-      </p:sp>
     </p:spTree>
     <p:extLst>
       <p:ext uri="{BB962C8B-B14F-4D97-AF65-F5344CB8AC3E}">
@@ -5420,6 +5728,7 @@
           <a:lstStyle xmlns:a="http://schemas.openxmlformats.org/drawingml/2006/main"/>
           <a:p xmlns:a="http://schemas.openxmlformats.org/drawingml/2006/main">
             <a:pPr>
+              <a:buNone/>
               <a:defRPr sz="3225" b="1">
                 <a:solidFill>
                   <a:srgbClr val="18202A"/>
@@ -5438,7 +5747,7 @@
                 <a:ea typeface="Noto Sans KR"/>
                 <a:cs typeface="Noto Sans KR"/>
               </a:rPr>
-              <a:t>LightFM은 양방향 선호 신호가 있을 때만 차이를 만들었다</a:t>
+              <a:t>양쪽 신호는 LightFM 적용 전제였다</a:t>
             </a:r>
           </a:p>
         </p:txBody>
@@ -5477,6 +5786,7 @@
           <a:lstStyle xmlns:a="http://schemas.openxmlformats.org/drawingml/2006/main"/>
           <a:p xmlns:a="http://schemas.openxmlformats.org/drawingml/2006/main">
             <a:pPr>
+              <a:buNone/>
               <a:defRPr sz="1275" b="1">
                 <a:solidFill>
                   <a:srgbClr val="68727F"/>
@@ -5534,6 +5844,7 @@
           <a:lstStyle xmlns:a="http://schemas.openxmlformats.org/drawingml/2006/main"/>
           <a:p xmlns:a="http://schemas.openxmlformats.org/drawingml/2006/main">
             <a:pPr>
+              <a:buNone/>
               <a:defRPr sz="2325" b="1">
                 <a:solidFill>
                   <a:srgbClr val="18202A"/>
@@ -5552,7 +5863,7 @@
                 <a:ea typeface="Noto Sans KR"/>
                 <a:cs typeface="Noto Sans KR"/>
               </a:rPr>
-              <a:t>좋아요·싫어요 모두 있음</a:t>
+              <a:t>원시 prefix 양쪽 신호</a:t>
             </a:r>
           </a:p>
         </p:txBody>
@@ -5591,6 +5902,7 @@
           <a:lstStyle xmlns:a="http://schemas.openxmlformats.org/drawingml/2006/main"/>
           <a:p xmlns:a="http://schemas.openxmlformats.org/drawingml/2006/main">
             <a:pPr>
+              <a:buNone/>
               <a:defRPr sz="4500" b="1">
                 <a:solidFill>
                   <a:srgbClr val="3157D5"/>
@@ -5609,7 +5921,7 @@
                 <a:ea typeface="Noto Sans KR"/>
                 <a:cs typeface="Noto Sans KR"/>
               </a:rPr>
-              <a:t>+0.0463</a:t>
+              <a:t>97명</a:t>
             </a:r>
           </a:p>
         </p:txBody>
@@ -5648,6 +5960,7 @@
           <a:lstStyle xmlns:a="http://schemas.openxmlformats.org/drawingml/2006/main"/>
           <a:p xmlns:a="http://schemas.openxmlformats.org/drawingml/2006/main">
             <a:pPr>
+              <a:buNone/>
               <a:defRPr sz="1575" b="0">
                 <a:solidFill>
                   <a:srgbClr val="68727F"/>
@@ -5666,7 +5979,7 @@
                 <a:ea typeface="Noto Sans KR"/>
                 <a:cs typeface="Noto Sans KR"/>
               </a:rPr>
-              <a:t>K5 NDCG 차이</a:t>
+              <a:t>K5 · anchor 부족 fallback</a:t>
             </a:r>
           </a:p>
         </p:txBody>
@@ -5705,6 +6018,7 @@
           <a:lstStyle xmlns:a="http://schemas.openxmlformats.org/drawingml/2006/main"/>
           <a:p xmlns:a="http://schemas.openxmlformats.org/drawingml/2006/main">
             <a:pPr>
+              <a:buNone/>
               <a:defRPr sz="4500" b="1">
                 <a:solidFill>
                   <a:srgbClr val="3157D5"/>
@@ -5723,7 +6037,7 @@
                 <a:ea typeface="Noto Sans KR"/>
                 <a:cs typeface="Noto Sans KR"/>
               </a:rPr>
-              <a:t>+0.0474</a:t>
+              <a:t>46명</a:t>
             </a:r>
           </a:p>
         </p:txBody>
@@ -5762,6 +6076,7 @@
           <a:lstStyle xmlns:a="http://schemas.openxmlformats.org/drawingml/2006/main"/>
           <a:p xmlns:a="http://schemas.openxmlformats.org/drawingml/2006/main">
             <a:pPr>
+              <a:buNone/>
               <a:defRPr sz="1575" b="0">
                 <a:solidFill>
                   <a:srgbClr val="68727F"/>
@@ -5780,7 +6095,7 @@
                 <a:ea typeface="Noto Sans KR"/>
                 <a:cs typeface="Noto Sans KR"/>
               </a:rPr>
-              <a:t>K10 NDCG 차이</a:t>
+              <a:t>K10 · anchor 부족 fallback</a:t>
             </a:r>
           </a:p>
         </p:txBody>
@@ -5819,6 +6134,7 @@
           <a:lstStyle xmlns:a="http://schemas.openxmlformats.org/drawingml/2006/main"/>
           <a:p xmlns:a="http://schemas.openxmlformats.org/drawingml/2006/main">
             <a:pPr>
+              <a:buNone/>
               <a:defRPr sz="2325" b="1">
                 <a:solidFill>
                   <a:srgbClr val="18202A"/>
@@ -5837,7 +6153,7 @@
                 <a:ea typeface="Noto Sans KR"/>
                 <a:cs typeface="Noto Sans KR"/>
               </a:rPr>
-              <a:t>한쪽 신호만 있음</a:t>
+              <a:t>원시 prefix 한쪽 신호</a:t>
             </a:r>
           </a:p>
         </p:txBody>
@@ -5876,6 +6192,7 @@
           <a:lstStyle xmlns:a="http://schemas.openxmlformats.org/drawingml/2006/main"/>
           <a:p xmlns:a="http://schemas.openxmlformats.org/drawingml/2006/main">
             <a:pPr>
+              <a:buNone/>
               <a:defRPr sz="4500" b="1">
                 <a:solidFill>
                   <a:srgbClr val="D34E5B"/>
@@ -5933,6 +6250,7 @@
           <a:lstStyle xmlns:a="http://schemas.openxmlformats.org/drawingml/2006/main"/>
           <a:p xmlns:a="http://schemas.openxmlformats.org/drawingml/2006/main">
             <a:pPr>
+              <a:buNone/>
               <a:defRPr sz="1575" b="0">
                 <a:solidFill>
                   <a:srgbClr val="68727F"/>
@@ -5951,7 +6269,7 @@
                 <a:ea typeface="Noto Sans KR"/>
                 <a:cs typeface="Noto Sans KR"/>
               </a:rPr>
-              <a:t>인기도 fallback</a:t>
+              <a:t>설계상 B0 fallback</a:t>
             </a:r>
           </a:p>
         </p:txBody>
@@ -5990,6 +6308,7 @@
           <a:lstStyle xmlns:a="http://schemas.openxmlformats.org/drawingml/2006/main"/>
           <a:p xmlns:a="http://schemas.openxmlformats.org/drawingml/2006/main">
             <a:pPr>
+              <a:buNone/>
               <a:defRPr sz="2325" b="1">
                 <a:solidFill>
                   <a:srgbClr val="3157D5"/>
@@ -6047,6 +6366,7 @@
           <a:lstStyle xmlns:a="http://schemas.openxmlformats.org/drawingml/2006/main"/>
           <a:p xmlns:a="http://schemas.openxmlformats.org/drawingml/2006/main">
             <a:pPr>
+              <a:buNone/>
               <a:defRPr sz="2025" b="1">
                 <a:solidFill>
                   <a:srgbClr val="18202A"/>
@@ -6065,7 +6385,7 @@
                 <a:ea typeface="Noto Sans KR"/>
                 <a:cs typeface="Noto Sans KR"/>
               </a:rPr>
-              <a:t>fallback 38.8%</a:t>
+              <a:t>1,085 → 988 적용</a:t>
             </a:r>
           </a:p>
         </p:txBody>
@@ -6104,6 +6424,7 @@
           <a:lstStyle xmlns:a="http://schemas.openxmlformats.org/drawingml/2006/main"/>
           <a:p xmlns:a="http://schemas.openxmlformats.org/drawingml/2006/main">
             <a:pPr>
+              <a:buNone/>
               <a:defRPr sz="2325" b="1">
                 <a:solidFill>
                   <a:srgbClr val="3157D5"/>
@@ -6161,6 +6482,7 @@
           <a:lstStyle xmlns:a="http://schemas.openxmlformats.org/drawingml/2006/main"/>
           <a:p xmlns:a="http://schemas.openxmlformats.org/drawingml/2006/main">
             <a:pPr>
+              <a:buNone/>
               <a:defRPr sz="2025" b="1">
                 <a:solidFill>
                   <a:srgbClr val="18202A"/>
@@ -6179,7 +6501,7 @@
                 <a:ea typeface="Noto Sans KR"/>
                 <a:cs typeface="Noto Sans KR"/>
               </a:rPr>
-              <a:t>fallback 11.5%</a:t>
+              <a:t>1,355 → 1,309 적용</a:t>
             </a:r>
           </a:p>
         </p:txBody>
@@ -6218,6 +6540,7 @@
           <a:lstStyle xmlns:a="http://schemas.openxmlformats.org/drawingml/2006/main"/>
           <a:p xmlns:a="http://schemas.openxmlformats.org/drawingml/2006/main">
             <a:pPr>
+              <a:buNone/>
               <a:defRPr sz="1575" b="1">
                 <a:solidFill>
                   <a:srgbClr val="68727F"/>
@@ -6236,7 +6559,7 @@
                 <a:ea typeface="Noto Sans KR"/>
                 <a:cs typeface="Noto Sans KR"/>
               </a:rPr>
-              <a:t>대리 검증에서 얻은 다음 후보</a:t>
+              <a:t>해석 경계</a:t>
             </a:r>
           </a:p>
         </p:txBody>
@@ -6275,6 +6598,7 @@
           <a:lstStyle xmlns:a="http://schemas.openxmlformats.org/drawingml/2006/main"/>
           <a:p xmlns:a="http://schemas.openxmlformats.org/drawingml/2006/main">
             <a:pPr>
+              <a:buNone/>
               <a:defRPr sz="2325" b="1">
                 <a:solidFill>
                   <a:srgbClr val="3157D5"/>
@@ -6293,7 +6617,7 @@
                 <a:ea typeface="Noto Sans KR"/>
                 <a:cs typeface="Noto Sans KR"/>
               </a:rPr>
-              <a:t>K10 + 양방향 입력 + LightFM</a:t>
+              <a:t>fallback 비교는 신호 효과 검증이 아님</a:t>
             </a:r>
           </a:p>
         </p:txBody>
@@ -6332,6 +6656,7 @@
           <a:lstStyle xmlns:a="http://schemas.openxmlformats.org/drawingml/2006/main"/>
           <a:p xmlns:a="http://schemas.openxmlformats.org/drawingml/2006/main">
             <a:pPr>
+              <a:buNone/>
               <a:defRPr sz="2100" b="1">
                 <a:solidFill>
                   <a:srgbClr val="18202A"/>
@@ -6350,7 +6675,7 @@
                 <a:ea typeface="Noto Sans KR"/>
                 <a:cs typeface="Noto Sans KR"/>
               </a:rPr>
-              <a:t>그 외 조건은 B0 인기도</a:t>
+              <a:t>양방향 효과 주장 삭제</a:t>
             </a:r>
           </a:p>
         </p:txBody>
@@ -6418,6 +6743,7 @@
           <a:lstStyle xmlns:a="http://schemas.openxmlformats.org/drawingml/2006/main"/>
           <a:p xmlns:a="http://schemas.openxmlformats.org/drawingml/2006/main">
             <a:pPr>
+              <a:buNone/>
               <a:defRPr sz="3225" b="1">
                 <a:solidFill>
                   <a:srgbClr val="18202A"/>
@@ -6436,7 +6762,7 @@
                 <a:ea typeface="Noto Sans KR"/>
                 <a:cs typeface="Noto Sans KR"/>
               </a:rPr>
-              <a:t>개선은 인기 영화 Q4와 비한국어 원어에 집중됐다</a:t>
+              <a:t>Q4 집중과 희소 slice는 품질 근거가 아니었다</a:t>
             </a:r>
           </a:p>
         </p:txBody>
@@ -6475,6 +6801,7 @@
           <a:lstStyle xmlns:a="http://schemas.openxmlformats.org/drawingml/2006/main"/>
           <a:p xmlns:a="http://schemas.openxmlformats.org/drawingml/2006/main">
             <a:pPr>
+              <a:buNone/>
               <a:defRPr sz="1275" b="1">
                 <a:solidFill>
                   <a:srgbClr val="68727F"/>
@@ -6494,13 +6821,399 @@
                 <a:cs typeface="Noto Sans KR"/>
               </a:rPr>
               <a:t>07</a:t>
+            </a:r>
+          </a:p>
+        </p:txBody>
+      </p:sp>
+      <p:sp>
+        <p:nvSpPr>
+          <p:cNvPr id="4" name="">
+            <a:extLst xmlns:a="http://schemas.openxmlformats.org/drawingml/2006/main">
+              <a:ext uri="{FF2B5EF4-FFF2-40B4-BE49-F238E27FC236}">
+                <a16:creationId xmlns:a16="http://schemas.microsoft.com/office/drawing/2014/main" id="{862180E6-5C8D-4945-B707-F47CA9B5A415}"/>
+              </a:ext>
+            </a:extLst>
+          </p:cNvPr>
+          <p:cNvSpPr>
+            <a:spLocks xmlns:a="http://schemas.openxmlformats.org/drawingml/2006/main" noGrp="1"/>
+          </p:cNvSpPr>
+          <p:nvPr/>
+        </p:nvSpPr>
+        <p:spPr>
+          <a:xfrm xmlns:a="http://schemas.openxmlformats.org/drawingml/2006/main">
+            <a:off x="9715500" y="1562100"/>
+            <a:ext cx="2000250" cy="457200"/>
+          </a:xfrm>
+          <a:prstGeom xmlns:a="http://schemas.openxmlformats.org/drawingml/2006/main" prst="rect">
+            <a:avLst/>
+          </a:prstGeom>
+          <a:noFill xmlns:a="http://schemas.openxmlformats.org/drawingml/2006/main"/>
+          <a:ln xmlns:a="http://schemas.openxmlformats.org/drawingml/2006/main" w="0">
+            <a:noFill/>
+          </a:ln>
+        </p:spPr>
+        <p:txBody>
+          <a:bodyPr xmlns:a="http://schemas.openxmlformats.org/drawingml/2006/main">
+            <a:noAutofit/>
+          </a:bodyPr>
+          <a:lstStyle xmlns:a="http://schemas.openxmlformats.org/drawingml/2006/main"/>
+          <a:p xmlns:a="http://schemas.openxmlformats.org/drawingml/2006/main">
+            <a:pPr>
+              <a:buNone/>
+              <a:defRPr sz="2850" b="1">
+                <a:solidFill>
+                  <a:srgbClr val="D34E5B"/>
+                </a:solidFill>
+                <a:latin typeface="Noto Sans KR"/>
+                <a:ea typeface="Noto Sans KR"/>
+                <a:cs typeface="Noto Sans KR"/>
+              </a:defRPr>
+            </a:pPr>
+            <a:r>
+              <a:rPr sz="2850" b="1">
+                <a:solidFill>
+                  <a:srgbClr val="D34E5B"/>
+                </a:solidFill>
+                <a:latin typeface="Noto Sans KR"/>
+                <a:ea typeface="Noto Sans KR"/>
+                <a:cs typeface="Noto Sans KR"/>
+              </a:rPr>
+              <a:t>Q4 비중</a:t>
+            </a:r>
+          </a:p>
+        </p:txBody>
+      </p:sp>
+      <p:sp>
+        <p:nvSpPr>
+          <p:cNvPr id="5" name="">
+            <a:extLst xmlns:a="http://schemas.openxmlformats.org/drawingml/2006/main">
+              <a:ext uri="{FF2B5EF4-FFF2-40B4-BE49-F238E27FC236}">
+                <a16:creationId xmlns:a16="http://schemas.microsoft.com/office/drawing/2014/main" id="{B3E5BB0F-4CA3-400A-98DF-AAD8AA73B8DD}"/>
+              </a:ext>
+            </a:extLst>
+          </p:cNvPr>
+          <p:cNvSpPr>
+            <a:spLocks xmlns:a="http://schemas.openxmlformats.org/drawingml/2006/main" noGrp="1"/>
+          </p:cNvSpPr>
+          <p:nvPr/>
+        </p:nvSpPr>
+        <p:spPr>
+          <a:xfrm xmlns:a="http://schemas.openxmlformats.org/drawingml/2006/main">
+            <a:off x="9715500" y="2095500"/>
+            <a:ext cx="2000250" cy="762000"/>
+          </a:xfrm>
+          <a:prstGeom xmlns:a="http://schemas.openxmlformats.org/drawingml/2006/main" prst="rect">
+            <a:avLst/>
+          </a:prstGeom>
+          <a:noFill xmlns:a="http://schemas.openxmlformats.org/drawingml/2006/main"/>
+          <a:ln xmlns:a="http://schemas.openxmlformats.org/drawingml/2006/main" w="0">
+            <a:noFill/>
+          </a:ln>
+        </p:spPr>
+        <p:txBody>
+          <a:bodyPr xmlns:a="http://schemas.openxmlformats.org/drawingml/2006/main">
+            <a:noAutofit/>
+          </a:bodyPr>
+          <a:lstStyle xmlns:a="http://schemas.openxmlformats.org/drawingml/2006/main"/>
+          <a:p xmlns:a="http://schemas.openxmlformats.org/drawingml/2006/main">
+            <a:pPr>
+              <a:buNone/>
+              <a:defRPr sz="1800" b="1">
+                <a:solidFill>
+                  <a:srgbClr val="18202A"/>
+                </a:solidFill>
+                <a:latin typeface="Noto Sans KR"/>
+                <a:ea typeface="Noto Sans KR"/>
+                <a:cs typeface="Noto Sans KR"/>
+              </a:defRPr>
+            </a:pPr>
+            <a:r>
+              <a:rPr sz="1800" b="1">
+                <a:solidFill>
+                  <a:srgbClr val="18202A"/>
+                </a:solidFill>
+                <a:latin typeface="Noto Sans KR"/>
+                <a:ea typeface="Noto Sans KR"/>
+                <a:cs typeface="Noto Sans KR"/>
+              </a:rPr>
+              <a:t>K5 95.9%</a:t>
+            </a:r>
+          </a:p>
+          <a:p xmlns:a="http://schemas.openxmlformats.org/drawingml/2006/main">
+            <a:pPr>
+              <a:buNone/>
+              <a:defRPr sz="1800" b="1">
+                <a:solidFill>
+                  <a:srgbClr val="18202A"/>
+                </a:solidFill>
+                <a:latin typeface="Noto Sans KR"/>
+                <a:ea typeface="Noto Sans KR"/>
+                <a:cs typeface="Noto Sans KR"/>
+              </a:defRPr>
+            </a:pPr>
+            <a:r>
+              <a:rPr sz="1800" b="1">
+                <a:solidFill>
+                  <a:srgbClr val="18202A"/>
+                </a:solidFill>
+                <a:latin typeface="Noto Sans KR"/>
+                <a:ea typeface="Noto Sans KR"/>
+                <a:cs typeface="Noto Sans KR"/>
+              </a:rPr>
+              <a:t>K10 96.4%</a:t>
+            </a:r>
+          </a:p>
+          <a:p xmlns:a="http://schemas.openxmlformats.org/drawingml/2006/main">
+            <a:pPr>
+              <a:buNone/>
+              <a:defRPr sz="1800" b="1">
+                <a:solidFill>
+                  <a:srgbClr val="18202A"/>
+                </a:solidFill>
+                <a:latin typeface="Noto Sans KR"/>
+                <a:ea typeface="Noto Sans KR"/>
+                <a:cs typeface="Noto Sans KR"/>
+              </a:defRPr>
+            </a:pPr>
+            <a:r>
+              <a:rPr sz="1800" b="1">
+                <a:solidFill>
+                  <a:srgbClr val="18202A"/>
+                </a:solidFill>
+                <a:latin typeface="Noto Sans KR"/>
+                <a:ea typeface="Noto Sans KR"/>
+                <a:cs typeface="Noto Sans KR"/>
+              </a:rPr>
+              <a:t>Q1~Q3 저검정력</a:t>
+            </a:r>
+          </a:p>
+        </p:txBody>
+      </p:sp>
+      <p:sp>
+        <p:nvSpPr>
+          <p:cNvPr id="6" name="">
+            <a:extLst xmlns:a="http://schemas.openxmlformats.org/drawingml/2006/main">
+              <a:ext uri="{FF2B5EF4-FFF2-40B4-BE49-F238E27FC236}">
+                <a16:creationId xmlns:a16="http://schemas.microsoft.com/office/drawing/2014/main" id="{A94CFB39-7C8F-4D94-AA27-4A712B4F6D85}"/>
+              </a:ext>
+            </a:extLst>
+          </p:cNvPr>
+          <p:cNvSpPr>
+            <a:spLocks xmlns:a="http://schemas.openxmlformats.org/drawingml/2006/main" noGrp="1"/>
+          </p:cNvSpPr>
+          <p:nvPr/>
+        </p:nvSpPr>
+        <p:spPr>
+          <a:xfrm xmlns:a="http://schemas.openxmlformats.org/drawingml/2006/main">
+            <a:off x="9715500" y="3314700"/>
+            <a:ext cx="2000250" cy="400050"/>
+          </a:xfrm>
+          <a:prstGeom xmlns:a="http://schemas.openxmlformats.org/drawingml/2006/main" prst="rect">
+            <a:avLst/>
+          </a:prstGeom>
+          <a:noFill xmlns:a="http://schemas.openxmlformats.org/drawingml/2006/main"/>
+          <a:ln xmlns:a="http://schemas.openxmlformats.org/drawingml/2006/main" w="0">
+            <a:noFill/>
+          </a:ln>
+        </p:spPr>
+        <p:txBody>
+          <a:bodyPr xmlns:a="http://schemas.openxmlformats.org/drawingml/2006/main">
+            <a:noAutofit/>
+          </a:bodyPr>
+          <a:lstStyle xmlns:a="http://schemas.openxmlformats.org/drawingml/2006/main"/>
+          <a:p xmlns:a="http://schemas.openxmlformats.org/drawingml/2006/main">
+            <a:pPr>
+              <a:buNone/>
+              <a:defRPr sz="2100" b="1">
+                <a:solidFill>
+                  <a:srgbClr val="D34E5B"/>
+                </a:solidFill>
+                <a:latin typeface="Noto Sans KR"/>
+                <a:ea typeface="Noto Sans KR"/>
+                <a:cs typeface="Noto Sans KR"/>
+              </a:defRPr>
+            </a:pPr>
+            <a:r>
+              <a:rPr sz="2100" b="1">
+                <a:solidFill>
+                  <a:srgbClr val="D34E5B"/>
+                </a:solidFill>
+                <a:latin typeface="Noto Sans KR"/>
+                <a:ea typeface="Noto Sans KR"/>
+                <a:cs typeface="Noto Sans KR"/>
+              </a:rPr>
+              <a:t>희소 slice</a:t>
+            </a:r>
+          </a:p>
+        </p:txBody>
+      </p:sp>
+      <p:sp>
+        <p:nvSpPr>
+          <p:cNvPr id="7" name="">
+            <a:extLst xmlns:a="http://schemas.openxmlformats.org/drawingml/2006/main">
+              <a:ext uri="{FF2B5EF4-FFF2-40B4-BE49-F238E27FC236}">
+                <a16:creationId xmlns:a16="http://schemas.microsoft.com/office/drawing/2014/main" id="{C413EF17-8764-405A-9031-ADC9ED113319}"/>
+              </a:ext>
+            </a:extLst>
+          </p:cNvPr>
+          <p:cNvSpPr>
+            <a:spLocks xmlns:a="http://schemas.openxmlformats.org/drawingml/2006/main" noGrp="1"/>
+          </p:cNvSpPr>
+          <p:nvPr/>
+        </p:nvSpPr>
+        <p:spPr>
+          <a:xfrm xmlns:a="http://schemas.openxmlformats.org/drawingml/2006/main">
+            <a:off x="9715500" y="3829050"/>
+            <a:ext cx="2000250" cy="742950"/>
+          </a:xfrm>
+          <a:prstGeom xmlns:a="http://schemas.openxmlformats.org/drawingml/2006/main" prst="rect">
+            <a:avLst/>
+          </a:prstGeom>
+          <a:noFill xmlns:a="http://schemas.openxmlformats.org/drawingml/2006/main"/>
+          <a:ln xmlns:a="http://schemas.openxmlformats.org/drawingml/2006/main" w="0">
+            <a:noFill/>
+          </a:ln>
+        </p:spPr>
+        <p:txBody>
+          <a:bodyPr xmlns:a="http://schemas.openxmlformats.org/drawingml/2006/main">
+            <a:noAutofit/>
+          </a:bodyPr>
+          <a:lstStyle xmlns:a="http://schemas.openxmlformats.org/drawingml/2006/main"/>
+          <a:p xmlns:a="http://schemas.openxmlformats.org/drawingml/2006/main">
+            <a:pPr>
+              <a:buNone/>
+              <a:defRPr sz="1725" b="1">
+                <a:solidFill>
+                  <a:srgbClr val="18202A"/>
+                </a:solidFill>
+                <a:latin typeface="Noto Sans KR"/>
+                <a:ea typeface="Noto Sans KR"/>
+                <a:cs typeface="Noto Sans KR"/>
+              </a:defRPr>
+            </a:pPr>
+            <a:r>
+              <a:rPr sz="1725" b="1">
+                <a:solidFill>
+                  <a:srgbClr val="18202A"/>
+                </a:solidFill>
+                <a:latin typeface="Noto Sans KR"/>
+                <a:ea typeface="Noto Sans KR"/>
+                <a:cs typeface="Noto Sans KR"/>
+              </a:rPr>
+              <a:t>Top500 B0 10 · LF 6</a:t>
+            </a:r>
+          </a:p>
+          <a:p xmlns:a="http://schemas.openxmlformats.org/drawingml/2006/main">
+            <a:pPr>
+              <a:buNone/>
+              <a:defRPr sz="1725" b="1">
+                <a:solidFill>
+                  <a:srgbClr val="18202A"/>
+                </a:solidFill>
+                <a:latin typeface="Noto Sans KR"/>
+                <a:ea typeface="Noto Sans KR"/>
+                <a:cs typeface="Noto Sans KR"/>
+              </a:defRPr>
+            </a:pPr>
+            <a:r>
+              <a:rPr sz="1725" b="1">
+                <a:solidFill>
+                  <a:srgbClr val="18202A"/>
+                </a:solidFill>
+                <a:latin typeface="Noto Sans KR"/>
+                <a:ea typeface="Noto Sans KR"/>
+                <a:cs typeface="Noto Sans KR"/>
+              </a:rPr>
+              <a:t>2020+ 9편 · positive 0</a:t>
+            </a:r>
+          </a:p>
+          <a:p xmlns:a="http://schemas.openxmlformats.org/drawingml/2006/main">
+            <a:pPr>
+              <a:buNone/>
+              <a:defRPr sz="1725" b="1">
+                <a:solidFill>
+                  <a:srgbClr val="18202A"/>
+                </a:solidFill>
+                <a:latin typeface="Noto Sans KR"/>
+                <a:ea typeface="Noto Sans KR"/>
+                <a:cs typeface="Noto Sans KR"/>
+              </a:defRPr>
+            </a:pPr>
+            <a:r>
+              <a:rPr sz="1725" b="1">
+                <a:solidFill>
+                  <a:srgbClr val="18202A"/>
+                </a:solidFill>
+                <a:latin typeface="Noto Sans KR"/>
+                <a:ea typeface="Noto Sans KR"/>
+                <a:cs typeface="Noto Sans KR"/>
+              </a:rPr>
+              <a:t>true cold 0편</a:t>
+            </a:r>
+          </a:p>
+        </p:txBody>
+      </p:sp>
+      <p:sp>
+        <p:nvSpPr>
+          <p:cNvPr id="8" name="">
+            <a:extLst xmlns:a="http://schemas.openxmlformats.org/drawingml/2006/main">
+              <a:ext uri="{FF2B5EF4-FFF2-40B4-BE49-F238E27FC236}">
+                <a16:creationId xmlns:a16="http://schemas.microsoft.com/office/drawing/2014/main" id="{D19BC32A-10F0-4201-9D7A-A61F56AFA554}"/>
+              </a:ext>
+            </a:extLst>
+          </p:cNvPr>
+          <p:cNvSpPr>
+            <a:spLocks xmlns:a="http://schemas.openxmlformats.org/drawingml/2006/main" noGrp="1"/>
+          </p:cNvSpPr>
+          <p:nvPr/>
+        </p:nvSpPr>
+        <p:spPr>
+          <a:xfrm xmlns:a="http://schemas.openxmlformats.org/drawingml/2006/main">
+            <a:off x="552450" y="6115050"/>
+            <a:ext cx="4762500" cy="266700"/>
+          </a:xfrm>
+          <a:prstGeom xmlns:a="http://schemas.openxmlformats.org/drawingml/2006/main" prst="rect">
+            <a:avLst/>
+          </a:prstGeom>
+          <a:noFill xmlns:a="http://schemas.openxmlformats.org/drawingml/2006/main"/>
+          <a:ln xmlns:a="http://schemas.openxmlformats.org/drawingml/2006/main" w="0">
+            <a:noFill/>
+          </a:ln>
+        </p:spPr>
+        <p:txBody>
+          <a:bodyPr xmlns:a="http://schemas.openxmlformats.org/drawingml/2006/main">
+            <a:noAutofit/>
+          </a:bodyPr>
+          <a:lstStyle xmlns:a="http://schemas.openxmlformats.org/drawingml/2006/main"/>
+          <a:p xmlns:a="http://schemas.openxmlformats.org/drawingml/2006/main">
+            <a:pPr>
+              <a:buNone/>
+              <a:defRPr sz="1275" b="0">
+                <a:solidFill>
+                  <a:srgbClr val="68727F"/>
+                </a:solidFill>
+                <a:latin typeface="Noto Sans KR"/>
+                <a:ea typeface="Noto Sans KR"/>
+                <a:cs typeface="Noto Sans KR"/>
+              </a:defRPr>
+            </a:pPr>
+            <a:r>
+              <a:rPr sz="1275" b="0">
+                <a:solidFill>
+                  <a:srgbClr val="68727F"/>
+                </a:solidFill>
+                <a:latin typeface="Noto Sans KR"/>
+                <a:ea typeface="Noto Sans KR"/>
+                <a:cs typeface="Noto Sans KR"/>
+              </a:rPr>
+              <a:t>관측 GOOD 기반 기술 통계 · 희소 slice inferiority 결론 금지</a:t>
             </a:r>
           </a:p>
         </p:txBody>
       </p:sp>
       <p:graphicFrame>
         <p:nvGraphicFramePr>
-          <p:cNvPr id="11" name="Chart"/>
+          <p:cNvPr id="18" name="Chart"/>
           <p:cNvGraphicFramePr/>
           <p:nvPr/>
         </p:nvGraphicFramePr>
@@ -6510,341 +7223,10 @@
         </p:xfrm>
         <a:graphic xmlns:a="http://schemas.openxmlformats.org/drawingml/2006/main">
           <a:graphicData uri="http://schemas.openxmlformats.org/drawingml/2006/chart">
-            <c:chart xmlns:r="http://schemas.openxmlformats.org/officeDocument/2006/relationships" xmlns:c="http://schemas.openxmlformats.org/drawingml/2006/chart" r:id="R0d91d9032295406b"/>
+            <c:chart xmlns:r="http://schemas.openxmlformats.org/officeDocument/2006/relationships" xmlns:c="http://schemas.openxmlformats.org/drawingml/2006/chart" r:id="Rc8615a839c91451a"/>
           </a:graphicData>
         </a:graphic>
       </p:graphicFrame>
-      <p:sp>
-        <p:nvSpPr>
-          <p:cNvPr id="4" name="">
-            <a:extLst xmlns:a="http://schemas.openxmlformats.org/drawingml/2006/main">
-              <a:ext uri="{FF2B5EF4-FFF2-40B4-BE49-F238E27FC236}">
-                <a16:creationId xmlns:a16="http://schemas.microsoft.com/office/drawing/2014/main" id="{862180E6-5C8D-4945-B707-F47CA9B5A415}"/>
-              </a:ext>
-            </a:extLst>
-          </p:cNvPr>
-          <p:cNvSpPr>
-            <a:spLocks xmlns:a="http://schemas.openxmlformats.org/drawingml/2006/main" noGrp="1"/>
-          </p:cNvSpPr>
-          <p:nvPr/>
-        </p:nvSpPr>
-        <p:spPr>
-          <a:xfrm xmlns:a="http://schemas.openxmlformats.org/drawingml/2006/main">
-            <a:off x="9715500" y="1562100"/>
-            <a:ext cx="2000250" cy="457200"/>
-          </a:xfrm>
-          <a:prstGeom xmlns:a="http://schemas.openxmlformats.org/drawingml/2006/main" prst="rect">
-            <a:avLst/>
-          </a:prstGeom>
-          <a:noFill xmlns:a="http://schemas.openxmlformats.org/drawingml/2006/main"/>
-          <a:ln xmlns:a="http://schemas.openxmlformats.org/drawingml/2006/main" w="0">
-            <a:noFill/>
-          </a:ln>
-        </p:spPr>
-        <p:txBody>
-          <a:bodyPr xmlns:a="http://schemas.openxmlformats.org/drawingml/2006/main">
-            <a:noAutofit/>
-          </a:bodyPr>
-          <a:lstStyle xmlns:a="http://schemas.openxmlformats.org/drawingml/2006/main"/>
-          <a:p xmlns:a="http://schemas.openxmlformats.org/drawingml/2006/main">
-            <a:pPr>
-              <a:defRPr sz="2850" b="1">
-                <a:solidFill>
-                  <a:srgbClr val="D34E5B"/>
-                </a:solidFill>
-                <a:latin typeface="Noto Sans KR"/>
-                <a:ea typeface="Noto Sans KR"/>
-                <a:cs typeface="Noto Sans KR"/>
-              </a:defRPr>
-            </a:pPr>
-            <a:r>
-              <a:rPr sz="2850" b="1">
-                <a:solidFill>
-                  <a:srgbClr val="D34E5B"/>
-                </a:solidFill>
-                <a:latin typeface="Noto Sans KR"/>
-                <a:ea typeface="Noto Sans KR"/>
-                <a:cs typeface="Noto Sans KR"/>
-              </a:rPr>
-              <a:t>Q1~Q3</a:t>
-            </a:r>
-          </a:p>
-        </p:txBody>
-      </p:sp>
-      <p:sp>
-        <p:nvSpPr>
-          <p:cNvPr id="5" name="">
-            <a:extLst xmlns:a="http://schemas.openxmlformats.org/drawingml/2006/main">
-              <a:ext uri="{FF2B5EF4-FFF2-40B4-BE49-F238E27FC236}">
-                <a16:creationId xmlns:a16="http://schemas.microsoft.com/office/drawing/2014/main" id="{B3E5BB0F-4CA3-400A-98DF-AAD8AA73B8DD}"/>
-              </a:ext>
-            </a:extLst>
-          </p:cNvPr>
-          <p:cNvSpPr>
-            <a:spLocks xmlns:a="http://schemas.openxmlformats.org/drawingml/2006/main" noGrp="1"/>
-          </p:cNvSpPr>
-          <p:nvPr/>
-        </p:nvSpPr>
-        <p:spPr>
-          <a:xfrm xmlns:a="http://schemas.openxmlformats.org/drawingml/2006/main">
-            <a:off x="9715500" y="2095500"/>
-            <a:ext cx="2000250" cy="762000"/>
-          </a:xfrm>
-          <a:prstGeom xmlns:a="http://schemas.openxmlformats.org/drawingml/2006/main" prst="rect">
-            <a:avLst/>
-          </a:prstGeom>
-          <a:noFill xmlns:a="http://schemas.openxmlformats.org/drawingml/2006/main"/>
-          <a:ln xmlns:a="http://schemas.openxmlformats.org/drawingml/2006/main" w="0">
-            <a:noFill/>
-          </a:ln>
-        </p:spPr>
-        <p:txBody>
-          <a:bodyPr xmlns:a="http://schemas.openxmlformats.org/drawingml/2006/main">
-            <a:noAutofit/>
-          </a:bodyPr>
-          <a:lstStyle xmlns:a="http://schemas.openxmlformats.org/drawingml/2006/main"/>
-          <a:p xmlns:a="http://schemas.openxmlformats.org/drawingml/2006/main">
-            <a:pPr>
-              <a:defRPr sz="1800" b="1">
-                <a:solidFill>
-                  <a:srgbClr val="18202A"/>
-                </a:solidFill>
-                <a:latin typeface="Noto Sans KR"/>
-                <a:ea typeface="Noto Sans KR"/>
-                <a:cs typeface="Noto Sans KR"/>
-              </a:defRPr>
-            </a:pPr>
-            <a:r>
-              <a:rPr sz="1800" b="1">
-                <a:solidFill>
-                  <a:srgbClr val="18202A"/>
-                </a:solidFill>
-                <a:latin typeface="Noto Sans KR"/>
-                <a:ea typeface="Noto Sans KR"/>
-                <a:cs typeface="Noto Sans KR"/>
-              </a:rPr>
-              <a:t>두 모델 모두</a:t>
-            </a:r>
-          </a:p>
-          <a:p xmlns:a="http://schemas.openxmlformats.org/drawingml/2006/main">
-            <a:pPr>
-              <a:defRPr sz="1800" b="1">
-                <a:solidFill>
-                  <a:srgbClr val="18202A"/>
-                </a:solidFill>
-                <a:latin typeface="Noto Sans KR"/>
-                <a:ea typeface="Noto Sans KR"/>
-                <a:cs typeface="Noto Sans KR"/>
-              </a:defRPr>
-            </a:pPr>
-            <a:r>
-              <a:rPr sz="1800" b="1">
-                <a:solidFill>
-                  <a:srgbClr val="18202A"/>
-                </a:solidFill>
-                <a:latin typeface="Noto Sans KR"/>
-                <a:ea typeface="Noto Sans KR"/>
-                <a:cs typeface="Noto Sans KR"/>
-              </a:rPr>
-              <a:t>Top-10 적중 0</a:t>
-            </a:r>
-          </a:p>
-        </p:txBody>
-      </p:sp>
-      <p:sp>
-        <p:nvSpPr>
-          <p:cNvPr id="6" name="">
-            <a:extLst xmlns:a="http://schemas.openxmlformats.org/drawingml/2006/main">
-              <a:ext uri="{FF2B5EF4-FFF2-40B4-BE49-F238E27FC236}">
-                <a16:creationId xmlns:a16="http://schemas.microsoft.com/office/drawing/2014/main" id="{A94CFB39-7C8F-4D94-AA27-4A712B4F6D85}"/>
-              </a:ext>
-            </a:extLst>
-          </p:cNvPr>
-          <p:cNvSpPr>
-            <a:spLocks xmlns:a="http://schemas.openxmlformats.org/drawingml/2006/main" noGrp="1"/>
-          </p:cNvSpPr>
-          <p:nvPr/>
-        </p:nvSpPr>
-        <p:spPr>
-          <a:xfrm xmlns:a="http://schemas.openxmlformats.org/drawingml/2006/main">
-            <a:off x="9715500" y="3314700"/>
-            <a:ext cx="2000250" cy="400050"/>
-          </a:xfrm>
-          <a:prstGeom xmlns:a="http://schemas.openxmlformats.org/drawingml/2006/main" prst="rect">
-            <a:avLst/>
-          </a:prstGeom>
-          <a:noFill xmlns:a="http://schemas.openxmlformats.org/drawingml/2006/main"/>
-          <a:ln xmlns:a="http://schemas.openxmlformats.org/drawingml/2006/main" w="0">
-            <a:noFill/>
-          </a:ln>
-        </p:spPr>
-        <p:txBody>
-          <a:bodyPr xmlns:a="http://schemas.openxmlformats.org/drawingml/2006/main">
-            <a:noAutofit/>
-          </a:bodyPr>
-          <a:lstStyle xmlns:a="http://schemas.openxmlformats.org/drawingml/2006/main"/>
-          <a:p xmlns:a="http://schemas.openxmlformats.org/drawingml/2006/main">
-            <a:pPr>
-              <a:defRPr sz="2100" b="1">
-                <a:solidFill>
-                  <a:srgbClr val="D34E5B"/>
-                </a:solidFill>
-                <a:latin typeface="Noto Sans KR"/>
-                <a:ea typeface="Noto Sans KR"/>
-                <a:cs typeface="Noto Sans KR"/>
-              </a:defRPr>
-            </a:pPr>
-            <a:r>
-              <a:rPr sz="2100" b="1">
-                <a:solidFill>
-                  <a:srgbClr val="D34E5B"/>
-                </a:solidFill>
-                <a:latin typeface="Noto Sans KR"/>
-                <a:ea typeface="Noto Sans KR"/>
-                <a:cs typeface="Noto Sans KR"/>
-              </a:rPr>
-              <a:t>한국어 원어</a:t>
-            </a:r>
-          </a:p>
-        </p:txBody>
-      </p:sp>
-      <p:sp>
-        <p:nvSpPr>
-          <p:cNvPr id="7" name="">
-            <a:extLst xmlns:a="http://schemas.openxmlformats.org/drawingml/2006/main">
-              <a:ext uri="{FF2B5EF4-FFF2-40B4-BE49-F238E27FC236}">
-                <a16:creationId xmlns:a16="http://schemas.microsoft.com/office/drawing/2014/main" id="{C413EF17-8764-405A-9031-ADC9ED113319}"/>
-              </a:ext>
-            </a:extLst>
-          </p:cNvPr>
-          <p:cNvSpPr>
-            <a:spLocks xmlns:a="http://schemas.openxmlformats.org/drawingml/2006/main" noGrp="1"/>
-          </p:cNvSpPr>
-          <p:nvPr/>
-        </p:nvSpPr>
-        <p:spPr>
-          <a:xfrm xmlns:a="http://schemas.openxmlformats.org/drawingml/2006/main">
-            <a:off x="9715500" y="3829050"/>
-            <a:ext cx="2000250" cy="742950"/>
-          </a:xfrm>
-          <a:prstGeom xmlns:a="http://schemas.openxmlformats.org/drawingml/2006/main" prst="rect">
-            <a:avLst/>
-          </a:prstGeom>
-          <a:noFill xmlns:a="http://schemas.openxmlformats.org/drawingml/2006/main"/>
-          <a:ln xmlns:a="http://schemas.openxmlformats.org/drawingml/2006/main" w="0">
-            <a:noFill/>
-          </a:ln>
-        </p:spPr>
-        <p:txBody>
-          <a:bodyPr xmlns:a="http://schemas.openxmlformats.org/drawingml/2006/main">
-            <a:noAutofit/>
-          </a:bodyPr>
-          <a:lstStyle xmlns:a="http://schemas.openxmlformats.org/drawingml/2006/main"/>
-          <a:p xmlns:a="http://schemas.openxmlformats.org/drawingml/2006/main">
-            <a:pPr>
-              <a:defRPr sz="1725" b="1">
-                <a:solidFill>
-                  <a:srgbClr val="18202A"/>
-                </a:solidFill>
-                <a:latin typeface="Noto Sans KR"/>
-                <a:ea typeface="Noto Sans KR"/>
-                <a:cs typeface="Noto Sans KR"/>
-              </a:defRPr>
-            </a:pPr>
-            <a:r>
-              <a:rPr sz="1725" b="1">
-                <a:solidFill>
-                  <a:srgbClr val="18202A"/>
-                </a:solidFill>
-                <a:latin typeface="Noto Sans KR"/>
-                <a:ea typeface="Noto Sans KR"/>
-                <a:cs typeface="Noto Sans KR"/>
-              </a:rPr>
-              <a:t>양성 23건</a:t>
-            </a:r>
-          </a:p>
-          <a:p xmlns:a="http://schemas.openxmlformats.org/drawingml/2006/main">
-            <a:pPr>
-              <a:defRPr sz="1725" b="1">
-                <a:solidFill>
-                  <a:srgbClr val="18202A"/>
-                </a:solidFill>
-                <a:latin typeface="Noto Sans KR"/>
-                <a:ea typeface="Noto Sans KR"/>
-                <a:cs typeface="Noto Sans KR"/>
-              </a:defRPr>
-            </a:pPr>
-            <a:r>
-              <a:rPr sz="1725" b="1">
-                <a:solidFill>
-                  <a:srgbClr val="18202A"/>
-                </a:solidFill>
-                <a:latin typeface="Noto Sans KR"/>
-                <a:ea typeface="Noto Sans KR"/>
-                <a:cs typeface="Noto Sans KR"/>
-              </a:rPr>
-              <a:t>두 모델 적중 0</a:t>
-            </a:r>
-          </a:p>
-        </p:txBody>
-      </p:sp>
-      <p:sp>
-        <p:nvSpPr>
-          <p:cNvPr id="8" name="">
-            <a:extLst xmlns:a="http://schemas.openxmlformats.org/drawingml/2006/main">
-              <a:ext uri="{FF2B5EF4-FFF2-40B4-BE49-F238E27FC236}">
-                <a16:creationId xmlns:a16="http://schemas.microsoft.com/office/drawing/2014/main" id="{D19BC32A-10F0-4201-9D7A-A61F56AFA554}"/>
-              </a:ext>
-            </a:extLst>
-          </p:cNvPr>
-          <p:cNvSpPr>
-            <a:spLocks xmlns:a="http://schemas.openxmlformats.org/drawingml/2006/main" noGrp="1"/>
-          </p:cNvSpPr>
-          <p:nvPr/>
-        </p:nvSpPr>
-        <p:spPr>
-          <a:xfrm xmlns:a="http://schemas.openxmlformats.org/drawingml/2006/main">
-            <a:off x="552450" y="6115050"/>
-            <a:ext cx="4762500" cy="266700"/>
-          </a:xfrm>
-          <a:prstGeom xmlns:a="http://schemas.openxmlformats.org/drawingml/2006/main" prst="rect">
-            <a:avLst/>
-          </a:prstGeom>
-          <a:noFill xmlns:a="http://schemas.openxmlformats.org/drawingml/2006/main"/>
-          <a:ln xmlns:a="http://schemas.openxmlformats.org/drawingml/2006/main" w="0">
-            <a:noFill/>
-          </a:ln>
-        </p:spPr>
-        <p:txBody>
-          <a:bodyPr xmlns:a="http://schemas.openxmlformats.org/drawingml/2006/main">
-            <a:noAutofit/>
-          </a:bodyPr>
-          <a:lstStyle xmlns:a="http://schemas.openxmlformats.org/drawingml/2006/main"/>
-          <a:p xmlns:a="http://schemas.openxmlformats.org/drawingml/2006/main">
-            <a:pPr>
-              <a:defRPr sz="1275" b="0">
-                <a:solidFill>
-                  <a:srgbClr val="68727F"/>
-                </a:solidFill>
-                <a:latin typeface="Noto Sans KR"/>
-                <a:ea typeface="Noto Sans KR"/>
-                <a:cs typeface="Noto Sans KR"/>
-              </a:defRPr>
-            </a:pPr>
-            <a:r>
-              <a:rPr sz="1275" b="0">
-                <a:solidFill>
-                  <a:srgbClr val="68727F"/>
-                </a:solidFill>
-                <a:latin typeface="Noto Sans KR"/>
-                <a:ea typeface="Noto Sans KR"/>
-                <a:cs typeface="Noto Sans KR"/>
-              </a:rPr>
-              <a:t>K=10 관측 GOOD Top-10 적중률</a:t>
-            </a:r>
-          </a:p>
-        </p:txBody>
-      </p:sp>
     </p:spTree>
     <p:extLst>
       <p:ext uri="{BB962C8B-B14F-4D97-AF65-F5344CB8AC3E}">
@@ -6908,6 +7290,7 @@
           <a:lstStyle xmlns:a="http://schemas.openxmlformats.org/drawingml/2006/main"/>
           <a:p xmlns:a="http://schemas.openxmlformats.org/drawingml/2006/main">
             <a:pPr>
+              <a:buNone/>
               <a:defRPr sz="3225" b="1">
                 <a:solidFill>
                   <a:srgbClr val="18202A"/>
@@ -6926,7 +7309,7 @@
                 <a:ea typeface="Noto Sans KR"/>
                 <a:cs typeface="Noto Sans KR"/>
               </a:rPr>
-              <a:t>AI 활용 범위와 판단 책임</a:t>
+              <a:t>AI 활용과 재현 경계</a:t>
             </a:r>
           </a:p>
         </p:txBody>
@@ -6965,6 +7348,7 @@
           <a:lstStyle xmlns:a="http://schemas.openxmlformats.org/drawingml/2006/main"/>
           <a:p xmlns:a="http://schemas.openxmlformats.org/drawingml/2006/main">
             <a:pPr>
+              <a:buNone/>
               <a:defRPr sz="1275" b="1">
                 <a:solidFill>
                   <a:srgbClr val="68727F"/>
@@ -7022,6 +7406,7 @@
           <a:lstStyle xmlns:a="http://schemas.openxmlformats.org/drawingml/2006/main"/>
           <a:p xmlns:a="http://schemas.openxmlformats.org/drawingml/2006/main">
             <a:pPr>
+              <a:buNone/>
               <a:defRPr sz="2550" b="1">
                 <a:solidFill>
                   <a:srgbClr val="3157D5"/>
@@ -7040,7 +7425,7 @@
                 <a:ea typeface="Noto Sans KR"/>
                 <a:cs typeface="Noto Sans KR"/>
               </a:rPr>
-              <a:t>사람이 정한 것</a:t>
+              <a:t>사람이 고정한 경계</a:t>
             </a:r>
           </a:p>
         </p:txBody>
@@ -7079,6 +7464,7 @@
           <a:lstStyle xmlns:a="http://schemas.openxmlformats.org/drawingml/2006/main"/>
           <a:p xmlns:a="http://schemas.openxmlformats.org/drawingml/2006/main">
             <a:pPr>
+              <a:buNone/>
               <a:defRPr sz="2100" b="0">
                 <a:solidFill>
                   <a:srgbClr val="18202A"/>
@@ -7097,11 +7483,12 @@
                 <a:ea typeface="Noto Sans KR"/>
                 <a:cs typeface="Noto Sans KR"/>
               </a:rPr>
-              <a:t>문제 1과 문제 2의 분리</a:t>
-            </a:r>
-          </a:p>
-          <a:p xmlns:a="http://schemas.openxmlformats.org/drawingml/2006/main">
-            <a:pPr>
+              <a:t>K5·K10 직접 비교 금지</a:t>
+            </a:r>
+          </a:p>
+          <a:p xmlns:a="http://schemas.openxmlformats.org/drawingml/2006/main">
+            <a:pPr>
+              <a:buNone/>
               <a:defRPr sz="2100" b="0">
                 <a:solidFill>
                   <a:srgbClr val="18202A"/>
@@ -7120,11 +7507,12 @@
                 <a:ea typeface="Noto Sans KR"/>
                 <a:cs typeface="Noto Sans KR"/>
               </a:rPr>
-              <a:t>MovieLens와 TMDB의 역할</a:t>
-            </a:r>
-          </a:p>
-          <a:p xmlns:a="http://schemas.openxmlformats.org/drawingml/2006/main">
-            <a:pPr>
+              <a:t>Locked Test 미사용</a:t>
+            </a:r>
+          </a:p>
+          <a:p xmlns:a="http://schemas.openxmlformats.org/drawingml/2006/main">
+            <a:pPr>
+              <a:buNone/>
               <a:defRPr sz="2100" b="0">
                 <a:solidFill>
                   <a:srgbClr val="18202A"/>
@@ -7143,11 +7531,12 @@
                 <a:ea typeface="Noto Sans KR"/>
                 <a:cs typeface="Noto Sans KR"/>
               </a:rPr>
-              <a:t>비교 기준과 주장 가능한 범위</a:t>
-            </a:r>
-          </a:p>
-          <a:p xmlns:a="http://schemas.openxmlformats.org/drawingml/2006/main">
-            <a:pPr>
+              <a:t>champion null</a:t>
+            </a:r>
+          </a:p>
+          <a:p xmlns:a="http://schemas.openxmlformats.org/drawingml/2006/main">
+            <a:pPr>
+              <a:buNone/>
               <a:defRPr sz="2100" b="0">
                 <a:solidFill>
                   <a:srgbClr val="18202A"/>
@@ -7166,7 +7555,7 @@
                 <a:ea typeface="Noto Sans KR"/>
                 <a:cs typeface="Noto Sans KR"/>
               </a:rPr>
-              <a:t>Locked Test와 제품 정책 경계</a:t>
+              <a:t>제품 정책 미변경</a:t>
             </a:r>
           </a:p>
         </p:txBody>
@@ -7205,6 +7594,7 @@
           <a:lstStyle xmlns:a="http://schemas.openxmlformats.org/drawingml/2006/main"/>
           <a:p xmlns:a="http://schemas.openxmlformats.org/drawingml/2006/main">
             <a:pPr>
+              <a:buNone/>
               <a:defRPr sz="2550" b="1">
                 <a:solidFill>
                   <a:srgbClr val="3157D5"/>
@@ -7223,7 +7613,7 @@
                 <a:ea typeface="Noto Sans KR"/>
                 <a:cs typeface="Noto Sans KR"/>
               </a:rPr>
-              <a:t>AI로 확장한 것</a:t>
+              <a:t>AI로 확장한 검증</a:t>
             </a:r>
           </a:p>
         </p:txBody>
@@ -7262,6 +7652,7 @@
           <a:lstStyle xmlns:a="http://schemas.openxmlformats.org/drawingml/2006/main"/>
           <a:p xmlns:a="http://schemas.openxmlformats.org/drawingml/2006/main">
             <a:pPr>
+              <a:buNone/>
               <a:defRPr sz="2100" b="0">
                 <a:solidFill>
                   <a:srgbClr val="18202A"/>
@@ -7280,11 +7671,12 @@
                 <a:ea typeface="Noto Sans KR"/>
                 <a:cs typeface="Noto Sans KR"/>
               </a:rPr>
-              <a:t>7개 모델의 동일 조건 구현</a:t>
-            </a:r>
-          </a:p>
-          <a:p xmlns:a="http://schemas.openxmlformats.org/drawingml/2006/main">
-            <a:pPr>
+              <a:t>paired·slice 원자료 재계산</a:t>
+            </a:r>
+          </a:p>
+          <a:p xmlns:a="http://schemas.openxmlformats.org/drawingml/2006/main">
+            <a:pPr>
+              <a:buNone/>
               <a:defRPr sz="2100" b="0">
                 <a:solidFill>
                   <a:srgbClr val="18202A"/>
@@ -7303,11 +7695,12 @@
                 <a:ea typeface="Noto Sans KR"/>
                 <a:cs typeface="Noto Sans KR"/>
               </a:rPr>
-              <a:t>K5·10과 5개 seed 반복</a:t>
-            </a:r>
-          </a:p>
-          <a:p xmlns:a="http://schemas.openxmlformats.org/drawingml/2006/main">
-            <a:pPr>
+              <a:t>anchor fallback 검증</a:t>
+            </a:r>
+          </a:p>
+          <a:p xmlns:a="http://schemas.openxmlformats.org/drawingml/2006/main">
+            <a:pPr>
+              <a:buNone/>
               <a:defRPr sz="2100" b="0">
                 <a:solidFill>
                   <a:srgbClr val="18202A"/>
@@ -7326,11 +7719,12 @@
                 <a:ea typeface="Noto Sans KR"/>
                 <a:cs typeface="Noto Sans KR"/>
               </a:rPr>
-              <a:t>checkpoint·resume과 결과 검증</a:t>
-            </a:r>
-          </a:p>
-          <a:p xmlns:a="http://schemas.openxmlformats.org/drawingml/2006/main">
-            <a:pPr>
+              <a:t>stability는 tuning panel 한정</a:t>
+            </a:r>
+          </a:p>
+          <a:p xmlns:a="http://schemas.openxmlformats.org/drawingml/2006/main">
+            <a:pPr>
+              <a:buNone/>
               <a:defRPr sz="2100" b="0">
                 <a:solidFill>
                   <a:srgbClr val="18202A"/>
@@ -7349,7 +7743,7 @@
                 <a:ea typeface="Noto Sans KR"/>
                 <a:cs typeface="Noto Sans KR"/>
               </a:rPr>
-              <a:t>사용자·영화 구간 분석 자동화</a:t>
+              <a:t>checkpoint·resume 결과 검증</a:t>
             </a:r>
           </a:p>
         </p:txBody>
@@ -7388,6 +7782,7 @@
           <a:lstStyle xmlns:a="http://schemas.openxmlformats.org/drawingml/2006/main"/>
           <a:p xmlns:a="http://schemas.openxmlformats.org/drawingml/2006/main">
             <a:pPr>
+              <a:buNone/>
               <a:defRPr sz="2100" b="1">
                 <a:solidFill>
                   <a:srgbClr val="3157D5"/>
@@ -7406,7 +7801,7 @@
                 <a:ea typeface="Noto Sans KR"/>
                 <a:cs typeface="Noto Sans KR"/>
               </a:rPr>
-              <a:t>중단된 seed 42 학습도 cache를 보존해 이어서 실행</a:t>
+              <a:t>commit 단독 재현 불가</a:t>
             </a:r>
           </a:p>
         </p:txBody>
@@ -7445,6 +7840,7 @@
           <a:lstStyle xmlns:a="http://schemas.openxmlformats.org/drawingml/2006/main"/>
           <a:p xmlns:a="http://schemas.openxmlformats.org/drawingml/2006/main">
             <a:pPr>
+              <a:buNone/>
               <a:defRPr sz="1725" b="0">
                 <a:solidFill>
                   <a:srgbClr val="68727F"/>
@@ -7463,7 +7859,7 @@
                 <a:ea typeface="Noto Sans KR"/>
                 <a:cs typeface="Noto Sans KR"/>
               </a:rPr>
-              <a:t>AI는 비교 범위를 넓혔고, 결과의 의미와 한계는 실험 목적에 맞춰 판단했다</a:t>
+              <a:t>raw Parquet은 ignored outputs에만 있고 외부 artifact URI가 없다</a:t>
             </a:r>
           </a:p>
         </p:txBody>
@@ -7531,6 +7927,7 @@
           <a:lstStyle xmlns:a="http://schemas.openxmlformats.org/drawingml/2006/main"/>
           <a:p xmlns:a="http://schemas.openxmlformats.org/drawingml/2006/main">
             <a:pPr>
+              <a:buNone/>
               <a:defRPr sz="3225" b="1">
                 <a:solidFill>
                   <a:srgbClr val="18202A"/>
@@ -7549,7 +7946,7 @@
                 <a:ea typeface="Noto Sans KR"/>
                 <a:cs typeface="Noto Sans KR"/>
               </a:rPr>
-              <a:t>두 문제에 대한 최종 판정</a:t>
+              <a:t>독립 감사 교정 후 최종 판정</a:t>
             </a:r>
           </a:p>
         </p:txBody>
@@ -7588,6 +7985,7 @@
           <a:lstStyle xmlns:a="http://schemas.openxmlformats.org/drawingml/2006/main"/>
           <a:p xmlns:a="http://schemas.openxmlformats.org/drawingml/2006/main">
             <a:pPr>
+              <a:buNone/>
               <a:defRPr sz="1275" b="1">
                 <a:solidFill>
                   <a:srgbClr val="68727F"/>
@@ -7645,6 +8043,7 @@
           <a:lstStyle xmlns:a="http://schemas.openxmlformats.org/drawingml/2006/main"/>
           <a:p xmlns:a="http://schemas.openxmlformats.org/drawingml/2006/main">
             <a:pPr>
+              <a:buNone/>
               <a:defRPr sz="2100" b="1">
                 <a:solidFill>
                   <a:srgbClr val="3157D5"/>
@@ -7663,7 +8062,7 @@
                 <a:ea typeface="Noto Sans KR"/>
                 <a:cs typeface="Noto Sans KR"/>
               </a:rPr>
-              <a:t>문제 2</a:t>
+              <a:t>확인</a:t>
             </a:r>
           </a:p>
         </p:txBody>
@@ -7702,6 +8101,7 @@
           <a:lstStyle xmlns:a="http://schemas.openxmlformats.org/drawingml/2006/main"/>
           <a:p xmlns:a="http://schemas.openxmlformats.org/drawingml/2006/main">
             <a:pPr>
+              <a:buNone/>
               <a:defRPr sz="2550" b="1">
                 <a:solidFill>
                   <a:srgbClr val="18202A"/>
@@ -7720,7 +8120,7 @@
                 <a:ea typeface="Noto Sans KR"/>
                 <a:cs typeface="Noto Sans KR"/>
               </a:rPr>
-              <a:t>대리 검증으로 다음 후보를 좁혔다</a:t>
+              <a:t>각 K 안의 B0 대비 우위</a:t>
             </a:r>
           </a:p>
         </p:txBody>
@@ -7759,6 +8159,7 @@
           <a:lstStyle xmlns:a="http://schemas.openxmlformats.org/drawingml/2006/main"/>
           <a:p xmlns:a="http://schemas.openxmlformats.org/drawingml/2006/main">
             <a:pPr>
+              <a:buNone/>
               <a:defRPr sz="2250" b="0">
                 <a:solidFill>
                   <a:srgbClr val="18202A"/>
@@ -7777,11 +8178,12 @@
                 <a:ea typeface="Noto Sans KR"/>
                 <a:cs typeface="Noto Sans KR"/>
               </a:rPr>
-              <a:t>K10</a:t>
-            </a:r>
-          </a:p>
-          <a:p xmlns:a="http://schemas.openxmlformats.org/drawingml/2006/main">
-            <a:pPr>
+              <a:t>LightFM T003</a:t>
+            </a:r>
+          </a:p>
+          <a:p xmlns:a="http://schemas.openxmlformats.org/drawingml/2006/main">
+            <a:pPr>
+              <a:buNone/>
               <a:defRPr sz="2250" b="0">
                 <a:solidFill>
                   <a:srgbClr val="18202A"/>
@@ -7800,11 +8202,12 @@
                 <a:ea typeface="Noto Sans KR"/>
                 <a:cs typeface="Noto Sans KR"/>
               </a:rPr>
-              <a:t>양방향 선호 신호</a:t>
-            </a:r>
-          </a:p>
-          <a:p xmlns:a="http://schemas.openxmlformats.org/drawingml/2006/main">
-            <a:pPr>
+              <a:t>panel 제외 CI도 0보다 큼</a:t>
+            </a:r>
+          </a:p>
+          <a:p xmlns:a="http://schemas.openxmlformats.org/drawingml/2006/main">
+            <a:pPr>
+              <a:buNone/>
               <a:defRPr sz="2250" b="0">
                 <a:solidFill>
                   <a:srgbClr val="18202A"/>
@@ -7823,11 +8226,12 @@
                 <a:ea typeface="Noto Sans KR"/>
                 <a:cs typeface="Noto Sans KR"/>
               </a:rPr>
-              <a:t>LightFM T003</a:t>
-            </a:r>
-          </a:p>
-          <a:p xmlns:a="http://schemas.openxmlformats.org/drawingml/2006/main">
-            <a:pPr>
+              <a:t>K5·K10 직접 비교 안 함</a:t>
+            </a:r>
+          </a:p>
+          <a:p xmlns:a="http://schemas.openxmlformats.org/drawingml/2006/main">
+            <a:pPr>
+              <a:buNone/>
               <a:defRPr sz="2250" b="0">
                 <a:solidFill>
                   <a:srgbClr val="18202A"/>
@@ -7846,7 +8250,7 @@
                 <a:ea typeface="Noto Sans KR"/>
                 <a:cs typeface="Noto Sans KR"/>
               </a:rPr>
-              <a:t>그 외 B0 fallback</a:t>
+              <a:t>Locked Test 미사용</a:t>
             </a:r>
           </a:p>
         </p:txBody>
@@ -7885,6 +8289,7 @@
           <a:lstStyle xmlns:a="http://schemas.openxmlformats.org/drawingml/2006/main"/>
           <a:p xmlns:a="http://schemas.openxmlformats.org/drawingml/2006/main">
             <a:pPr>
+              <a:buNone/>
               <a:defRPr sz="2100" b="1">
                 <a:solidFill>
                   <a:srgbClr val="D34E5B"/>
@@ -7903,7 +8308,7 @@
                 <a:ea typeface="Noto Sans KR"/>
                 <a:cs typeface="Noto Sans KR"/>
               </a:rPr>
-              <a:t>문제 1</a:t>
+              <a:t>미확인</a:t>
             </a:r>
           </a:p>
         </p:txBody>
@@ -7942,6 +8347,7 @@
           <a:lstStyle xmlns:a="http://schemas.openxmlformats.org/drawingml/2006/main"/>
           <a:p xmlns:a="http://schemas.openxmlformats.org/drawingml/2006/main">
             <a:pPr>
+              <a:buNone/>
               <a:defRPr sz="2550" b="1">
                 <a:solidFill>
                   <a:srgbClr val="18202A"/>
@@ -7960,7 +8366,7 @@
                 <a:ea typeface="Noto Sans KR"/>
                 <a:cs typeface="Noto Sans KR"/>
               </a:rPr>
-              <a:t>한국 영화·신작 문제는 미해결</a:t>
+              <a:t>효과·slice·실사용 결론</a:t>
             </a:r>
           </a:p>
         </p:txBody>
@@ -7999,6 +8405,7 @@
           <a:lstStyle xmlns:a="http://schemas.openxmlformats.org/drawingml/2006/main"/>
           <a:p xmlns:a="http://schemas.openxmlformats.org/drawingml/2006/main">
             <a:pPr>
+              <a:buNone/>
               <a:defRPr sz="2250" b="0">
                 <a:solidFill>
                   <a:srgbClr val="18202A"/>
@@ -8017,11 +8424,12 @@
                 <a:ea typeface="Noto Sans KR"/>
                 <a:cs typeface="Noto Sans KR"/>
               </a:rPr>
-              <a:t>콘텐츠 단독 모델은 기준선 미달</a:t>
-            </a:r>
-          </a:p>
-          <a:p xmlns:a="http://schemas.openxmlformats.org/drawingml/2006/main">
-            <a:pPr>
+              <a:t>양방향 신호 효과</a:t>
+            </a:r>
+          </a:p>
+          <a:p xmlns:a="http://schemas.openxmlformats.org/drawingml/2006/main">
+            <a:pPr>
+              <a:buNone/>
               <a:defRPr sz="2250" b="0">
                 <a:solidFill>
                   <a:srgbClr val="18202A"/>
@@ -8040,11 +8448,12 @@
                 <a:ea typeface="Noto Sans KR"/>
                 <a:cs typeface="Noto Sans KR"/>
               </a:rPr>
-              <a:t>개선은 인기 영화에 집중</a:t>
-            </a:r>
-          </a:p>
-          <a:p xmlns:a="http://schemas.openxmlformats.org/drawingml/2006/main">
-            <a:pPr>
+              <a:t>저인기·한국어 원어 품질</a:t>
+            </a:r>
+          </a:p>
+          <a:p xmlns:a="http://schemas.openxmlformats.org/drawingml/2006/main">
+            <a:pPr>
+              <a:buNone/>
               <a:defRPr sz="2250" b="0">
                 <a:solidFill>
                   <a:srgbClr val="18202A"/>
@@ -8063,11 +8472,12 @@
                 <a:ea typeface="Noto Sans KR"/>
                 <a:cs typeface="Noto Sans KR"/>
               </a:rPr>
-              <a:t>한국어 원어 적중 근거 없음</a:t>
-            </a:r>
-          </a:p>
-          <a:p xmlns:a="http://schemas.openxmlformats.org/drawingml/2006/main">
-            <a:pPr>
+              <a:t>2020+·true cold 품질</a:t>
+            </a:r>
+          </a:p>
+          <a:p xmlns:a="http://schemas.openxmlformats.org/drawingml/2006/main">
+            <a:pPr>
+              <a:buNone/>
               <a:defRPr sz="2250" b="0">
                 <a:solidFill>
                   <a:srgbClr val="18202A"/>
@@ -8086,7 +8496,7 @@
                 <a:ea typeface="Noto Sans KR"/>
                 <a:cs typeface="Noto Sans KR"/>
               </a:rPr>
-              <a:t>목표 도메인 행동 데이터 필요</a:t>
+              <a:t>실제 FEELM 만족</a:t>
             </a:r>
           </a:p>
         </p:txBody>
@@ -8125,6 +8535,7 @@
           <a:lstStyle xmlns:a="http://schemas.openxmlformats.org/drawingml/2006/main"/>
           <a:p xmlns:a="http://schemas.openxmlformats.org/drawingml/2006/main">
             <a:pPr>
+              <a:buNone/>
               <a:defRPr sz="1650" b="1">
                 <a:solidFill>
                   <a:srgbClr val="68727F"/>
@@ -8143,7 +8554,7 @@
                 <a:ea typeface="Noto Sans KR"/>
                 <a:cs typeface="Noto Sans KR"/>
               </a:rPr>
-              <a:t>시점 정책</a:t>
+              <a:t>다음 검증</a:t>
             </a:r>
           </a:p>
         </p:txBody>
@@ -8182,6 +8593,7 @@
           <a:lstStyle xmlns:a="http://schemas.openxmlformats.org/drawingml/2006/main"/>
           <a:p xmlns:a="http://schemas.openxmlformats.org/drawingml/2006/main">
             <a:pPr>
+              <a:buNone/>
               <a:defRPr sz="1875" b="1">
                 <a:solidFill>
                   <a:srgbClr val="18202A"/>
@@ -8200,7 +8612,7 @@
                 <a:ea typeface="Noto Sans KR"/>
                 <a:cs typeface="Noto Sans KR"/>
               </a:rPr>
-              <a:t>전체 관측 범위 비교 전까지 미결정</a:t>
+              <a:t>같은 사용자·같은 미래 구간의 K5/K10 prefix ablation</a:t>
             </a:r>
           </a:p>
         </p:txBody>
@@ -8239,6 +8651,7 @@
           <a:lstStyle xmlns:a="http://schemas.openxmlformats.org/drawingml/2006/main"/>
           <a:p xmlns:a="http://schemas.openxmlformats.org/drawingml/2006/main">
             <a:pPr>
+              <a:buNone/>
               <a:defRPr sz="1575" b="1">
                 <a:solidFill>
                   <a:srgbClr val="D34E5B"/>
@@ -8257,7 +8670,7 @@
                 <a:ea typeface="Noto Sans KR"/>
                 <a:cs typeface="Noto Sans KR"/>
               </a:rPr>
-              <a:t>Locked Test 미개봉  ·  champion null  ·  제품 정책 유지</a:t>
+              <a:t>locked_test_used=false · champion=null · product_policy_updated=false</a:t>
             </a:r>
           </a:p>
         </p:txBody>

</xml_diff>